<commit_message>
Slides 2026-10: trim script to ~4.6 min
Co-Authored-By: Claude Opus 5.5 (1M context) <noreply@anthropic.com>
</commit_message>
<xml_diff>
--- a/results/progress_slides_2026-10.pptx
+++ b/results/progress_slides_2026-10.pptx
@@ -789,7 +789,7 @@
             <a:r>
               <a:rPr lang="en-US" dirty="0"/>
               <a:t>【台本】（約65秒）
-関連研究です。一番近いのは、今回の音響学会で東大の山中さんたちが発表した研究で、同じTAPSのデータを使っています。声質変換などで喉マイクの音を普通のマイクの音に近づけていて、聞こえは良くなりますが、音声認識の誤りはどの方法でも増えていました。誤りの測り方が違うので直接は比べられませんが、聞こえを良くしても認識は良くならない点は、私の卒論の結果と同じです。
+関連研究です。一番近いのは、今回の音響学会で東大の山中さんたちが発表した研究で、同じTAPSのデータを使っています。声質変換などで喉マイクの音を普通のマイクの音に近づけていて、聞こえは良くなりますが、音声認識の誤りはどの方法でも増えていました。聞こえを良くしても認識は良くならない点は、私の卒論の結果と同じです。
 一方、向こうは別の喉マイクや日本語でも確かめていて、同時録音のデータも要りません。ここは私に足りない点です。
 Satoらは普通のマイクの雑音除去で、特定の認識器に頼らない方法を提案していて、今回比較対象として再現しました。
 喉マイクで、入力の違う複数の音声認識で誤りが減るかを確かめた例は、調べた範囲では見当たりません。
@@ -978,11 +978,10 @@
             <a:r>
               <a:rPr lang="en-US" dirty="0"/>
               <a:t>【台本】（約60秒）
-これからの方針です。課題の番号に対応させています。
-まず1週間ほどで、①②の確認をします。事前学習なしで同じモデルを学習して比べることと、開発データや生成し直しでの再確認、先行研究の方法との同じ条件での比較です。
-次の1週間で、③別のマイクで効くかを、フランス語の公開データで確かめます。汎用の音声復元ツールとの比較と、処理時間の計測もします。
+これからの方針です。まず1週間ほどで、課題①②の確認をします。事前学習なしで同じモデルを学習して比べることと、開発データや生成し直しでの再確認です。
+次の1週間で、③別のマイクで効くかを、フランス語の公開データで確かめます。
 その先で、④手法としての工夫を入れたいと考えています。候補は、マイクの情報を手がかりとして与えて少ないデータで別のマイクに対応する方法と、生成を複数回行って平均し、誤りを安定して減らす方法です。
-最後に相談したいことが3つあります。別のマイクでの検証のために日本語で自分でも録音すべきか、手法の新しさをどこに置くのがよいか、そして非商用ライセンスの公開モデルを土台にしてよいか。ご意見をいただけると助かります。以上です。
+最後に、ここに挙げた3つについてご意見をいただけると助かります。以上です。
 【補足】VibraVoxはマイクと言語が同時に変わるため、効果の切り分けには日本語の自前収録が有効（相談1の理由）。複数回の平均は、以前4つの音声強調の出力を平均すると全認識器で改善した知見から。</a:t>
             </a:r>
             <a:endParaRPr lang="en-US" dirty="0"/>

</xml_diff>

<commit_message>
Slides 2026-10: fix wraps/overlaps and add missing context (TAPS, input types, relative %, license) from visual and comprehension QA
Co-Authored-By: Claude Opus 5.5 (1M context) <noreply@anthropic.com>
</commit_message>
<xml_diff>
--- a/results/progress_slides_2026-10.pptx
+++ b/results/progress_slides_2026-10.pptx
@@ -2080,7 +2080,7 @@
         </p:nvGraphicFramePr>
         <p:xfrm>
           <a:off x="548640" y="1463040"/>
-          <a:ext cx="6766560" cy="4206240"/>
+          <a:ext cx="6400800" cy="4206240"/>
         </p:xfrm>
         <a:graphic xmlns:a="http://schemas.openxmlformats.org/drawingml/2006/main">
           <a:graphicData uri="http://schemas.openxmlformats.org/drawingml/2006/chart">
@@ -2097,7 +2097,7 @@
         <p:spPr>
           <a:xfrm>
             <a:off x="548640" y="5715000"/>
-            <a:ext cx="6766560" cy="320040"/>
+            <a:ext cx="6400800" cy="320040"/>
           </a:xfrm>
           <a:prstGeom prst="rect">
             <a:avLst/>
@@ -2121,7 +2121,7 @@
                 <a:ea typeface="Yu Gothic" pitchFamily="34" charset="-122"/>
                 <a:cs typeface="Yu Gothic" pitchFamily="34" charset="-120"/>
               </a:rPr>
-              <a:t>誤りの増減（元の音声強調と比べて）</a:t>
+              <a:t>文字誤り率の相対的な増減（元の音声強調と比べて）</a:t>
             </a:r>
             <a:endParaRPr lang="en-US" sz="1400" dirty="0"/>
           </a:p>
@@ -2135,8 +2135,8 @@
         </p:nvSpPr>
         <p:spPr>
           <a:xfrm>
-            <a:off x="7772400" y="1645920"/>
-            <a:ext cx="3870655" cy="4023360"/>
+            <a:off x="7315200" y="1645920"/>
+            <a:ext cx="4327855" cy="4023360"/>
           </a:xfrm>
           <a:prstGeom prst="rect">
             <a:avLst/>
@@ -2207,7 +2207,7 @@
                 <a:ea typeface="Yu Gothic" pitchFamily="34" charset="-122"/>
                 <a:cs typeface="Yu Gothic" pitchFamily="34" charset="-120"/>
               </a:rPr>
-              <a:t>の認識器では誤りが減る</a:t>
+              <a:t>（音の特徴の作り方）の認識器では誤りが減る</a:t>
             </a:r>
             <a:endParaRPr lang="en-US" sz="2000" dirty="0"/>
           </a:p>
@@ -2231,7 +2231,7 @@
                 <a:ea typeface="Yu Gothic" pitchFamily="34" charset="-122"/>
                 <a:cs typeface="Yu Gothic" pitchFamily="34" charset="-120"/>
               </a:rPr>
-              <a:t>入力の作りが違う認識器では</a:t>
+              <a:t>入力が違う認識器（波形をそのまま入れる等）では</a:t>
             </a:r>
             <a:pPr indent="0" marL="0">
               <a:lnSpc>
@@ -2354,7 +2354,7 @@
                 <a:ea typeface="Yu Gothic" pitchFamily="34" charset="-122"/>
                 <a:cs typeface="Yu Gothic" pitchFamily="34" charset="-120"/>
               </a:rPr>
-              <a:t>卒論の方法：Whisper-small が正しく書き起こせるように音声強調（TAPS SE-Conformer）を追加学習。比べる相手は追加学習前の同じモデル</a:t>
+              <a:t>データ: TAPS（喉マイクと普通のマイクの同時録音、韓国語）。元の音声強調 = TAPS 公開の SE-Conformer</a:t>
             </a:r>
             <a:endParaRPr lang="en-US" sz="1200" dirty="0"/>
           </a:p>
@@ -2433,14 +2433,53 @@
       </p:sp>
       <p:sp>
         <p:nvSpPr>
-          <p:cNvPr id="3" name="Shape 1"/>
-          <p:cNvSpPr/>
-          <p:nvPr/>
-        </p:nvSpPr>
-        <p:spPr>
-          <a:xfrm>
-            <a:off x="3429000" y="1691640"/>
-            <a:ext cx="0" cy="3913632"/>
+          <p:cNvPr id="3" name="Text 1"/>
+          <p:cNvSpPr/>
+          <p:nvPr/>
+        </p:nvSpPr>
+        <p:spPr>
+          <a:xfrm>
+            <a:off x="548640" y="1188720"/>
+            <a:ext cx="11094415" cy="365760"/>
+          </a:xfrm>
+          <a:prstGeom prst="rect">
+            <a:avLst/>
+          </a:prstGeom>
+          <a:noFill/>
+          <a:ln/>
+        </p:spPr>
+        <p:txBody>
+          <a:bodyPr wrap="square" lIns="0" tIns="0" rIns="0" bIns="0" rtlCol="0" anchor="t"/>
+          <a:lstStyle/>
+          <a:p>
+            <a:pPr indent="0" marL="0">
+              <a:buNone/>
+            </a:pPr>
+            <a:r>
+              <a:rPr lang="en-US" sz="1800" dirty="0">
+                <a:solidFill>
+                  <a:srgbClr val="777777"/>
+                </a:solidFill>
+                <a:latin typeface="Yu Gothic" pitchFamily="34" charset="0"/>
+                <a:ea typeface="Yu Gothic" pitchFamily="34" charset="-122"/>
+                <a:cs typeface="Yu Gothic" pitchFamily="34" charset="-120"/>
+              </a:rPr>
+              <a:t>狙い：特定の認識器に合わせず、音そのものを直す（音声認識は学習に使わない）</a:t>
+            </a:r>
+            <a:endParaRPr lang="en-US" sz="1800" dirty="0"/>
+          </a:p>
+        </p:txBody>
+      </p:sp>
+      <p:sp>
+        <p:nvSpPr>
+          <p:cNvPr id="4" name="Shape 2"/>
+          <p:cNvSpPr/>
+          <p:nvPr/>
+        </p:nvSpPr>
+        <p:spPr>
+          <a:xfrm>
+            <a:off x="3429000" y="2011680"/>
+            <a:ext cx="0" cy="3831336"/>
           </a:xfrm>
           <a:prstGeom prst="line">
             <a:avLst/>
@@ -2456,13 +2495,13 @@
       </p:sp>
       <p:sp>
         <p:nvSpPr>
-          <p:cNvPr id="4" name="Text 2"/>
-          <p:cNvSpPr/>
-          <p:nvPr/>
-        </p:nvSpPr>
-        <p:spPr>
-          <a:xfrm>
-            <a:off x="3108960" y="5669280"/>
+          <p:cNvPr id="5" name="Text 3"/>
+          <p:cNvSpPr/>
+          <p:nvPr/>
+        </p:nvSpPr>
+        <p:spPr>
+          <a:xfrm>
+            <a:off x="3108960" y="5907024"/>
             <a:ext cx="640080" cy="274320"/>
           </a:xfrm>
           <a:prstGeom prst="rect">
@@ -2495,14 +2534,14 @@
       </p:sp>
       <p:sp>
         <p:nvSpPr>
-          <p:cNvPr id="5" name="Shape 3"/>
-          <p:cNvSpPr/>
-          <p:nvPr/>
-        </p:nvSpPr>
-        <p:spPr>
-          <a:xfrm>
-            <a:off x="4770120" y="1691640"/>
-            <a:ext cx="0" cy="3913632"/>
+          <p:cNvPr id="6" name="Shape 4"/>
+          <p:cNvSpPr/>
+          <p:nvPr/>
+        </p:nvSpPr>
+        <p:spPr>
+          <a:xfrm>
+            <a:off x="4770120" y="2011680"/>
+            <a:ext cx="0" cy="3831336"/>
           </a:xfrm>
           <a:prstGeom prst="line">
             <a:avLst/>
@@ -2518,13 +2557,13 @@
       </p:sp>
       <p:sp>
         <p:nvSpPr>
-          <p:cNvPr id="6" name="Text 4"/>
-          <p:cNvSpPr/>
-          <p:nvPr/>
-        </p:nvSpPr>
-        <p:spPr>
-          <a:xfrm>
-            <a:off x="4450080" y="5669280"/>
+          <p:cNvPr id="7" name="Text 5"/>
+          <p:cNvSpPr/>
+          <p:nvPr/>
+        </p:nvSpPr>
+        <p:spPr>
+          <a:xfrm>
+            <a:off x="4450080" y="5907024"/>
             <a:ext cx="640080" cy="274320"/>
           </a:xfrm>
           <a:prstGeom prst="rect">
@@ -2557,14 +2596,14 @@
       </p:sp>
       <p:sp>
         <p:nvSpPr>
-          <p:cNvPr id="7" name="Shape 5"/>
-          <p:cNvSpPr/>
-          <p:nvPr/>
-        </p:nvSpPr>
-        <p:spPr>
-          <a:xfrm>
-            <a:off x="6111240" y="1691640"/>
-            <a:ext cx="0" cy="3913632"/>
+          <p:cNvPr id="8" name="Shape 6"/>
+          <p:cNvSpPr/>
+          <p:nvPr/>
+        </p:nvSpPr>
+        <p:spPr>
+          <a:xfrm>
+            <a:off x="6111240" y="2011680"/>
+            <a:ext cx="0" cy="3831336"/>
           </a:xfrm>
           <a:prstGeom prst="line">
             <a:avLst/>
@@ -2580,13 +2619,13 @@
       </p:sp>
       <p:sp>
         <p:nvSpPr>
-          <p:cNvPr id="8" name="Text 6"/>
-          <p:cNvSpPr/>
-          <p:nvPr/>
-        </p:nvSpPr>
-        <p:spPr>
-          <a:xfrm>
-            <a:off x="5791200" y="5669280"/>
+          <p:cNvPr id="9" name="Text 7"/>
+          <p:cNvSpPr/>
+          <p:nvPr/>
+        </p:nvSpPr>
+        <p:spPr>
+          <a:xfrm>
+            <a:off x="5791200" y="5907024"/>
             <a:ext cx="640080" cy="274320"/>
           </a:xfrm>
           <a:prstGeom prst="rect">
@@ -2619,14 +2658,14 @@
       </p:sp>
       <p:sp>
         <p:nvSpPr>
-          <p:cNvPr id="9" name="Shape 7"/>
-          <p:cNvSpPr/>
-          <p:nvPr/>
-        </p:nvSpPr>
-        <p:spPr>
-          <a:xfrm>
-            <a:off x="7452360" y="1691640"/>
-            <a:ext cx="0" cy="3913632"/>
+          <p:cNvPr id="10" name="Shape 8"/>
+          <p:cNvSpPr/>
+          <p:nvPr/>
+        </p:nvSpPr>
+        <p:spPr>
+          <a:xfrm>
+            <a:off x="7452360" y="2011680"/>
+            <a:ext cx="0" cy="3831336"/>
           </a:xfrm>
           <a:prstGeom prst="line">
             <a:avLst/>
@@ -2642,13 +2681,13 @@
       </p:sp>
       <p:sp>
         <p:nvSpPr>
-          <p:cNvPr id="10" name="Text 8"/>
-          <p:cNvSpPr/>
-          <p:nvPr/>
-        </p:nvSpPr>
-        <p:spPr>
-          <a:xfrm>
-            <a:off x="7132320" y="5669280"/>
+          <p:cNvPr id="11" name="Text 9"/>
+          <p:cNvSpPr/>
+          <p:nvPr/>
+        </p:nvSpPr>
+        <p:spPr>
+          <a:xfrm>
+            <a:off x="7132320" y="5907024"/>
             <a:ext cx="640080" cy="274320"/>
           </a:xfrm>
           <a:prstGeom prst="rect">
@@ -2681,13 +2720,13 @@
       </p:sp>
       <p:sp>
         <p:nvSpPr>
-          <p:cNvPr id="11" name="Text 9"/>
-          <p:cNvSpPr/>
-          <p:nvPr/>
-        </p:nvSpPr>
-        <p:spPr>
-          <a:xfrm>
-            <a:off x="548640" y="1783080"/>
+          <p:cNvPr id="12" name="Text 10"/>
+          <p:cNvSpPr/>
+          <p:nvPr/>
+        </p:nvSpPr>
+        <p:spPr>
+          <a:xfrm>
+            <a:off x="548640" y="2103120"/>
             <a:ext cx="2743200" cy="274320"/>
           </a:xfrm>
           <a:prstGeom prst="rect">
@@ -2704,9 +2743,9 @@
               <a:buNone/>
             </a:pPr>
             <a:r>
-              <a:rPr lang="en-US" sz="1500" dirty="0">
-                <a:solidFill>
-                  <a:srgbClr val="2D2D2D"/>
+              <a:rPr lang="en-US" sz="1500" b="1" dirty="0">
+                <a:solidFill>
+                  <a:srgbClr val="2E75B6"/>
                 </a:solidFill>
                 <a:latin typeface="Yu Gothic" pitchFamily="34" charset="0"/>
                 <a:ea typeface="Yu Gothic" pitchFamily="34" charset="-122"/>
@@ -2720,13 +2759,13 @@
       </p:sp>
       <p:sp>
         <p:nvSpPr>
-          <p:cNvPr id="12" name="Shape 10"/>
-          <p:cNvSpPr/>
-          <p:nvPr/>
-        </p:nvSpPr>
-        <p:spPr>
-          <a:xfrm>
-            <a:off x="6453226" y="1920240"/>
+          <p:cNvPr id="13" name="Shape 11"/>
+          <p:cNvSpPr/>
+          <p:nvPr/>
+        </p:nvSpPr>
+        <p:spPr>
+          <a:xfrm>
+            <a:off x="6453226" y="2240280"/>
             <a:ext cx="610210" cy="0"/>
           </a:xfrm>
           <a:prstGeom prst="line">
@@ -2743,13 +2782,13 @@
       </p:sp>
       <p:sp>
         <p:nvSpPr>
-          <p:cNvPr id="13" name="Shape 11"/>
-          <p:cNvSpPr/>
-          <p:nvPr/>
-        </p:nvSpPr>
-        <p:spPr>
-          <a:xfrm>
-            <a:off x="6981139" y="1837944"/>
+          <p:cNvPr id="14" name="Shape 12"/>
+          <p:cNvSpPr/>
+          <p:nvPr/>
+        </p:nvSpPr>
+        <p:spPr>
+          <a:xfrm>
+            <a:off x="6981139" y="2157984"/>
             <a:ext cx="164592" cy="164592"/>
           </a:xfrm>
           <a:prstGeom prst="ellipse">
@@ -2768,13 +2807,13 @@
       </p:sp>
       <p:sp>
         <p:nvSpPr>
-          <p:cNvPr id="14" name="Shape 12"/>
-          <p:cNvSpPr/>
-          <p:nvPr/>
-        </p:nvSpPr>
-        <p:spPr>
-          <a:xfrm>
-            <a:off x="6361786" y="1828800"/>
+          <p:cNvPr id="15" name="Shape 13"/>
+          <p:cNvSpPr/>
+          <p:nvPr/>
+        </p:nvSpPr>
+        <p:spPr>
+          <a:xfrm>
+            <a:off x="6361786" y="2148840"/>
             <a:ext cx="182880" cy="182880"/>
           </a:xfrm>
           <a:prstGeom prst="ellipse">
@@ -2793,13 +2832,13 @@
       </p:sp>
       <p:sp>
         <p:nvSpPr>
-          <p:cNvPr id="15" name="Text 13"/>
-          <p:cNvSpPr/>
-          <p:nvPr/>
-        </p:nvSpPr>
-        <p:spPr>
-          <a:xfrm>
-            <a:off x="548640" y="2212848"/>
+          <p:cNvPr id="16" name="Text 14"/>
+          <p:cNvSpPr/>
+          <p:nvPr/>
+        </p:nvSpPr>
+        <p:spPr>
+          <a:xfrm>
+            <a:off x="548640" y="2523744"/>
             <a:ext cx="2743200" cy="274320"/>
           </a:xfrm>
           <a:prstGeom prst="rect">
@@ -2816,9 +2855,9 @@
               <a:buNone/>
             </a:pPr>
             <a:r>
-              <a:rPr lang="en-US" sz="1500" dirty="0">
-                <a:solidFill>
-                  <a:srgbClr val="2D2D2D"/>
+              <a:rPr lang="en-US" sz="1500" b="1" dirty="0">
+                <a:solidFill>
+                  <a:srgbClr val="2E75B6"/>
                 </a:solidFill>
                 <a:latin typeface="Yu Gothic" pitchFamily="34" charset="0"/>
                 <a:ea typeface="Yu Gothic" pitchFamily="34" charset="-122"/>
@@ -2832,13 +2871,13 @@
       </p:sp>
       <p:sp>
         <p:nvSpPr>
-          <p:cNvPr id="16" name="Shape 14"/>
-          <p:cNvSpPr/>
-          <p:nvPr/>
-        </p:nvSpPr>
-        <p:spPr>
-          <a:xfrm>
-            <a:off x="5420563" y="2350008"/>
+          <p:cNvPr id="17" name="Shape 15"/>
+          <p:cNvSpPr/>
+          <p:nvPr/>
+        </p:nvSpPr>
+        <p:spPr>
+          <a:xfrm>
+            <a:off x="5420563" y="2660904"/>
             <a:ext cx="355397" cy="0"/>
           </a:xfrm>
           <a:prstGeom prst="line">
@@ -2855,13 +2894,13 @@
       </p:sp>
       <p:sp>
         <p:nvSpPr>
-          <p:cNvPr id="17" name="Shape 15"/>
-          <p:cNvSpPr/>
-          <p:nvPr/>
-        </p:nvSpPr>
-        <p:spPr>
-          <a:xfrm>
-            <a:off x="5693664" y="2267712"/>
+          <p:cNvPr id="18" name="Shape 16"/>
+          <p:cNvSpPr/>
+          <p:nvPr/>
+        </p:nvSpPr>
+        <p:spPr>
+          <a:xfrm>
+            <a:off x="5693664" y="2578608"/>
             <a:ext cx="164592" cy="164592"/>
           </a:xfrm>
           <a:prstGeom prst="ellipse">
@@ -2880,13 +2919,13 @@
       </p:sp>
       <p:sp>
         <p:nvSpPr>
-          <p:cNvPr id="18" name="Shape 16"/>
-          <p:cNvSpPr/>
-          <p:nvPr/>
-        </p:nvSpPr>
-        <p:spPr>
-          <a:xfrm>
-            <a:off x="5329123" y="2258568"/>
+          <p:cNvPr id="19" name="Shape 17"/>
+          <p:cNvSpPr/>
+          <p:nvPr/>
+        </p:nvSpPr>
+        <p:spPr>
+          <a:xfrm>
+            <a:off x="5329123" y="2569464"/>
             <a:ext cx="182880" cy="182880"/>
           </a:xfrm>
           <a:prstGeom prst="ellipse">
@@ -2905,13 +2944,13 @@
       </p:sp>
       <p:sp>
         <p:nvSpPr>
-          <p:cNvPr id="19" name="Text 17"/>
-          <p:cNvSpPr/>
-          <p:nvPr/>
-        </p:nvSpPr>
-        <p:spPr>
-          <a:xfrm>
-            <a:off x="548640" y="2642616"/>
+          <p:cNvPr id="20" name="Text 18"/>
+          <p:cNvSpPr/>
+          <p:nvPr/>
+        </p:nvSpPr>
+        <p:spPr>
+          <a:xfrm>
+            <a:off x="548640" y="2944368"/>
             <a:ext cx="2743200" cy="274320"/>
           </a:xfrm>
           <a:prstGeom prst="rect">
@@ -2944,13 +2983,13 @@
       </p:sp>
       <p:sp>
         <p:nvSpPr>
-          <p:cNvPr id="20" name="Shape 18"/>
-          <p:cNvSpPr/>
-          <p:nvPr/>
-        </p:nvSpPr>
-        <p:spPr>
-          <a:xfrm>
-            <a:off x="4890821" y="2779776"/>
+          <p:cNvPr id="21" name="Shape 19"/>
+          <p:cNvSpPr/>
+          <p:nvPr/>
+        </p:nvSpPr>
+        <p:spPr>
+          <a:xfrm>
+            <a:off x="4890821" y="3081528"/>
             <a:ext cx="368808" cy="0"/>
           </a:xfrm>
           <a:prstGeom prst="line">
@@ -2967,13 +3006,13 @@
       </p:sp>
       <p:sp>
         <p:nvSpPr>
-          <p:cNvPr id="21" name="Shape 19"/>
-          <p:cNvSpPr/>
-          <p:nvPr/>
-        </p:nvSpPr>
-        <p:spPr>
-          <a:xfrm>
-            <a:off x="5177333" y="2697480"/>
+          <p:cNvPr id="22" name="Shape 20"/>
+          <p:cNvSpPr/>
+          <p:nvPr/>
+        </p:nvSpPr>
+        <p:spPr>
+          <a:xfrm>
+            <a:off x="5177333" y="2999232"/>
             <a:ext cx="164592" cy="164592"/>
           </a:xfrm>
           <a:prstGeom prst="ellipse">
@@ -2992,13 +3031,13 @@
       </p:sp>
       <p:sp>
         <p:nvSpPr>
-          <p:cNvPr id="22" name="Shape 20"/>
-          <p:cNvSpPr/>
-          <p:nvPr/>
-        </p:nvSpPr>
-        <p:spPr>
-          <a:xfrm>
-            <a:off x="4799381" y="2688336"/>
+          <p:cNvPr id="23" name="Shape 21"/>
+          <p:cNvSpPr/>
+          <p:nvPr/>
+        </p:nvSpPr>
+        <p:spPr>
+          <a:xfrm>
+            <a:off x="4799381" y="2990088"/>
             <a:ext cx="182880" cy="182880"/>
           </a:xfrm>
           <a:prstGeom prst="ellipse">
@@ -3017,13 +3056,13 @@
       </p:sp>
       <p:sp>
         <p:nvSpPr>
-          <p:cNvPr id="23" name="Text 21"/>
-          <p:cNvSpPr/>
-          <p:nvPr/>
-        </p:nvSpPr>
-        <p:spPr>
-          <a:xfrm>
-            <a:off x="548640" y="3072384"/>
+          <p:cNvPr id="24" name="Text 22"/>
+          <p:cNvSpPr/>
+          <p:nvPr/>
+        </p:nvSpPr>
+        <p:spPr>
+          <a:xfrm>
+            <a:off x="548640" y="3364992"/>
             <a:ext cx="2743200" cy="274320"/>
           </a:xfrm>
           <a:prstGeom prst="rect">
@@ -3056,13 +3095,13 @@
       </p:sp>
       <p:sp>
         <p:nvSpPr>
-          <p:cNvPr id="24" name="Shape 22"/>
-          <p:cNvSpPr/>
-          <p:nvPr/>
-        </p:nvSpPr>
-        <p:spPr>
-          <a:xfrm>
-            <a:off x="4636008" y="3209544"/>
+          <p:cNvPr id="25" name="Shape 23"/>
+          <p:cNvSpPr/>
+          <p:nvPr/>
+        </p:nvSpPr>
+        <p:spPr>
+          <a:xfrm>
+            <a:off x="4636008" y="3502152"/>
             <a:ext cx="335280" cy="0"/>
           </a:xfrm>
           <a:prstGeom prst="line">
@@ -3079,13 +3118,13 @@
       </p:sp>
       <p:sp>
         <p:nvSpPr>
-          <p:cNvPr id="25" name="Shape 23"/>
-          <p:cNvSpPr/>
-          <p:nvPr/>
-        </p:nvSpPr>
-        <p:spPr>
-          <a:xfrm>
-            <a:off x="4888992" y="3127248"/>
+          <p:cNvPr id="26" name="Shape 24"/>
+          <p:cNvSpPr/>
+          <p:nvPr/>
+        </p:nvSpPr>
+        <p:spPr>
+          <a:xfrm>
+            <a:off x="4888992" y="3419856"/>
             <a:ext cx="164592" cy="164592"/>
           </a:xfrm>
           <a:prstGeom prst="ellipse">
@@ -3104,13 +3143,13 @@
       </p:sp>
       <p:sp>
         <p:nvSpPr>
-          <p:cNvPr id="26" name="Shape 24"/>
-          <p:cNvSpPr/>
-          <p:nvPr/>
-        </p:nvSpPr>
-        <p:spPr>
-          <a:xfrm>
-            <a:off x="4544568" y="3118104"/>
+          <p:cNvPr id="27" name="Shape 25"/>
+          <p:cNvSpPr/>
+          <p:nvPr/>
+        </p:nvSpPr>
+        <p:spPr>
+          <a:xfrm>
+            <a:off x="4544568" y="3410712"/>
             <a:ext cx="182880" cy="182880"/>
           </a:xfrm>
           <a:prstGeom prst="ellipse">
@@ -3129,13 +3168,13 @@
       </p:sp>
       <p:sp>
         <p:nvSpPr>
-          <p:cNvPr id="27" name="Text 25"/>
-          <p:cNvSpPr/>
-          <p:nvPr/>
-        </p:nvSpPr>
-        <p:spPr>
-          <a:xfrm>
-            <a:off x="548640" y="3502152"/>
+          <p:cNvPr id="28" name="Text 26"/>
+          <p:cNvSpPr/>
+          <p:nvPr/>
+        </p:nvSpPr>
+        <p:spPr>
+          <a:xfrm>
+            <a:off x="548640" y="3785616"/>
             <a:ext cx="2743200" cy="274320"/>
           </a:xfrm>
           <a:prstGeom prst="rect">
@@ -3152,9 +3191,9 @@
               <a:buNone/>
             </a:pPr>
             <a:r>
-              <a:rPr lang="en-US" sz="1500" dirty="0">
-                <a:solidFill>
-                  <a:srgbClr val="2D2D2D"/>
+              <a:rPr lang="en-US" sz="1500" b="1" dirty="0">
+                <a:solidFill>
+                  <a:srgbClr val="2E75B6"/>
                 </a:solidFill>
                 <a:latin typeface="Yu Gothic" pitchFamily="34" charset="0"/>
                 <a:ea typeface="Yu Gothic" pitchFamily="34" charset="-122"/>
@@ -3168,13 +3207,13 @@
       </p:sp>
       <p:sp>
         <p:nvSpPr>
-          <p:cNvPr id="28" name="Shape 26"/>
-          <p:cNvSpPr/>
-          <p:nvPr/>
-        </p:nvSpPr>
-        <p:spPr>
-          <a:xfrm>
-            <a:off x="4562246" y="3639312"/>
+          <p:cNvPr id="29" name="Shape 27"/>
+          <p:cNvSpPr/>
+          <p:nvPr/>
+        </p:nvSpPr>
+        <p:spPr>
+          <a:xfrm>
+            <a:off x="4562246" y="3922776"/>
             <a:ext cx="355397" cy="0"/>
           </a:xfrm>
           <a:prstGeom prst="line">
@@ -3191,13 +3230,13 @@
       </p:sp>
       <p:sp>
         <p:nvSpPr>
-          <p:cNvPr id="29" name="Shape 27"/>
-          <p:cNvSpPr/>
-          <p:nvPr/>
-        </p:nvSpPr>
-        <p:spPr>
-          <a:xfrm>
-            <a:off x="4835347" y="3557016"/>
+          <p:cNvPr id="30" name="Shape 28"/>
+          <p:cNvSpPr/>
+          <p:nvPr/>
+        </p:nvSpPr>
+        <p:spPr>
+          <a:xfrm>
+            <a:off x="4835347" y="3840480"/>
             <a:ext cx="164592" cy="164592"/>
           </a:xfrm>
           <a:prstGeom prst="ellipse">
@@ -3216,13 +3255,13 @@
       </p:sp>
       <p:sp>
         <p:nvSpPr>
-          <p:cNvPr id="30" name="Shape 28"/>
-          <p:cNvSpPr/>
-          <p:nvPr/>
-        </p:nvSpPr>
-        <p:spPr>
-          <a:xfrm>
-            <a:off x="4470806" y="3547872"/>
+          <p:cNvPr id="31" name="Shape 29"/>
+          <p:cNvSpPr/>
+          <p:nvPr/>
+        </p:nvSpPr>
+        <p:spPr>
+          <a:xfrm>
+            <a:off x="4470806" y="3831336"/>
             <a:ext cx="182880" cy="182880"/>
           </a:xfrm>
           <a:prstGeom prst="ellipse">
@@ -3241,13 +3280,13 @@
       </p:sp>
       <p:sp>
         <p:nvSpPr>
-          <p:cNvPr id="31" name="Text 29"/>
-          <p:cNvSpPr/>
-          <p:nvPr/>
-        </p:nvSpPr>
-        <p:spPr>
-          <a:xfrm>
-            <a:off x="548640" y="3931920"/>
+          <p:cNvPr id="32" name="Text 30"/>
+          <p:cNvSpPr/>
+          <p:nvPr/>
+        </p:nvSpPr>
+        <p:spPr>
+          <a:xfrm>
+            <a:off x="548640" y="4206240"/>
             <a:ext cx="2743200" cy="274320"/>
           </a:xfrm>
           <a:prstGeom prst="rect">
@@ -3280,13 +3319,13 @@
       </p:sp>
       <p:sp>
         <p:nvSpPr>
-          <p:cNvPr id="32" name="Shape 30"/>
-          <p:cNvSpPr/>
-          <p:nvPr/>
-        </p:nvSpPr>
-        <p:spPr>
-          <a:xfrm>
-            <a:off x="4495190" y="4069080"/>
+          <p:cNvPr id="33" name="Shape 31"/>
+          <p:cNvSpPr/>
+          <p:nvPr/>
+        </p:nvSpPr>
+        <p:spPr>
+          <a:xfrm>
+            <a:off x="4495190" y="4343400"/>
             <a:ext cx="248107" cy="0"/>
           </a:xfrm>
           <a:prstGeom prst="line">
@@ -3303,13 +3342,13 @@
       </p:sp>
       <p:sp>
         <p:nvSpPr>
-          <p:cNvPr id="33" name="Shape 31"/>
-          <p:cNvSpPr/>
-          <p:nvPr/>
-        </p:nvSpPr>
-        <p:spPr>
-          <a:xfrm>
-            <a:off x="4661002" y="3986784"/>
+          <p:cNvPr id="34" name="Shape 32"/>
+          <p:cNvSpPr/>
+          <p:nvPr/>
+        </p:nvSpPr>
+        <p:spPr>
+          <a:xfrm>
+            <a:off x="4661002" y="4261104"/>
             <a:ext cx="164592" cy="164592"/>
           </a:xfrm>
           <a:prstGeom prst="ellipse">
@@ -3328,13 +3367,13 @@
       </p:sp>
       <p:sp>
         <p:nvSpPr>
-          <p:cNvPr id="34" name="Shape 32"/>
-          <p:cNvSpPr/>
-          <p:nvPr/>
-        </p:nvSpPr>
-        <p:spPr>
-          <a:xfrm>
-            <a:off x="4403750" y="3977640"/>
+          <p:cNvPr id="35" name="Shape 33"/>
+          <p:cNvSpPr/>
+          <p:nvPr/>
+        </p:nvSpPr>
+        <p:spPr>
+          <a:xfrm>
+            <a:off x="4403750" y="4251960"/>
             <a:ext cx="182880" cy="182880"/>
           </a:xfrm>
           <a:prstGeom prst="ellipse">
@@ -3353,13 +3392,13 @@
       </p:sp>
       <p:sp>
         <p:nvSpPr>
-          <p:cNvPr id="35" name="Text 33"/>
-          <p:cNvSpPr/>
-          <p:nvPr/>
-        </p:nvSpPr>
-        <p:spPr>
-          <a:xfrm>
-            <a:off x="548640" y="4361688"/>
+          <p:cNvPr id="36" name="Text 34"/>
+          <p:cNvSpPr/>
+          <p:nvPr/>
+        </p:nvSpPr>
+        <p:spPr>
+          <a:xfrm>
+            <a:off x="548640" y="4626864"/>
             <a:ext cx="2743200" cy="274320"/>
           </a:xfrm>
           <a:prstGeom prst="rect">
@@ -3392,13 +3431,13 @@
       </p:sp>
       <p:sp>
         <p:nvSpPr>
-          <p:cNvPr id="36" name="Shape 34"/>
-          <p:cNvSpPr/>
-          <p:nvPr/>
-        </p:nvSpPr>
-        <p:spPr>
-          <a:xfrm>
-            <a:off x="4347667" y="4498848"/>
+          <p:cNvPr id="37" name="Shape 35"/>
+          <p:cNvSpPr/>
+          <p:nvPr/>
+        </p:nvSpPr>
+        <p:spPr>
+          <a:xfrm>
+            <a:off x="4347667" y="4764024"/>
             <a:ext cx="221285" cy="0"/>
           </a:xfrm>
           <a:prstGeom prst="line">
@@ -3415,13 +3454,13 @@
       </p:sp>
       <p:sp>
         <p:nvSpPr>
-          <p:cNvPr id="37" name="Shape 35"/>
-          <p:cNvSpPr/>
-          <p:nvPr/>
-        </p:nvSpPr>
-        <p:spPr>
-          <a:xfrm>
-            <a:off x="4486656" y="4416552"/>
+          <p:cNvPr id="38" name="Shape 36"/>
+          <p:cNvSpPr/>
+          <p:nvPr/>
+        </p:nvSpPr>
+        <p:spPr>
+          <a:xfrm>
+            <a:off x="4486656" y="4681728"/>
             <a:ext cx="164592" cy="164592"/>
           </a:xfrm>
           <a:prstGeom prst="ellipse">
@@ -3440,13 +3479,13 @@
       </p:sp>
       <p:sp>
         <p:nvSpPr>
-          <p:cNvPr id="38" name="Shape 36"/>
-          <p:cNvSpPr/>
-          <p:nvPr/>
-        </p:nvSpPr>
-        <p:spPr>
-          <a:xfrm>
-            <a:off x="4256227" y="4407408"/>
+          <p:cNvPr id="39" name="Shape 37"/>
+          <p:cNvSpPr/>
+          <p:nvPr/>
+        </p:nvSpPr>
+        <p:spPr>
+          <a:xfrm>
+            <a:off x="4256227" y="4672584"/>
             <a:ext cx="182880" cy="182880"/>
           </a:xfrm>
           <a:prstGeom prst="ellipse">
@@ -3465,13 +3504,13 @@
       </p:sp>
       <p:sp>
         <p:nvSpPr>
-          <p:cNvPr id="39" name="Text 37"/>
-          <p:cNvSpPr/>
-          <p:nvPr/>
-        </p:nvSpPr>
-        <p:spPr>
-          <a:xfrm>
-            <a:off x="548640" y="4791456"/>
+          <p:cNvPr id="40" name="Text 38"/>
+          <p:cNvSpPr/>
+          <p:nvPr/>
+        </p:nvSpPr>
+        <p:spPr>
+          <a:xfrm>
+            <a:off x="548640" y="5047488"/>
             <a:ext cx="2743200" cy="274320"/>
           </a:xfrm>
           <a:prstGeom prst="rect">
@@ -3504,13 +3543,13 @@
       </p:sp>
       <p:sp>
         <p:nvSpPr>
-          <p:cNvPr id="40" name="Shape 38"/>
-          <p:cNvSpPr/>
-          <p:nvPr/>
-        </p:nvSpPr>
-        <p:spPr>
-          <a:xfrm>
-            <a:off x="4166616" y="4928616"/>
+          <p:cNvPr id="41" name="Shape 39"/>
+          <p:cNvSpPr/>
+          <p:nvPr/>
+        </p:nvSpPr>
+        <p:spPr>
+          <a:xfrm>
+            <a:off x="4166616" y="5184648"/>
             <a:ext cx="241402" cy="0"/>
           </a:xfrm>
           <a:prstGeom prst="line">
@@ -3527,13 +3566,13 @@
       </p:sp>
       <p:sp>
         <p:nvSpPr>
-          <p:cNvPr id="41" name="Shape 39"/>
-          <p:cNvSpPr/>
-          <p:nvPr/>
-        </p:nvSpPr>
-        <p:spPr>
-          <a:xfrm>
-            <a:off x="4325722" y="4846320"/>
+          <p:cNvPr id="42" name="Shape 40"/>
+          <p:cNvSpPr/>
+          <p:nvPr/>
+        </p:nvSpPr>
+        <p:spPr>
+          <a:xfrm>
+            <a:off x="4325722" y="5102352"/>
             <a:ext cx="164592" cy="164592"/>
           </a:xfrm>
           <a:prstGeom prst="ellipse">
@@ -3552,13 +3591,13 @@
       </p:sp>
       <p:sp>
         <p:nvSpPr>
-          <p:cNvPr id="42" name="Shape 40"/>
-          <p:cNvSpPr/>
-          <p:nvPr/>
-        </p:nvSpPr>
-        <p:spPr>
-          <a:xfrm>
-            <a:off x="4075176" y="4837176"/>
+          <p:cNvPr id="43" name="Shape 41"/>
+          <p:cNvSpPr/>
+          <p:nvPr/>
+        </p:nvSpPr>
+        <p:spPr>
+          <a:xfrm>
+            <a:off x="4075176" y="5093208"/>
             <a:ext cx="182880" cy="182880"/>
           </a:xfrm>
           <a:prstGeom prst="ellipse">
@@ -3577,13 +3616,13 @@
       </p:sp>
       <p:sp>
         <p:nvSpPr>
-          <p:cNvPr id="43" name="Text 41"/>
-          <p:cNvSpPr/>
-          <p:nvPr/>
-        </p:nvSpPr>
-        <p:spPr>
-          <a:xfrm>
-            <a:off x="548640" y="5221224"/>
+          <p:cNvPr id="44" name="Text 42"/>
+          <p:cNvSpPr/>
+          <p:nvPr/>
+        </p:nvSpPr>
+        <p:spPr>
+          <a:xfrm>
+            <a:off x="548640" y="5468112"/>
             <a:ext cx="2743200" cy="274320"/>
           </a:xfrm>
           <a:prstGeom prst="rect">
@@ -3616,13 +3655,13 @@
       </p:sp>
       <p:sp>
         <p:nvSpPr>
-          <p:cNvPr id="44" name="Shape 42"/>
-          <p:cNvSpPr/>
-          <p:nvPr/>
-        </p:nvSpPr>
-        <p:spPr>
-          <a:xfrm>
-            <a:off x="4126382" y="5358384"/>
+          <p:cNvPr id="45" name="Shape 43"/>
+          <p:cNvSpPr/>
+          <p:nvPr/>
+        </p:nvSpPr>
+        <p:spPr>
+          <a:xfrm>
+            <a:off x="4126382" y="5605272"/>
             <a:ext cx="214579" cy="0"/>
           </a:xfrm>
           <a:prstGeom prst="line">
@@ -3639,13 +3678,13 @@
       </p:sp>
       <p:sp>
         <p:nvSpPr>
-          <p:cNvPr id="45" name="Shape 43"/>
-          <p:cNvSpPr/>
-          <p:nvPr/>
-        </p:nvSpPr>
-        <p:spPr>
-          <a:xfrm>
-            <a:off x="4258666" y="5276088"/>
+          <p:cNvPr id="46" name="Shape 44"/>
+          <p:cNvSpPr/>
+          <p:nvPr/>
+        </p:nvSpPr>
+        <p:spPr>
+          <a:xfrm>
+            <a:off x="4258666" y="5522976"/>
             <a:ext cx="164592" cy="164592"/>
           </a:xfrm>
           <a:prstGeom prst="ellipse">
@@ -3664,13 +3703,13 @@
       </p:sp>
       <p:sp>
         <p:nvSpPr>
-          <p:cNvPr id="46" name="Shape 44"/>
-          <p:cNvSpPr/>
-          <p:nvPr/>
-        </p:nvSpPr>
-        <p:spPr>
-          <a:xfrm>
-            <a:off x="4034942" y="5266944"/>
+          <p:cNvPr id="47" name="Shape 45"/>
+          <p:cNvSpPr/>
+          <p:nvPr/>
+        </p:nvSpPr>
+        <p:spPr>
+          <a:xfrm>
+            <a:off x="4034942" y="5513832"/>
             <a:ext cx="182880" cy="182880"/>
           </a:xfrm>
           <a:prstGeom prst="ellipse">
@@ -3689,13 +3728,13 @@
       </p:sp>
       <p:sp>
         <p:nvSpPr>
-          <p:cNvPr id="47" name="Text 45"/>
-          <p:cNvSpPr/>
-          <p:nvPr/>
-        </p:nvSpPr>
-        <p:spPr>
-          <a:xfrm>
-            <a:off x="3154680" y="1371600"/>
+          <p:cNvPr id="48" name="Text 46"/>
+          <p:cNvSpPr/>
+          <p:nvPr/>
+        </p:nvSpPr>
+        <p:spPr>
+          <a:xfrm>
+            <a:off x="3154680" y="1691640"/>
             <a:ext cx="5029200" cy="320040"/>
           </a:xfrm>
           <a:prstGeom prst="rect">
@@ -3770,18 +3809,18 @@
       </p:sp>
       <p:sp>
         <p:nvSpPr>
-          <p:cNvPr id="48" name="Shape 46"/>
-          <p:cNvSpPr/>
-          <p:nvPr/>
-        </p:nvSpPr>
-        <p:spPr>
-          <a:xfrm>
-            <a:off x="5440680" y="4407408"/>
-            <a:ext cx="2011680" cy="502920"/>
+          <p:cNvPr id="49" name="Shape 47"/>
+          <p:cNvSpPr/>
+          <p:nvPr/>
+        </p:nvSpPr>
+        <p:spPr>
+          <a:xfrm>
+            <a:off x="5532120" y="3364992"/>
+            <a:ext cx="1783080" cy="777240"/>
           </a:xfrm>
           <a:prstGeom prst="roundRect">
             <a:avLst>
-              <a:gd name="adj" fmla="val 10909"/>
+              <a:gd name="adj" fmla="val 7059"/>
             </a:avLst>
           </a:prstGeom>
           <a:solidFill>
@@ -3797,14 +3836,14 @@
       </p:sp>
       <p:sp>
         <p:nvSpPr>
-          <p:cNvPr id="49" name="Text 47"/>
-          <p:cNvSpPr/>
-          <p:nvPr/>
-        </p:nvSpPr>
-        <p:spPr>
-          <a:xfrm>
-            <a:off x="5440680" y="4407408"/>
-            <a:ext cx="2011680" cy="502920"/>
+          <p:cNvPr id="50" name="Text 48"/>
+          <p:cNvSpPr/>
+          <p:nvPr/>
+        </p:nvSpPr>
+        <p:spPr>
+          <a:xfrm>
+            <a:off x="5532120" y="3364992"/>
+            <a:ext cx="1783080" cy="777240"/>
           </a:xfrm>
           <a:prstGeom prst="rect">
             <a:avLst/>
@@ -3828,21 +3867,38 @@
                 <a:ea typeface="Yu Gothic" pitchFamily="34" charset="-122"/>
                 <a:cs typeface="Yu Gothic" pitchFamily="34" charset="-120"/>
               </a:rPr>
-              <a:t>全9つで 15〜24% 減</a:t>
+              <a:t>全9つで</a:t>
             </a:r>
             <a:endParaRPr lang="en-US" sz="1600" dirty="0"/>
           </a:p>
+          <a:p>
+            <a:pPr algn="ctr" indent="0" marL="0">
+              <a:buNone/>
+            </a:pPr>
+            <a:r>
+              <a:rPr lang="en-US" sz="1600" b="1" dirty="0">
+                <a:solidFill>
+                  <a:srgbClr val="7A5200"/>
+                </a:solidFill>
+                <a:latin typeface="Yu Gothic" pitchFamily="34" charset="0"/>
+                <a:ea typeface="Yu Gothic" pitchFamily="34" charset="-122"/>
+                <a:cs typeface="Yu Gothic" pitchFamily="34" charset="-120"/>
+              </a:rPr>
+              <a:t>相対15〜24%減</a:t>
+            </a:r>
+            <a:endParaRPr lang="en-US" sz="1600" dirty="0"/>
+          </a:p>
         </p:txBody>
       </p:sp>
       <p:sp>
         <p:nvSpPr>
-          <p:cNvPr id="50" name="Text 48"/>
-          <p:cNvSpPr/>
-          <p:nvPr/>
-        </p:nvSpPr>
-        <p:spPr>
-          <a:xfrm>
-            <a:off x="7818120" y="1554480"/>
+          <p:cNvPr id="51" name="Text 49"/>
+          <p:cNvSpPr/>
+          <p:nvPr/>
+        </p:nvSpPr>
+        <p:spPr>
+          <a:xfrm>
+            <a:off x="7818120" y="2011680"/>
             <a:ext cx="3824935" cy="4206240"/>
           </a:xfrm>
           <a:prstGeom prst="rect">
@@ -3866,7 +3922,7 @@
               <a:buChar char="•"/>
             </a:pPr>
             <a:r>
-              <a:rPr lang="en-US" sz="2000" dirty="0">
+              <a:rPr lang="en-US" sz="2000" b="1" dirty="0">
                 <a:solidFill>
                   <a:srgbClr val="2D2D2D"/>
                 </a:solidFill>
@@ -3874,7 +3930,7 @@
                 <a:ea typeface="Yu Gothic" pitchFamily="34" charset="-122"/>
                 <a:cs typeface="Yu Gothic" pitchFamily="34" charset="-120"/>
               </a:rPr>
-              <a:t>大量の音声で事前学習した「音声を作るAI」を、喉マイクと普通のマイクの</a:t>
+              <a:t>音声を作るAI</a:t>
             </a:r>
             <a:pPr indent="0" marL="0">
               <a:lnSpc>
@@ -3886,7 +3942,7 @@
               <a:buNone/>
             </a:pPr>
             <a:r>
-              <a:rPr lang="en-US" sz="2000" b="1" dirty="0">
+              <a:rPr lang="en-US" sz="2000" dirty="0">
                 <a:solidFill>
                   <a:srgbClr val="2D2D2D"/>
                 </a:solidFill>
@@ -3894,7 +3950,7 @@
                 <a:ea typeface="Yu Gothic" pitchFamily="34" charset="-122"/>
                 <a:cs typeface="Yu Gothic" pitchFamily="34" charset="-120"/>
               </a:rPr>
-              <a:t>同時録音で調整</a:t>
+              <a:t>（大量の音声で事前学習済み）を、喉マイク用に同時録音で調整</a:t>
             </a:r>
             <a:endParaRPr lang="en-US" sz="2000" dirty="0"/>
           </a:p>
@@ -3912,13 +3968,33 @@
             <a:r>
               <a:rPr lang="en-US" sz="2000" b="1" dirty="0">
                 <a:solidFill>
+                  <a:srgbClr val="2E75B6"/>
+                </a:solidFill>
+                <a:latin typeface="Yu Gothic" pitchFamily="34" charset="0"/>
+                <a:ea typeface="Yu Gothic" pitchFamily="34" charset="-122"/>
+                <a:cs typeface="Yu Gothic" pitchFamily="34" charset="-120"/>
+              </a:rPr>
+              <a:t>入力が違う認識器</a:t>
+            </a:r>
+            <a:pPr indent="0" marL="0">
+              <a:lnSpc>
+                <a:spcPct val="120000"/>
+              </a:lnSpc>
+              <a:spcAft>
+                <a:spcPts val="1800"/>
+              </a:spcAft>
+              <a:buNone/>
+            </a:pPr>
+            <a:r>
+              <a:rPr lang="en-US" sz="2000" dirty="0">
+                <a:solidFill>
                   <a:srgbClr val="2D2D2D"/>
                 </a:solidFill>
                 <a:latin typeface="Yu Gothic" pitchFamily="34" charset="0"/>
                 <a:ea typeface="Yu Gothic" pitchFamily="34" charset="-122"/>
                 <a:cs typeface="Yu Gothic" pitchFamily="34" charset="-120"/>
               </a:rPr>
-              <a:t>音声認識は学習に使っていない</a:t>
+              <a:t>でも改善</a:t>
             </a:r>
             <a:endParaRPr lang="en-US" sz="2000" dirty="0"/>
           </a:p>
@@ -3990,7 +4066,7 @@
       </p:sp>
       <p:sp>
         <p:nvSpPr>
-          <p:cNvPr id="51" name="Text 49"/>
+          <p:cNvPr id="52" name="Text 50"/>
           <p:cNvSpPr/>
           <p:nvPr/>
         </p:nvSpPr>
@@ -4021,7 +4097,7 @@
                 <a:ea typeface="Yu Gothic" pitchFamily="34" charset="-122"/>
                 <a:cs typeface="Yu Gothic" pitchFamily="34" charset="-120"/>
               </a:rPr>
-              <a:t>テストデータで1回生成した分のみ（開発データ・再生成での確認は実行中）。Zipformer は空白込み。生成モデル: NVIDIA NeMo flow matching（Ku et al., arXiv:2409.16117）</a:t>
+              <a:t>生成は毎回少し変わるが、今はテストデータで1回生成した分のみ（再確認中）。生成モデル: NVIDIA NeMo（Ku et al., arXiv:2409.16117）</a:t>
             </a:r>
             <a:endParaRPr lang="en-US" sz="1200" dirty="0"/>
           </a:p>
@@ -4122,9 +4198,9 @@
               <a:tblPr/>
               <a:tblGrid>
                 <a:gridCol w="2377440"/>
+                <a:gridCol w="3017520"/>
                 <a:gridCol w="3108960"/>
-                <a:gridCol w="3291840"/>
-                <a:gridCol w="2316175"/>
+                <a:gridCol w="2590495"/>
               </a:tblGrid>
               <a:tr h="685800">
                 <a:tc>
@@ -4326,7 +4402,7 @@
                         <a:buNone/>
                       </a:pPr>
                       <a:r>
-                        <a:rPr lang="en-US" sz="1700" dirty="0">
+                        <a:rPr lang="en-US" sz="1500" dirty="0">
                           <a:solidFill>
                             <a:srgbClr val="2D2D2D"/>
                           </a:solidFill>
@@ -4334,9 +4410,9 @@
                           <a:ea typeface="Yu Gothic" pitchFamily="34" charset="-122"/>
                           <a:cs typeface="Yu Gothic" pitchFamily="34" charset="-120"/>
                         </a:rPr>
-                        <a:t>山中ら（東大, 2026）</a:t>
+                        <a:t>山中ら（東大 2026）</a:t>
                       </a:r>
-                      <a:endParaRPr lang="en-US" sz="1700" dirty="0">
+                      <a:endParaRPr lang="en-US" sz="1500" dirty="0">
                         <a:latin typeface="Yu Gothic" charset="0"/>
                         <a:ea typeface="Yu Gothic" charset="0"/>
                         <a:cs typeface="Yu Gothic" charset="0"/>
@@ -4373,7 +4449,7 @@
                         <a:buNone/>
                       </a:pPr>
                       <a:r>
-                        <a:rPr lang="en-US" sz="1700" dirty="0">
+                        <a:rPr lang="en-US" sz="1500" dirty="0">
                           <a:solidFill>
                             <a:srgbClr val="2D2D2D"/>
                           </a:solidFill>
@@ -4381,9 +4457,9 @@
                           <a:ea typeface="Yu Gothic" pitchFamily="34" charset="-122"/>
                           <a:cs typeface="Yu Gothic" pitchFamily="34" charset="-120"/>
                         </a:rPr>
-                        <a:t>喉マイク（TAPS・日本語）</a:t>
+                        <a:t>喉マイク（韓国語・日本語）</a:t>
                       </a:r>
-                      <a:endParaRPr lang="en-US" sz="1700" dirty="0">
+                      <a:endParaRPr lang="en-US" sz="1500" dirty="0">
                         <a:latin typeface="Yu Gothic" charset="0"/>
                         <a:ea typeface="Yu Gothic" charset="0"/>
                         <a:cs typeface="Yu Gothic" charset="0"/>
@@ -4420,7 +4496,7 @@
                         <a:buNone/>
                       </a:pPr>
                       <a:r>
-                        <a:rPr lang="en-US" sz="1700" dirty="0">
+                        <a:rPr lang="en-US" sz="1500" dirty="0">
                           <a:solidFill>
                             <a:srgbClr val="2D2D2D"/>
                           </a:solidFill>
@@ -4428,9 +4504,9 @@
                           <a:ea typeface="Yu Gothic" pitchFamily="34" charset="-122"/>
                           <a:cs typeface="Yu Gothic" pitchFamily="34" charset="-120"/>
                         </a:rPr>
-                        <a:t>普通のマイクらしい音へ</a:t>
+                        <a:t>普通のマイクらしい音に変換</a:t>
                       </a:r>
-                      <a:endParaRPr lang="en-US" sz="1700" dirty="0">
+                      <a:endParaRPr lang="en-US" sz="1500" dirty="0">
                         <a:latin typeface="Yu Gothic" charset="0"/>
                         <a:ea typeface="Yu Gothic" charset="0"/>
                         <a:cs typeface="Yu Gothic" charset="0"/>
@@ -4467,7 +4543,7 @@
                         <a:buNone/>
                       </a:pPr>
                       <a:r>
-                        <a:rPr lang="en-US" sz="1700" b="1" dirty="0">
+                        <a:rPr lang="en-US" sz="1500" b="1" dirty="0">
                           <a:solidFill>
                             <a:srgbClr val="C55A11"/>
                           </a:solidFill>
@@ -4477,7 +4553,7 @@
                         </a:rPr>
                         <a:t>どの方法でも増加</a:t>
                       </a:r>
-                      <a:endParaRPr lang="en-US" sz="1700" dirty="0">
+                      <a:endParaRPr lang="en-US" sz="1500" dirty="0">
                         <a:latin typeface="Yu Gothic" charset="0"/>
                         <a:ea typeface="Yu Gothic" charset="0"/>
                         <a:cs typeface="Yu Gothic" charset="0"/>
@@ -4516,7 +4592,7 @@
                         <a:buNone/>
                       </a:pPr>
                       <a:r>
-                        <a:rPr lang="en-US" sz="1700" dirty="0">
+                        <a:rPr lang="en-US" sz="1500" dirty="0">
                           <a:solidFill>
                             <a:srgbClr val="2D2D2D"/>
                           </a:solidFill>
@@ -4526,7 +4602,7 @@
                         </a:rPr>
                         <a:t>Sato ら（2025）</a:t>
                       </a:r>
-                      <a:endParaRPr lang="en-US" sz="1700" dirty="0">
+                      <a:endParaRPr lang="en-US" sz="1500" dirty="0">
                         <a:latin typeface="Yu Gothic" charset="0"/>
                         <a:ea typeface="Yu Gothic" charset="0"/>
                         <a:cs typeface="Yu Gothic" charset="0"/>
@@ -4563,7 +4639,7 @@
                         <a:buNone/>
                       </a:pPr>
                       <a:r>
-                        <a:rPr lang="en-US" sz="1700" dirty="0">
+                        <a:rPr lang="en-US" sz="1500" dirty="0">
                           <a:solidFill>
                             <a:srgbClr val="2D2D2D"/>
                           </a:solidFill>
@@ -4573,7 +4649,7 @@
                         </a:rPr>
                         <a:t>普通のマイクの雑音</a:t>
                       </a:r>
-                      <a:endParaRPr lang="en-US" sz="1700" dirty="0">
+                      <a:endParaRPr lang="en-US" sz="1500" dirty="0">
                         <a:latin typeface="Yu Gothic" charset="0"/>
                         <a:ea typeface="Yu Gothic" charset="0"/>
                         <a:cs typeface="Yu Gothic" charset="0"/>
@@ -4610,7 +4686,7 @@
                         <a:buNone/>
                       </a:pPr>
                       <a:r>
-                        <a:rPr lang="en-US" sz="1700" dirty="0">
+                        <a:rPr lang="en-US" sz="1500" dirty="0">
                           <a:solidFill>
                             <a:srgbClr val="2D2D2D"/>
                           </a:solidFill>
@@ -4620,7 +4696,7 @@
                         </a:rPr>
                         <a:t>認識器に頼らない音声強調</a:t>
                       </a:r>
-                      <a:endParaRPr lang="en-US" sz="1700" dirty="0">
+                      <a:endParaRPr lang="en-US" sz="1500" dirty="0">
                         <a:latin typeface="Yu Gothic" charset="0"/>
                         <a:ea typeface="Yu Gothic" charset="0"/>
                         <a:cs typeface="Yu Gothic" charset="0"/>
@@ -4657,7 +4733,7 @@
                         <a:buNone/>
                       </a:pPr>
                       <a:r>
-                        <a:rPr lang="en-US" sz="1700" dirty="0">
+                        <a:rPr lang="en-US" sz="1500" dirty="0">
                           <a:solidFill>
                             <a:srgbClr val="2D2D2D"/>
                           </a:solidFill>
@@ -4667,7 +4743,7 @@
                         </a:rPr>
                         <a:t>複数の認識器で減少</a:t>
                       </a:r>
-                      <a:endParaRPr lang="en-US" sz="1700" dirty="0">
+                      <a:endParaRPr lang="en-US" sz="1500" dirty="0">
                         <a:latin typeface="Yu Gothic" charset="0"/>
                         <a:ea typeface="Yu Gothic" charset="0"/>
                         <a:cs typeface="Yu Gothic" charset="0"/>
@@ -4706,7 +4782,7 @@
                         <a:buNone/>
                       </a:pPr>
                       <a:r>
-                        <a:rPr lang="en-US" sz="1700" b="1" dirty="0">
+                        <a:rPr lang="en-US" sz="1500" b="1" dirty="0">
                           <a:solidFill>
                             <a:srgbClr val="1F4E79"/>
                           </a:solidFill>
@@ -4716,7 +4792,7 @@
                         </a:rPr>
                         <a:t>本研究</a:t>
                       </a:r>
-                      <a:endParaRPr lang="en-US" sz="1700" dirty="0">
+                      <a:endParaRPr lang="en-US" sz="1500" dirty="0">
                         <a:latin typeface="Yu Gothic" charset="0"/>
                         <a:ea typeface="Yu Gothic" charset="0"/>
                         <a:cs typeface="Yu Gothic" charset="0"/>
@@ -4753,7 +4829,7 @@
                         <a:buNone/>
                       </a:pPr>
                       <a:r>
-                        <a:rPr lang="en-US" sz="1700" dirty="0">
+                        <a:rPr lang="en-US" sz="1500" dirty="0">
                           <a:solidFill>
                             <a:srgbClr val="2D2D2D"/>
                           </a:solidFill>
@@ -4761,9 +4837,9 @@
                           <a:ea typeface="Yu Gothic" pitchFamily="34" charset="-122"/>
                           <a:cs typeface="Yu Gothic" pitchFamily="34" charset="-120"/>
                         </a:rPr>
-                        <a:t>喉マイク（TAPS）</a:t>
+                        <a:t>喉マイク（韓国語）</a:t>
                       </a:r>
-                      <a:endParaRPr lang="en-US" sz="1700" dirty="0">
+                      <a:endParaRPr lang="en-US" sz="1500" dirty="0">
                         <a:latin typeface="Yu Gothic" charset="0"/>
                         <a:ea typeface="Yu Gothic" charset="0"/>
                         <a:cs typeface="Yu Gothic" charset="0"/>
@@ -4800,7 +4876,7 @@
                         <a:buNone/>
                       </a:pPr>
                       <a:r>
-                        <a:rPr lang="en-US" sz="1700" dirty="0">
+                        <a:rPr lang="en-US" sz="1500" dirty="0">
                           <a:solidFill>
                             <a:srgbClr val="2D2D2D"/>
                           </a:solidFill>
@@ -4808,9 +4884,9 @@
                           <a:ea typeface="Yu Gothic" pitchFamily="34" charset="-122"/>
                           <a:cs typeface="Yu Gothic" pitchFamily="34" charset="-120"/>
                         </a:rPr>
-                        <a:t>どの音声認識でも誤りを減らす</a:t>
+                        <a:t>どの認識器でも誤りを減らす</a:t>
                       </a:r>
-                      <a:endParaRPr lang="en-US" sz="1700" dirty="0">
+                      <a:endParaRPr lang="en-US" sz="1500" dirty="0">
                         <a:latin typeface="Yu Gothic" charset="0"/>
                         <a:ea typeface="Yu Gothic" charset="0"/>
                         <a:cs typeface="Yu Gothic" charset="0"/>
@@ -4847,7 +4923,7 @@
                         <a:buNone/>
                       </a:pPr>
                       <a:r>
-                        <a:rPr lang="en-US" sz="1700" b="1" dirty="0">
+                        <a:rPr lang="en-US" sz="1500" b="1" dirty="0">
                           <a:solidFill>
                             <a:srgbClr val="1F4E79"/>
                           </a:solidFill>
@@ -4855,9 +4931,30 @@
                           <a:ea typeface="Yu Gothic" pitchFamily="34" charset="-122"/>
                           <a:cs typeface="Yu Gothic" pitchFamily="34" charset="-120"/>
                         </a:rPr>
-                        <a:t>入力の違う9つすべてで減少</a:t>
+                        <a:t>9つすべてで減少</a:t>
                       </a:r>
-                      <a:endParaRPr lang="en-US" sz="1700" dirty="0">
+                      <a:endParaRPr lang="en-US" sz="1500" dirty="0">
+                        <a:latin typeface="Yu Gothic" charset="0"/>
+                        <a:ea typeface="Yu Gothic" charset="0"/>
+                        <a:cs typeface="Yu Gothic" charset="0"/>
+                      </a:endParaRPr>
+                    </a:p>
+                    <a:p>
+                      <a:pPr indent="0" marL="0">
+                        <a:buNone/>
+                      </a:pPr>
+                      <a:r>
+                        <a:rPr lang="en-US" sz="1500" b="1" dirty="0">
+                          <a:solidFill>
+                            <a:srgbClr val="1F4E79"/>
+                          </a:solidFill>
+                          <a:latin typeface="Yu Gothic" pitchFamily="34" charset="0"/>
+                          <a:ea typeface="Yu Gothic" pitchFamily="34" charset="-122"/>
+                          <a:cs typeface="Yu Gothic" pitchFamily="34" charset="-120"/>
+                        </a:rPr>
+                        <a:t>（入力の違う認識器も）</a:t>
+                      </a:r>
+                      <a:endParaRPr lang="en-US" sz="1500" dirty="0">
                         <a:latin typeface="Yu Gothic" charset="0"/>
                         <a:ea typeface="Yu Gothic" charset="0"/>
                         <a:cs typeface="Yu Gothic" charset="0"/>
@@ -4991,7 +5088,7 @@
                 <a:ea typeface="Yu Gothic" pitchFamily="34" charset="-122"/>
                 <a:cs typeface="Yu Gothic" pitchFamily="34" charset="-120"/>
               </a:rPr>
-              <a:t>山中ら, 日本音響学会 2026年秋 1-Q-42（誤り率は気導音の書き起こしを基準とし、本研究とは測り方が異なる）／Sato et al., arXiv:2507.07631／他: 和田ら 1-Q-56</a:t>
+              <a:t>山中ら: 日本音響学会 2026年秋 1-Q-42（誤り率の基準が本研究と異なる）／Sato et al., arXiv:2507.07631</a:t>
             </a:r>
             <a:endParaRPr lang="en-US" sz="1200" dirty="0"/>
           </a:p>
@@ -5076,7 +5173,7 @@
         </p:nvSpPr>
         <p:spPr>
           <a:xfrm>
-            <a:off x="548640" y="1600200"/>
+            <a:off x="548640" y="1645920"/>
             <a:ext cx="3291840" cy="822960"/>
           </a:xfrm>
           <a:prstGeom prst="rect">
@@ -5115,7 +5212,7 @@
         </p:nvSpPr>
         <p:spPr>
           <a:xfrm>
-            <a:off x="4023360" y="1600200"/>
+            <a:off x="4023360" y="1645920"/>
             <a:ext cx="7619695" cy="822960"/>
           </a:xfrm>
           <a:prstGeom prst="rect">
@@ -5140,7 +5237,7 @@
                 <a:ea typeface="Yu Gothic" pitchFamily="34" charset="-122"/>
                 <a:cs typeface="Yu Gothic" pitchFamily="34" charset="-120"/>
               </a:rPr>
-              <a:t>大量の音声での事前学習のおかげか、モデルが大きい（元の約35倍）だけか</a:t>
+              <a:t>事前学習のおかげか、単にモデルが大きい（約35倍）からか</a:t>
             </a:r>
             <a:endParaRPr lang="en-US" sz="2000" dirty="0"/>
           </a:p>
@@ -5154,7 +5251,7 @@
         </p:nvSpPr>
         <p:spPr>
           <a:xfrm>
-            <a:off x="548640" y="2560320"/>
+            <a:off x="548640" y="2651760"/>
             <a:ext cx="11094415" cy="0"/>
           </a:xfrm>
           <a:prstGeom prst="line">
@@ -5177,7 +5274,7 @@
         </p:nvSpPr>
         <p:spPr>
           <a:xfrm>
-            <a:off x="548640" y="2697480"/>
+            <a:off x="548640" y="2834640"/>
             <a:ext cx="3291840" cy="822960"/>
           </a:xfrm>
           <a:prstGeom prst="rect">
@@ -5216,7 +5313,7 @@
         </p:nvSpPr>
         <p:spPr>
           <a:xfrm>
-            <a:off x="4023360" y="2697480"/>
+            <a:off x="4023360" y="2834640"/>
             <a:ext cx="7619695" cy="822960"/>
           </a:xfrm>
           <a:prstGeom prst="rect">
@@ -5241,7 +5338,7 @@
                 <a:ea typeface="Yu Gothic" pitchFamily="34" charset="-122"/>
                 <a:cs typeface="Yu Gothic" pitchFamily="34" charset="-120"/>
               </a:rPr>
-              <a:t>テストデータで1回生成しただけ。先行研究の方法との同条件比較もまだ</a:t>
+              <a:t>1回生成しただけ。Sato らの方法との同条件比較もまだ</a:t>
             </a:r>
             <a:endParaRPr lang="en-US" sz="2000" dirty="0"/>
           </a:p>
@@ -5255,7 +5352,7 @@
         </p:nvSpPr>
         <p:spPr>
           <a:xfrm>
-            <a:off x="548640" y="3657600"/>
+            <a:off x="548640" y="3840480"/>
             <a:ext cx="11094415" cy="0"/>
           </a:xfrm>
           <a:prstGeom prst="line">
@@ -5278,7 +5375,7 @@
         </p:nvSpPr>
         <p:spPr>
           <a:xfrm>
-            <a:off x="548640" y="3794760"/>
+            <a:off x="548640" y="4023360"/>
             <a:ext cx="3291840" cy="822960"/>
           </a:xfrm>
           <a:prstGeom prst="rect">
@@ -5317,7 +5414,7 @@
         </p:nvSpPr>
         <p:spPr>
           <a:xfrm>
-            <a:off x="4023360" y="3794760"/>
+            <a:off x="4023360" y="4023360"/>
             <a:ext cx="7619695" cy="822960"/>
           </a:xfrm>
           <a:prstGeom prst="rect">
@@ -5342,7 +5439,7 @@
                 <a:ea typeface="Yu Gothic" pitchFamily="34" charset="-122"/>
                 <a:cs typeface="Yu Gothic" pitchFamily="34" charset="-120"/>
               </a:rPr>
-              <a:t>データセット1つ・喉マイク1種類でしか確かめていない</a:t>
+              <a:t>韓国語のデータ・喉マイク1種類でしか確かめていない</a:t>
             </a:r>
             <a:endParaRPr lang="en-US" sz="2000" dirty="0"/>
           </a:p>
@@ -5356,7 +5453,7 @@
         </p:nvSpPr>
         <p:spPr>
           <a:xfrm>
-            <a:off x="548640" y="4754880"/>
+            <a:off x="548640" y="5029200"/>
             <a:ext cx="11094415" cy="0"/>
           </a:xfrm>
           <a:prstGeom prst="line">
@@ -5379,7 +5476,7 @@
         </p:nvSpPr>
         <p:spPr>
           <a:xfrm>
-            <a:off x="548640" y="4892040"/>
+            <a:off x="548640" y="5212080"/>
             <a:ext cx="3291840" cy="822960"/>
           </a:xfrm>
           <a:prstGeom prst="rect">
@@ -5418,7 +5515,7 @@
         </p:nvSpPr>
         <p:spPr>
           <a:xfrm>
-            <a:off x="4023360" y="4892040"/>
+            <a:off x="4023360" y="5212080"/>
             <a:ext cx="7619695" cy="822960"/>
           </a:xfrm>
           <a:prstGeom prst="rect">
@@ -5443,7 +5540,7 @@
                 <a:ea typeface="Yu Gothic" pitchFamily="34" charset="-122"/>
                 <a:cs typeface="Yu Gothic" pitchFamily="34" charset="-120"/>
               </a:rPr>
-              <a:t>公開モデルを調整しただけで、手法としての新しさがない</a:t>
+              <a:t>公開モデルを調整しただけ（非商用ライセンス・計算が重い）</a:t>
             </a:r>
             <a:endParaRPr lang="en-US" sz="2000" dirty="0"/>
           </a:p>
@@ -5547,7 +5644,7 @@
                 <a:gridCol w="1188720"/>
                 <a:gridCol w="8168335"/>
               </a:tblGrid>
-              <a:tr h="868680">
+              <a:tr h="1051560">
                 <a:tc>
                   <a:txBody>
                     <a:bodyPr/>
@@ -5690,7 +5787,7 @@
                   </a:tcPr>
                 </a:tc>
               </a:tr>
-              <a:tr h="868680">
+              <a:tr h="1051560">
                 <a:tc>
                   <a:txBody>
                     <a:bodyPr/>
@@ -5802,7 +5899,28 @@
                           <a:ea typeface="Yu Gothic" pitchFamily="34" charset="-122"/>
                           <a:cs typeface="Yu Gothic" pitchFamily="34" charset="-120"/>
                         </a:rPr>
-                        <a:t>事前学習なしで同じモデルを学習して比較／開発データ・生成し直しで再確認</a:t>
+                        <a:t>事前学習なしのモデルと比較</a:t>
+                      </a:r>
+                      <a:endParaRPr lang="en-US" sz="1800" dirty="0">
+                        <a:latin typeface="Yu Gothic" charset="0"/>
+                        <a:ea typeface="Yu Gothic" charset="0"/>
+                        <a:cs typeface="Yu Gothic" charset="0"/>
+                      </a:endParaRPr>
+                    </a:p>
+                    <a:p>
+                      <a:pPr indent="0" marL="0">
+                        <a:buNone/>
+                      </a:pPr>
+                      <a:r>
+                        <a:rPr lang="en-US" sz="1800" dirty="0">
+                          <a:solidFill>
+                            <a:srgbClr val="2D2D2D"/>
+                          </a:solidFill>
+                          <a:latin typeface="Yu Gothic" pitchFamily="34" charset="0"/>
+                          <a:ea typeface="Yu Gothic" pitchFamily="34" charset="-122"/>
+                          <a:cs typeface="Yu Gothic" pitchFamily="34" charset="-120"/>
+                        </a:rPr>
+                        <a:t>生成し直し・開発データで再確認</a:t>
                       </a:r>
                       <a:endParaRPr lang="en-US" sz="1800" dirty="0">
                         <a:latin typeface="Yu Gothic" charset="0"/>
@@ -5833,7 +5951,7 @@
                   </a:tcPr>
                 </a:tc>
               </a:tr>
-              <a:tr h="868680">
+              <a:tr h="1051560">
                 <a:tc>
                   <a:txBody>
                     <a:bodyPr/>
@@ -5945,7 +6063,7 @@
                           <a:ea typeface="Yu Gothic" pitchFamily="34" charset="-122"/>
                           <a:cs typeface="Yu Gothic" pitchFamily="34" charset="-120"/>
                         </a:rPr>
-                        <a:t>別の喉マイク（仏語の公開データ VibraVox）で検証</a:t>
+                        <a:t>別の喉マイクで検証（仏語の公開データ VibraVox。言語も変わる）</a:t>
                       </a:r>
                       <a:endParaRPr lang="en-US" sz="1800" dirty="0">
                         <a:latin typeface="Yu Gothic" charset="0"/>
@@ -5976,7 +6094,7 @@
                   </a:tcPr>
                 </a:tc>
               </a:tr>
-              <a:tr h="868680">
+              <a:tr h="1051560">
                 <a:tc>
                   <a:txBody>
                     <a:bodyPr/>
@@ -6088,7 +6206,28 @@
                           <a:ea typeface="Yu Gothic" pitchFamily="34" charset="-122"/>
                           <a:cs typeface="Yu Gothic" pitchFamily="34" charset="-120"/>
                         </a:rPr>
-                        <a:t>マイクの情報を手がかりに少ないデータで別のマイクへ対応／生成を複数回行って平均し安定化</a:t>
+                        <a:t>マイクの情報を手がかりに、少ないデータで別のマイクへ対応</a:t>
+                      </a:r>
+                      <a:endParaRPr lang="en-US" sz="1800" dirty="0">
+                        <a:latin typeface="Yu Gothic" charset="0"/>
+                        <a:ea typeface="Yu Gothic" charset="0"/>
+                        <a:cs typeface="Yu Gothic" charset="0"/>
+                      </a:endParaRPr>
+                    </a:p>
+                    <a:p>
+                      <a:pPr indent="0" marL="0">
+                        <a:buNone/>
+                      </a:pPr>
+                      <a:r>
+                        <a:rPr lang="en-US" sz="1800" dirty="0">
+                          <a:solidFill>
+                            <a:srgbClr val="2D2D2D"/>
+                          </a:solidFill>
+                          <a:latin typeface="Yu Gothic" pitchFamily="34" charset="0"/>
+                          <a:ea typeface="Yu Gothic" pitchFamily="34" charset="-122"/>
+                          <a:cs typeface="Yu Gothic" pitchFamily="34" charset="-120"/>
+                        </a:rPr>
+                        <a:t>生成を複数回行って平均し、誤りを安定して減らす</a:t>
                       </a:r>
                       <a:endParaRPr lang="en-US" sz="1800" dirty="0">
                         <a:latin typeface="Yu Gothic" charset="0"/>
@@ -6600,7 +6739,7 @@
                 <a:ea typeface="Yu Gothic" pitchFamily="34" charset="-122"/>
                 <a:cs typeface="Yu Gothic" pitchFamily="34" charset="-120"/>
               </a:rPr>
-              <a:t>Y. Kim et al., “Throat and acoustic paired speech dataset for deep learning-based speech enhancement,” Scientific Data, 2026.（TAPS）</a:t>
+              <a:t>TAPS: Y. Kim et al., “Throat and acoustic paired speech dataset for deep learning-based speech enhancement,” Scientific Data, 2026.</a:t>
             </a:r>
             <a:endParaRPr lang="en-US" sz="1400" dirty="0"/>
           </a:p>

</xml_diff>

<commit_message>
Slides 2026-10: rewrite plan (ASR-oriented generation, then distillation); drop summary slide; challenge 3 = other datasets
Co-Authored-By: Claude Opus 5.5 (1M context) <noreply@anthropic.com>
</commit_message>
<xml_diff>
--- a/results/progress_slides_2026-10.pptx
+++ b/results/progress_slides_2026-10.pptx
@@ -13,10 +13,9 @@
     <p:sldId id="261" r:id="rId7"/>
     <p:sldId id="262" r:id="rId8"/>
     <p:sldId id="263" r:id="rId9"/>
-    <p:sldId id="264" r:id="rId10"/>
   </p:sldIdLst>
   <p:notesMasterIdLst>
-    <p:notesMasterId r:id="rId11"/>
+    <p:notesMasterId r:id="rId10"/>
   </p:notesMasterIdLst>
   <p:sldSz cx="12192000" cy="6858000"/>
   <p:notesSz cx="6858000" cy="12192000"/>
@@ -840,7 +839,7 @@
             <a:r>
               <a:rPr lang="en-US" dirty="0"/>
               <a:t>【台本】（約10秒）
-進捗を報告します。今日は、予備実験の結果と、関連研究、そこから見えた課題、これからの方針を話します。</a:t>
+進捗を報告します。今日は、予備実験の結果と課題、これからの方針を中心に話します。</a:t>
             </a:r>
             <a:endParaRPr lang="en-US" dirty="0"/>
           </a:p>
@@ -1212,8 +1211,7 @@
             <a:r>
               <a:rPr lang="en-US" dirty="0"/>
               <a:t>【台本】（約60秒）
-関連研究です。一番近いのは、今回の音響学会で東大の山中さんたちが発表した研究で、同じTAPSのデータを使っています。声質変換などで喉マイクの音を普通のマイクの音に近づけていて、聞こえは良くなりますが、音声認識の誤りはどの方法でも増えていました。聞こえを良くしても認識は良くならない点は、私の卒論の結果と同じです。
-一方、向こうは別の喉マイクや日本語でも確かめていて、同時録音のデータも要りません。ここは私に足りない点です。
+関連研究です。一番近いのは、今回の音響学会で東大の山中さんたちが発表した研究で、同じTAPSのデータを使っています。声質変換などで喉マイクの音を普通のマイクの音に近づけていて、聞こえは良くなりますが、音声認識の誤りはどの方法でも増えていました。一方、向こうは別の喉マイクや日本語でも確かめていて、同時録音のデータも要りません。ここは私に足りない点です。
 喉マイクで、入力の違う複数の音声認識で誤りが減るかを確かめた例は、調べた範囲では見当たりません。
 【補足】山中ら：無処理0.233、Sidon 0.308、Kanade(ft) 0.550。和田ら（神戸大・三菱電機）：喉マイクの感情認識でも汎用の雑音除去で悪化。</a:t>
             </a:r>
@@ -1307,7 +1305,7 @@
 課題は4つです。
 ①なぜ効いたのかが、まだ分かっていません。大量の音声での事前学習が効いたのか、単にモデルが大きいからなのかを切り分ける必要があります。
 ②結果が確かかどうか。今の結果はテストデータで1回生成しただけなので、開発データや生成し直した場合でも同じになるか、先行研究の方法と同じ条件で比べる必要があります。
-③別のマイクで効くか。今は1つのデータセット、1種類の喉マイクでしか確かめていません。
+③他のデータでも効くか。今は韓国語のTAPSという1つのデータセットでしか確かめていません。
 ④一番大きいのがこれで、今は公開されているモデルを調整しただけなので、手法としての新しさがありません。
 【補足】生成モデル：4.3億パラメータ、非商用ライセンス（CC-BY-NC-SA）。元の音声強調は1200万パラメータ。1発話の変換に20段階の計算。事前学習なしの対照実験は研究室PCの停止で中断中。</a:t>
             </a:r>
@@ -1397,11 +1395,12 @@
           <a:p>
             <a:r>
               <a:rPr lang="en-US" dirty="0"/>
-              <a:t>【台本】（約45秒）
-これからの方針です。まず1週間ほどで、課題①②の確認をします。事前学習なしで同じモデルを学習して比べることと、開発データや生成し直しでの再確認です。
-次の1週間で、③別のマイクで効くかを、フランス語の公開データで確かめます。
-その先で、④手法としての工夫を入れます。候補はここに挙げた2つです。
-【補足】比較手法として汎用の音声復元ツール（Sidon）と Sato ら型も同条件で評価し、処理時間も測る。VibraVox はマイクと言語が同時に変わるため、切り分けには日本語の自前収録が有効（相談1の理由）。</a:t>
+              <a:t>【台本】（約55秒）
+これからの方針です。
+まず、課題①②の確認として、事前学習なしの同じモデルと比べ、生成し直しや開発データ、別のデータセットでも同じ結果になるかを確かめます。
+そのうえで中心にしたいのが、認識に向いた生成のさせ方です。今は、砂嵐のようなランダムな状態から1回だけ描き直していて、描くたびに少しずつ違う音になります。誤りが増えた発話も、音の取り違えでした。そこで、何回か生成して平均したり、互いに一番似た候補を選んだり、砂嵐ではなく元の音声強調の出力から描き始めたりして、内容を取り違えにくくします。どれも今のモデルのまま、認識器を使わずに試せます。
+最後に、見つけた出し方の出力を正解にして、軽い音声強調へ蒸留し、実用的な速さにしたいと考えています。以上です。
+【補足】互いに一番似た候補を選ぶ＝最小ベイズリスク選択（類似度は認識器に依存しない音声特徴で測る）。蒸留の正解は、生成モデルが学習で見ていない喉マイク音声（VibraVox のラベルなし約9時間）で作る（以前、学習データの丸暗記で蒸留が失敗したため）。VibraVox は結果の確認に使うだけで、マイクへの適応はしない。</a:t>
             </a:r>
             <a:endParaRPr lang="en-US" dirty="0"/>
           </a:p>
@@ -1489,9 +1488,7 @@
           <a:p>
             <a:r>
               <a:rPr lang="en-US" dirty="0"/>
-              <a:t>【台本】（約25秒）
-まとめると、Whisperに合わせた音声強調は他の認識器で逆効果でしたが、生成モデルを喉マイクに合わせると、9つの音声認識すべてで誤りが減りました。ただ、その理由や確かさはこれから確かめます。
-最後に、ここに挙げた3つについてご意見をいただけると助かります。以上です。</a:t>
+              <a:t/>
             </a:r>
             <a:endParaRPr lang="en-US" dirty="0"/>
           </a:p>
@@ -1515,94 +1512,6 @@
             <a:fld id="{F7021451-1387-4CA6-816F-3879F97B5CBC}" type="slidenum">
               <a:rPr lang="en-US"/>
               <a:t>8</a:t>
-            </a:fld>
-            <a:endParaRPr lang="en-US"/>
-          </a:p>
-        </p:txBody>
-      </p:sp>
-    </p:spTree>
-    <p:extLst>
-      <p:ext uri="{BB962C8B-B14F-4D97-AF65-F5344CB8AC3E}">
-        <p14:creationId xmlns:p14="http://schemas.microsoft.com/office/powerpoint/2010/main" val="1024086991"/>
-      </p:ext>
-    </p:extLst>
-  </p:cSld>
-  <p:clrMapOvr>
-    <a:masterClrMapping/>
-  </p:clrMapOvr>
-</p:notes>
-</file>
-
-<file path=ppt/notesSlides/notesSlide9.xml><?xml version="1.0" encoding="utf-8"?>
-<p:notes xmlns:a="http://schemas.openxmlformats.org/drawingml/2006/main" xmlns:r="http://schemas.openxmlformats.org/officeDocument/2006/relationships" xmlns:p="http://schemas.openxmlformats.org/presentationml/2006/main">
-  <p:cSld>
-    <p:spTree>
-      <p:nvGrpSpPr>
-        <p:cNvPr id="1" name=""/>
-        <p:cNvGrpSpPr/>
-        <p:nvPr/>
-      </p:nvGrpSpPr>
-      <p:grpSpPr>
-        <a:xfrm>
-          <a:off x="0" y="0"/>
-          <a:ext cx="0" cy="0"/>
-          <a:chOff x="0" y="0"/>
-          <a:chExt cx="0" cy="0"/>
-        </a:xfrm>
-      </p:grpSpPr>
-      <p:sp>
-        <p:nvSpPr>
-          <p:cNvPr id="2" name="Slide Image Placeholder 1"/>
-          <p:cNvSpPr>
-            <a:spLocks noGrp="1" noRot="1" noChangeAspect="1"/>
-          </p:cNvSpPr>
-          <p:nvPr>
-            <p:ph type="sldImg"/>
-          </p:nvPr>
-        </p:nvSpPr>
-        <p:spPr/>
-      </p:sp>
-      <p:sp>
-        <p:nvSpPr>
-          <p:cNvPr id="3" name="Notes Placeholder 2"/>
-          <p:cNvSpPr>
-            <a:spLocks noGrp="1"/>
-          </p:cNvSpPr>
-          <p:nvPr>
-            <p:ph type="body" idx="1"/>
-          </p:nvPr>
-        </p:nvSpPr>
-        <p:spPr/>
-        <p:txBody>
-          <a:bodyPr/>
-          <a:lstStyle/>
-          <a:p>
-            <a:r>
-              <a:rPr lang="en-US" dirty="0"/>
-              <a:t/>
-            </a:r>
-            <a:endParaRPr lang="en-US" dirty="0"/>
-          </a:p>
-        </p:txBody>
-      </p:sp>
-      <p:sp>
-        <p:nvSpPr>
-          <p:cNvPr id="4" name="Slide Number Placeholder 3"/>
-          <p:cNvSpPr>
-            <a:spLocks noGrp="1"/>
-          </p:cNvSpPr>
-          <p:nvPr>
-            <p:ph type="sldNum" sz="quarter" idx="10"/>
-          </p:nvPr>
-        </p:nvSpPr>
-        <p:spPr/>
-        <p:txBody>
-          <a:bodyPr/>
-          <a:lstStyle/>
-          <a:p>
-            <a:fld id="{F7021451-1387-4CA6-816F-3879F97B5CBC}" type="slidenum">
-              <a:rPr lang="en-US"/>
-              <a:t>9</a:t>
             </a:fld>
             <a:endParaRPr lang="en-US"/>
           </a:p>
@@ -6392,7 +6301,7 @@
                 <a:ea typeface="Yu Gothic" pitchFamily="34" charset="-122"/>
                 <a:cs typeface="Yu Gothic" pitchFamily="34" charset="-120"/>
               </a:rPr>
-              <a:t>効果は大きいが、理由・確かさ・別のマイクでの効果・新しさが課題</a:t>
+              <a:t>効果は大きいが、理由・確かさ・他のデータでの効果・新しさが課題</a:t>
             </a:r>
             <a:endParaRPr lang="en-US" sz="2800" dirty="0"/>
           </a:p>
@@ -6633,7 +6542,7 @@
                 <a:ea typeface="Yu Gothic" pitchFamily="34" charset="-122"/>
                 <a:cs typeface="Yu Gothic" pitchFamily="34" charset="-120"/>
               </a:rPr>
-              <a:t>③ 別のマイクで効くか</a:t>
+              <a:t>③ 他のデータでも効くか</a:t>
             </a:r>
             <a:endParaRPr lang="en-US" sz="2200" dirty="0"/>
           </a:p>
@@ -6672,7 +6581,7 @@
                 <a:ea typeface="Yu Gothic" pitchFamily="34" charset="-122"/>
                 <a:cs typeface="Yu Gothic" pitchFamily="34" charset="-120"/>
               </a:rPr>
-              <a:t>韓国語のデータ・喉マイク1種類でしか確かめていない</a:t>
+              <a:t>1つのデータセット（韓国語 TAPS）でしか確かめていない</a:t>
             </a:r>
             <a:endParaRPr lang="en-US" sz="2000" dirty="0"/>
           </a:p>
@@ -6773,7 +6682,7 @@
                 <a:ea typeface="Yu Gothic" pitchFamily="34" charset="-122"/>
                 <a:cs typeface="Yu Gothic" pitchFamily="34" charset="-120"/>
               </a:rPr>
-              <a:t>公開モデルを調整しただけ（非商用ライセンス・計算が重い）</a:t>
+              <a:t>公開モデルを調整しただけ（計算も重い）</a:t>
             </a:r>
             <a:endParaRPr lang="en-US" sz="2000" dirty="0"/>
           </a:p>
@@ -6844,7 +6753,7 @@
                 <a:ea typeface="Yu Gothic" pitchFamily="34" charset="-122"/>
                 <a:cs typeface="Yu Gothic" pitchFamily="34" charset="-120"/>
               </a:rPr>
-              <a:t>まず結果を確かめ、そのうえで手法の工夫に進む</a:t>
+              <a:t>次は、認識に向いた生成のさせ方を探し、最後に軽くする</a:t>
             </a:r>
             <a:endParaRPr lang="en-US" sz="2800" dirty="0"/>
           </a:p>
@@ -6865,7 +6774,7 @@
           </p:nvPr>
         </p:nvGraphicFramePr>
         <p:xfrm>
-          <a:off x="548640" y="1645920"/>
+          <a:off x="548640" y="1600200"/>
           <a:ext cx="11094415" cy="914400"/>
         </p:xfrm>
         <a:graphic>
@@ -6873,11 +6782,11 @@
             <a:tbl>
               <a:tblPr/>
               <a:tblGrid>
-                <a:gridCol w="1737360"/>
-                <a:gridCol w="1188720"/>
-                <a:gridCol w="8168335"/>
+                <a:gridCol w="2468880"/>
+                <a:gridCol w="1920240"/>
+                <a:gridCol w="6705295"/>
               </a:tblGrid>
-              <a:tr h="1051560">
+              <a:tr h="548640">
                 <a:tc>
                   <a:txBody>
                     <a:bodyPr/>
@@ -6887,7 +6796,7 @@
                         <a:buNone/>
                       </a:pPr>
                       <a:r>
-                        <a:rPr lang="en-US" sz="1800" b="1" dirty="0">
+                        <a:rPr lang="en-US" sz="1600" b="1" dirty="0">
                           <a:solidFill>
                             <a:srgbClr val="1F4E79"/>
                           </a:solidFill>
@@ -6895,9 +6804,9 @@
                           <a:ea typeface="Yu Gothic" pitchFamily="34" charset="-122"/>
                           <a:cs typeface="Yu Gothic" pitchFamily="34" charset="-120"/>
                         </a:rPr>
-                        <a:t>時期</a:t>
+                        <a:t>段階</a:t>
                       </a:r>
-                      <a:endParaRPr lang="en-US" sz="1800" dirty="0">
+                      <a:endParaRPr lang="en-US" sz="1600" dirty="0">
                         <a:latin typeface="Yu Gothic" charset="0"/>
                         <a:ea typeface="Yu Gothic" charset="0"/>
                         <a:cs typeface="Yu Gothic" charset="0"/>
@@ -6934,7 +6843,7 @@
                         <a:buNone/>
                       </a:pPr>
                       <a:r>
-                        <a:rPr lang="en-US" sz="1800" b="1" dirty="0">
+                        <a:rPr lang="en-US" sz="1600" b="1" dirty="0">
                           <a:solidFill>
                             <a:srgbClr val="1F4E79"/>
                           </a:solidFill>
@@ -6942,9 +6851,9 @@
                           <a:ea typeface="Yu Gothic" pitchFamily="34" charset="-122"/>
                           <a:cs typeface="Yu Gothic" pitchFamily="34" charset="-120"/>
                         </a:rPr>
-                        <a:t>課題</a:t>
+                        <a:t>ねらい</a:t>
                       </a:r>
-                      <a:endParaRPr lang="en-US" sz="1800" dirty="0">
+                      <a:endParaRPr lang="en-US" sz="1600" dirty="0">
                         <a:latin typeface="Yu Gothic" charset="0"/>
                         <a:ea typeface="Yu Gothic" charset="0"/>
                         <a:cs typeface="Yu Gothic" charset="0"/>
@@ -6981,7 +6890,7 @@
                         <a:buNone/>
                       </a:pPr>
                       <a:r>
-                        <a:rPr lang="en-US" sz="1800" b="1" dirty="0">
+                        <a:rPr lang="en-US" sz="1600" b="1" dirty="0">
                           <a:solidFill>
                             <a:srgbClr val="1F4E79"/>
                           </a:solidFill>
@@ -6991,7 +6900,7 @@
                         </a:rPr>
                         <a:t>やること</a:t>
                       </a:r>
-                      <a:endParaRPr lang="en-US" sz="1800" dirty="0">
+                      <a:endParaRPr lang="en-US" sz="1600" dirty="0">
                         <a:latin typeface="Yu Gothic" charset="0"/>
                         <a:ea typeface="Yu Gothic" charset="0"/>
                         <a:cs typeface="Yu Gothic" charset="0"/>
@@ -7030,7 +6939,7 @@
                         <a:buNone/>
                       </a:pPr>
                       <a:r>
-                        <a:rPr lang="en-US" sz="1800" b="1" dirty="0">
+                        <a:rPr lang="en-US" sz="1700" b="1" dirty="0">
                           <a:solidFill>
                             <a:srgbClr val="2D2D2D"/>
                           </a:solidFill>
@@ -7038,9 +6947,9 @@
                           <a:ea typeface="Yu Gothic" pitchFamily="34" charset="-122"/>
                           <a:cs typeface="Yu Gothic" pitchFamily="34" charset="-120"/>
                         </a:rPr>
-                        <a:t>〜1週間</a:t>
+                        <a:t>1. 結果を固める</a:t>
                       </a:r>
-                      <a:endParaRPr lang="en-US" sz="1800" dirty="0">
+                      <a:endParaRPr lang="en-US" sz="1700" dirty="0">
                         <a:latin typeface="Yu Gothic" charset="0"/>
                         <a:ea typeface="Yu Gothic" charset="0"/>
                         <a:cs typeface="Yu Gothic" charset="0"/>
@@ -7077,7 +6986,7 @@
                         <a:buNone/>
                       </a:pPr>
                       <a:r>
-                        <a:rPr lang="en-US" sz="1800" dirty="0">
+                        <a:rPr lang="en-US" sz="1700" dirty="0">
                           <a:solidFill>
                             <a:srgbClr val="2D2D2D"/>
                           </a:solidFill>
@@ -7085,9 +6994,9 @@
                           <a:ea typeface="Yu Gothic" pitchFamily="34" charset="-122"/>
                           <a:cs typeface="Yu Gothic" pitchFamily="34" charset="-120"/>
                         </a:rPr>
-                        <a:t>①②</a:t>
+                        <a:t>課題①②</a:t>
                       </a:r>
-                      <a:endParaRPr lang="en-US" sz="1800" dirty="0">
+                      <a:endParaRPr lang="en-US" sz="1700" dirty="0">
                         <a:latin typeface="Yu Gothic" charset="0"/>
                         <a:ea typeface="Yu Gothic" charset="0"/>
                         <a:cs typeface="Yu Gothic" charset="0"/>
@@ -7124,7 +7033,7 @@
                         <a:buNone/>
                       </a:pPr>
                       <a:r>
-                        <a:rPr lang="en-US" sz="1800" dirty="0">
+                        <a:rPr lang="en-US" sz="1700" dirty="0">
                           <a:solidFill>
                             <a:srgbClr val="2D2D2D"/>
                           </a:solidFill>
@@ -7132,9 +7041,9 @@
                           <a:ea typeface="Yu Gothic" pitchFamily="34" charset="-122"/>
                           <a:cs typeface="Yu Gothic" pitchFamily="34" charset="-120"/>
                         </a:rPr>
-                        <a:t>事前学習なしのモデルと比較</a:t>
+                        <a:t>事前学習なしの同じモデルと比較</a:t>
                       </a:r>
-                      <a:endParaRPr lang="en-US" sz="1800" dirty="0">
+                      <a:endParaRPr lang="en-US" sz="1700" dirty="0">
                         <a:latin typeface="Yu Gothic" charset="0"/>
                         <a:ea typeface="Yu Gothic" charset="0"/>
                         <a:cs typeface="Yu Gothic" charset="0"/>
@@ -7145,7 +7054,7 @@
                         <a:buNone/>
                       </a:pPr>
                       <a:r>
-                        <a:rPr lang="en-US" sz="1800" dirty="0">
+                        <a:rPr lang="en-US" sz="1700" dirty="0">
                           <a:solidFill>
                             <a:srgbClr val="2D2D2D"/>
                           </a:solidFill>
@@ -7153,9 +7062,9 @@
                           <a:ea typeface="Yu Gothic" pitchFamily="34" charset="-122"/>
                           <a:cs typeface="Yu Gothic" pitchFamily="34" charset="-120"/>
                         </a:rPr>
-                        <a:t>生成し直し・開発データで再確認</a:t>
+                        <a:t>生成し直し・開発データ・別のデータセット（VibraVox）で再確認</a:t>
                       </a:r>
-                      <a:endParaRPr lang="en-US" sz="1800" dirty="0">
+                      <a:endParaRPr lang="en-US" sz="1700" dirty="0">
                         <a:latin typeface="Yu Gothic" charset="0"/>
                         <a:ea typeface="Yu Gothic" charset="0"/>
                         <a:cs typeface="Yu Gothic" charset="0"/>
@@ -7194,17 +7103,17 @@
                         <a:buNone/>
                       </a:pPr>
                       <a:r>
-                        <a:rPr lang="en-US" sz="1800" b="1" dirty="0">
+                        <a:rPr lang="en-US" sz="1700" b="1" dirty="0">
                           <a:solidFill>
-                            <a:srgbClr val="2D2D2D"/>
+                            <a:srgbClr val="1F4E79"/>
                           </a:solidFill>
                           <a:latin typeface="Yu Gothic" pitchFamily="34" charset="0"/>
                           <a:ea typeface="Yu Gothic" pitchFamily="34" charset="-122"/>
                           <a:cs typeface="Yu Gothic" pitchFamily="34" charset="-120"/>
                         </a:rPr>
-                        <a:t>〜2週間</a:t>
+                        <a:t>2. 生成のさせ方</a:t>
                       </a:r>
-                      <a:endParaRPr lang="en-US" sz="1800" dirty="0">
+                      <a:endParaRPr lang="en-US" sz="1700" dirty="0">
                         <a:latin typeface="Yu Gothic" charset="0"/>
                         <a:ea typeface="Yu Gothic" charset="0"/>
                         <a:cs typeface="Yu Gothic" charset="0"/>
@@ -7241,17 +7150,17 @@
                         <a:buNone/>
                       </a:pPr>
                       <a:r>
-                        <a:rPr lang="en-US" sz="1800" dirty="0">
+                        <a:rPr lang="en-US" sz="1700" b="1" dirty="0">
                           <a:solidFill>
-                            <a:srgbClr val="2D2D2D"/>
+                            <a:srgbClr val="1F4E79"/>
                           </a:solidFill>
                           <a:latin typeface="Yu Gothic" pitchFamily="34" charset="0"/>
                           <a:ea typeface="Yu Gothic" pitchFamily="34" charset="-122"/>
                           <a:cs typeface="Yu Gothic" pitchFamily="34" charset="-120"/>
                         </a:rPr>
-                        <a:t>③</a:t>
+                        <a:t>本研究の中心</a:t>
                       </a:r>
-                      <a:endParaRPr lang="en-US" sz="1800" dirty="0">
+                      <a:endParaRPr lang="en-US" sz="1700" dirty="0">
                         <a:latin typeface="Yu Gothic" charset="0"/>
                         <a:ea typeface="Yu Gothic" charset="0"/>
                         <a:cs typeface="Yu Gothic" charset="0"/>
@@ -7288,7 +7197,7 @@
                         <a:buNone/>
                       </a:pPr>
                       <a:r>
-                        <a:rPr lang="en-US" sz="1800" dirty="0">
+                        <a:rPr lang="en-US" sz="1700" dirty="0">
                           <a:solidFill>
                             <a:srgbClr val="2D2D2D"/>
                           </a:solidFill>
@@ -7296,9 +7205,30 @@
                           <a:ea typeface="Yu Gothic" pitchFamily="34" charset="-122"/>
                           <a:cs typeface="Yu Gothic" pitchFamily="34" charset="-120"/>
                         </a:rPr>
-                        <a:t>別の喉マイクで検証（仏語の公開データ VibraVox。言語も変わる）</a:t>
+                        <a:t>何回か生成して平均する／互いに一番似た候補を選ぶ</a:t>
                       </a:r>
-                      <a:endParaRPr lang="en-US" sz="1800" dirty="0">
+                      <a:endParaRPr lang="en-US" sz="1700" dirty="0">
+                        <a:latin typeface="Yu Gothic" charset="0"/>
+                        <a:ea typeface="Yu Gothic" charset="0"/>
+                        <a:cs typeface="Yu Gothic" charset="0"/>
+                      </a:endParaRPr>
+                    </a:p>
+                    <a:p>
+                      <a:pPr indent="0" marL="0">
+                        <a:buNone/>
+                      </a:pPr>
+                      <a:r>
+                        <a:rPr lang="en-US" sz="1700" dirty="0">
+                          <a:solidFill>
+                            <a:srgbClr val="2D2D2D"/>
+                          </a:solidFill>
+                          <a:latin typeface="Yu Gothic" pitchFamily="34" charset="0"/>
+                          <a:ea typeface="Yu Gothic" pitchFamily="34" charset="-122"/>
+                          <a:cs typeface="Yu Gothic" pitchFamily="34" charset="-120"/>
+                        </a:rPr>
+                        <a:t>ランダムな状態ではなく、元の音声強調の出力から生成を始める</a:t>
+                      </a:r>
+                      <a:endParaRPr lang="en-US" sz="1700" dirty="0">
                         <a:latin typeface="Yu Gothic" charset="0"/>
                         <a:ea typeface="Yu Gothic" charset="0"/>
                         <a:cs typeface="Yu Gothic" charset="0"/>
@@ -7327,7 +7257,7 @@
                   </a:tcPr>
                 </a:tc>
               </a:tr>
-              <a:tr h="1051560">
+              <a:tr h="777240">
                 <a:tc>
                   <a:txBody>
                     <a:bodyPr/>
@@ -7337,7 +7267,7 @@
                         <a:buNone/>
                       </a:pPr>
                       <a:r>
-                        <a:rPr lang="en-US" sz="1800" b="1" dirty="0">
+                        <a:rPr lang="en-US" sz="1700" b="1" dirty="0">
                           <a:solidFill>
                             <a:srgbClr val="2D2D2D"/>
                           </a:solidFill>
@@ -7345,9 +7275,9 @@
                           <a:ea typeface="Yu Gothic" pitchFamily="34" charset="-122"/>
                           <a:cs typeface="Yu Gothic" pitchFamily="34" charset="-120"/>
                         </a:rPr>
-                        <a:t>その先</a:t>
+                        <a:t>3. 軽くする</a:t>
                       </a:r>
-                      <a:endParaRPr lang="en-US" sz="1800" dirty="0">
+                      <a:endParaRPr lang="en-US" sz="1700" dirty="0">
                         <a:latin typeface="Yu Gothic" charset="0"/>
                         <a:ea typeface="Yu Gothic" charset="0"/>
                         <a:cs typeface="Yu Gothic" charset="0"/>
@@ -7384,7 +7314,7 @@
                         <a:buNone/>
                       </a:pPr>
                       <a:r>
-                        <a:rPr lang="en-US" sz="1800" dirty="0">
+                        <a:rPr lang="en-US" sz="1700" dirty="0">
                           <a:solidFill>
                             <a:srgbClr val="2D2D2D"/>
                           </a:solidFill>
@@ -7392,9 +7322,9 @@
                           <a:ea typeface="Yu Gothic" pitchFamily="34" charset="-122"/>
                           <a:cs typeface="Yu Gothic" pitchFamily="34" charset="-120"/>
                         </a:rPr>
-                        <a:t>④</a:t>
+                        <a:t>実用</a:t>
                       </a:r>
-                      <a:endParaRPr lang="en-US" sz="1800" dirty="0">
+                      <a:endParaRPr lang="en-US" sz="1700" dirty="0">
                         <a:latin typeface="Yu Gothic" charset="0"/>
                         <a:ea typeface="Yu Gothic" charset="0"/>
                         <a:cs typeface="Yu Gothic" charset="0"/>
@@ -7431,7 +7361,7 @@
                         <a:buNone/>
                       </a:pPr>
                       <a:r>
-                        <a:rPr lang="en-US" sz="1800" dirty="0">
+                        <a:rPr lang="en-US" sz="1700" dirty="0">
                           <a:solidFill>
                             <a:srgbClr val="2D2D2D"/>
                           </a:solidFill>
@@ -7439,30 +7369,9 @@
                           <a:ea typeface="Yu Gothic" pitchFamily="34" charset="-122"/>
                           <a:cs typeface="Yu Gothic" pitchFamily="34" charset="-120"/>
                         </a:rPr>
-                        <a:t>マイクの情報を手がかりに、少ないデータで別のマイクへ対応</a:t>
+                        <a:t>2 の出力を正解にして、軽い音声強調へ蒸留</a:t>
                       </a:r>
-                      <a:endParaRPr lang="en-US" sz="1800" dirty="0">
-                        <a:latin typeface="Yu Gothic" charset="0"/>
-                        <a:ea typeface="Yu Gothic" charset="0"/>
-                        <a:cs typeface="Yu Gothic" charset="0"/>
-                      </a:endParaRPr>
-                    </a:p>
-                    <a:p>
-                      <a:pPr indent="0" marL="0">
-                        <a:buNone/>
-                      </a:pPr>
-                      <a:r>
-                        <a:rPr lang="en-US" sz="1800" dirty="0">
-                          <a:solidFill>
-                            <a:srgbClr val="2D2D2D"/>
-                          </a:solidFill>
-                          <a:latin typeface="Yu Gothic" pitchFamily="34" charset="0"/>
-                          <a:ea typeface="Yu Gothic" pitchFamily="34" charset="-122"/>
-                          <a:cs typeface="Yu Gothic" pitchFamily="34" charset="-120"/>
-                        </a:rPr>
-                        <a:t>生成を複数回行って平均し、誤りを安定して減らす</a:t>
-                      </a:r>
-                      <a:endParaRPr lang="en-US" sz="1800" dirty="0">
+                      <a:endParaRPr lang="en-US" sz="1700" dirty="0">
                         <a:latin typeface="Yu Gothic" charset="0"/>
                         <a:ea typeface="Yu Gothic" charset="0"/>
                         <a:cs typeface="Yu Gothic" charset="0"/>
@@ -7495,6 +7404,46 @@
           </a:graphicData>
         </a:graphic>
       </p:graphicFrame>
+      <p:sp>
+        <p:nvSpPr>
+          <p:cNvPr id="4" name="Text 1"/>
+          <p:cNvSpPr/>
+          <p:nvPr/>
+        </p:nvSpPr>
+        <p:spPr>
+          <a:xfrm>
+            <a:off x="548640" y="5349240"/>
+            <a:ext cx="11094415" cy="411480"/>
+          </a:xfrm>
+          <a:prstGeom prst="rect">
+            <a:avLst/>
+          </a:prstGeom>
+          <a:noFill/>
+          <a:ln/>
+        </p:spPr>
+        <p:txBody>
+          <a:bodyPr wrap="square" lIns="0" tIns="0" rIns="0" bIns="0" rtlCol="0" anchor="t"/>
+          <a:lstStyle/>
+          <a:p>
+            <a:pPr marL="228600" indent="-228600">
+              <a:buSzPct val="100000"/>
+              <a:buChar char="•"/>
+            </a:pPr>
+            <a:r>
+              <a:rPr lang="en-US" sz="1800" dirty="0">
+                <a:solidFill>
+                  <a:srgbClr val="777777"/>
+                </a:solidFill>
+                <a:latin typeface="Yu Gothic" pitchFamily="34" charset="0"/>
+                <a:ea typeface="Yu Gothic" pitchFamily="34" charset="-122"/>
+                <a:cs typeface="Yu Gothic" pitchFamily="34" charset="-120"/>
+              </a:rPr>
+              <a:t>2 は今の学習済みモデルのまま試せる（認識器は使わない）</a:t>
+            </a:r>
+            <a:endParaRPr lang="en-US" sz="1800" dirty="0"/>
+          </a:p>
+        </p:txBody>
+      </p:sp>
     </p:spTree>
   </p:cSld>
   <p:clrMapOvr>
@@ -7506,375 +7455,6 @@
 <file path=ppt/slides/slide8.xml><?xml version="1.0" encoding="utf-8"?>
 <p:sld xmlns:a="http://schemas.openxmlformats.org/drawingml/2006/main" xmlns:r="http://schemas.openxmlformats.org/officeDocument/2006/relationships" xmlns:p="http://schemas.openxmlformats.org/presentationml/2006/main">
   <p:cSld name="Slide 8">
-    <p:bg>
-      <p:bgPr>
-        <a:solidFill>
-          <a:srgbClr val="FFFFFF"/>
-        </a:solidFill>
-      </p:bgPr>
-    </p:bg>
-    <p:spTree>
-      <p:nvGrpSpPr>
-        <p:cNvPr id="1" name=""/>
-        <p:cNvGrpSpPr/>
-        <p:nvPr/>
-      </p:nvGrpSpPr>
-      <p:grpSpPr>
-        <a:xfrm>
-          <a:off x="0" y="0"/>
-          <a:ext cx="0" cy="0"/>
-          <a:chOff x="0" y="0"/>
-          <a:chExt cx="0" cy="0"/>
-        </a:xfrm>
-      </p:grpSpPr>
-      <p:sp>
-        <p:nvSpPr>
-          <p:cNvPr id="2" name="Text 0"/>
-          <p:cNvSpPr/>
-          <p:nvPr/>
-        </p:nvSpPr>
-        <p:spPr>
-          <a:xfrm>
-            <a:off x="548640" y="365760"/>
-            <a:ext cx="11094415" cy="914400"/>
-          </a:xfrm>
-          <a:prstGeom prst="rect">
-            <a:avLst/>
-          </a:prstGeom>
-          <a:noFill/>
-          <a:ln/>
-        </p:spPr>
-        <p:txBody>
-          <a:bodyPr wrap="square" lIns="0" tIns="0" rIns="0" bIns="0" rtlCol="0" anchor="ctr"/>
-          <a:lstStyle/>
-          <a:p>
-            <a:pPr indent="0" marL="0">
-              <a:buNone/>
-            </a:pPr>
-            <a:r>
-              <a:rPr lang="en-US" sz="2800" b="1" dirty="0">
-                <a:solidFill>
-                  <a:srgbClr val="1F4E79"/>
-                </a:solidFill>
-                <a:latin typeface="Yu Gothic" pitchFamily="34" charset="0"/>
-                <a:ea typeface="Yu Gothic" pitchFamily="34" charset="-122"/>
-                <a:cs typeface="Yu Gothic" pitchFamily="34" charset="-120"/>
-              </a:rPr>
-              <a:t>まとめと相談したいこと</a:t>
-            </a:r>
-            <a:endParaRPr lang="en-US" sz="2800" dirty="0"/>
-          </a:p>
-        </p:txBody>
-      </p:sp>
-      <p:sp>
-        <p:nvSpPr>
-          <p:cNvPr id="3" name="Text 1"/>
-          <p:cNvSpPr/>
-          <p:nvPr/>
-        </p:nvSpPr>
-        <p:spPr>
-          <a:xfrm>
-            <a:off x="548640" y="1554480"/>
-            <a:ext cx="11094415" cy="2194560"/>
-          </a:xfrm>
-          <a:prstGeom prst="rect">
-            <a:avLst/>
-          </a:prstGeom>
-          <a:noFill/>
-          <a:ln/>
-        </p:spPr>
-        <p:txBody>
-          <a:bodyPr wrap="square" lIns="0" tIns="0" rIns="0" bIns="0" rtlCol="0" anchor="t"/>
-          <a:lstStyle/>
-          <a:p>
-            <a:pPr indent="0" marL="0">
-              <a:lnSpc>
-                <a:spcPct val="120000"/>
-              </a:lnSpc>
-              <a:spcAft>
-                <a:spcPts val="1400"/>
-              </a:spcAft>
-              <a:buNone/>
-            </a:pPr>
-            <a:r>
-              <a:rPr lang="en-US" sz="2200" b="1" dirty="0">
-                <a:solidFill>
-                  <a:srgbClr val="1F4E79"/>
-                </a:solidFill>
-                <a:latin typeface="Yu Gothic" pitchFamily="34" charset="0"/>
-                <a:ea typeface="Yu Gothic" pitchFamily="34" charset="-122"/>
-                <a:cs typeface="Yu Gothic" pitchFamily="34" charset="-120"/>
-              </a:rPr>
-              <a:t>1. </a:t>
-            </a:r>
-            <a:pPr indent="0" marL="0">
-              <a:lnSpc>
-                <a:spcPct val="120000"/>
-              </a:lnSpc>
-              <a:spcAft>
-                <a:spcPts val="1400"/>
-              </a:spcAft>
-              <a:buNone/>
-            </a:pPr>
-            <a:r>
-              <a:rPr lang="en-US" sz="2200" dirty="0">
-                <a:solidFill>
-                  <a:srgbClr val="2D2D2D"/>
-                </a:solidFill>
-                <a:latin typeface="Yu Gothic" pitchFamily="34" charset="0"/>
-                <a:ea typeface="Yu Gothic" pitchFamily="34" charset="-122"/>
-                <a:cs typeface="Yu Gothic" pitchFamily="34" charset="-120"/>
-              </a:rPr>
-              <a:t>Whisperに合わせた音声強調は、入力の違う認識器で逆効果</a:t>
-            </a:r>
-            <a:endParaRPr lang="en-US" sz="2200" dirty="0"/>
-          </a:p>
-          <a:p>
-            <a:pPr indent="0" marL="0">
-              <a:lnSpc>
-                <a:spcPct val="120000"/>
-              </a:lnSpc>
-              <a:spcAft>
-                <a:spcPts val="1400"/>
-              </a:spcAft>
-              <a:buNone/>
-            </a:pPr>
-            <a:r>
-              <a:rPr lang="en-US" sz="2200" b="1" dirty="0">
-                <a:solidFill>
-                  <a:srgbClr val="1F4E79"/>
-                </a:solidFill>
-                <a:latin typeface="Yu Gothic" pitchFamily="34" charset="0"/>
-                <a:ea typeface="Yu Gothic" pitchFamily="34" charset="-122"/>
-                <a:cs typeface="Yu Gothic" pitchFamily="34" charset="-120"/>
-              </a:rPr>
-              <a:t>2. </a:t>
-            </a:r>
-            <a:pPr indent="0" marL="0">
-              <a:lnSpc>
-                <a:spcPct val="120000"/>
-              </a:lnSpc>
-              <a:spcAft>
-                <a:spcPts val="1400"/>
-              </a:spcAft>
-              <a:buNone/>
-            </a:pPr>
-            <a:r>
-              <a:rPr lang="en-US" sz="2200" b="1" dirty="0">
-                <a:solidFill>
-                  <a:srgbClr val="2D2D2D"/>
-                </a:solidFill>
-                <a:latin typeface="Yu Gothic" pitchFamily="34" charset="0"/>
-                <a:ea typeface="Yu Gothic" pitchFamily="34" charset="-122"/>
-                <a:cs typeface="Yu Gothic" pitchFamily="34" charset="-120"/>
-              </a:rPr>
-              <a:t>生成モデルの調整で、9つの音声認識すべての誤りが15〜24%減った</a:t>
-            </a:r>
-            <a:endParaRPr lang="en-US" sz="2200" dirty="0"/>
-          </a:p>
-          <a:p>
-            <a:pPr indent="0" marL="0">
-              <a:lnSpc>
-                <a:spcPct val="120000"/>
-              </a:lnSpc>
-              <a:spcAft>
-                <a:spcPts val="1400"/>
-              </a:spcAft>
-              <a:buNone/>
-            </a:pPr>
-            <a:r>
-              <a:rPr lang="en-US" sz="2200" b="1" dirty="0">
-                <a:solidFill>
-                  <a:srgbClr val="1F4E79"/>
-                </a:solidFill>
-                <a:latin typeface="Yu Gothic" pitchFamily="34" charset="0"/>
-                <a:ea typeface="Yu Gothic" pitchFamily="34" charset="-122"/>
-                <a:cs typeface="Yu Gothic" pitchFamily="34" charset="-120"/>
-              </a:rPr>
-              <a:t>3. </a:t>
-            </a:r>
-            <a:pPr indent="0" marL="0">
-              <a:lnSpc>
-                <a:spcPct val="120000"/>
-              </a:lnSpc>
-              <a:spcAft>
-                <a:spcPts val="1400"/>
-              </a:spcAft>
-              <a:buNone/>
-            </a:pPr>
-            <a:r>
-              <a:rPr lang="en-US" sz="2200" dirty="0">
-                <a:solidFill>
-                  <a:srgbClr val="2D2D2D"/>
-                </a:solidFill>
-                <a:latin typeface="Yu Gothic" pitchFamily="34" charset="0"/>
-                <a:ea typeface="Yu Gothic" pitchFamily="34" charset="-122"/>
-                <a:cs typeface="Yu Gothic" pitchFamily="34" charset="-120"/>
-              </a:rPr>
-              <a:t>理由・確かさ・別のマイクでの効果・自分の工夫を、これから確かめる</a:t>
-            </a:r>
-            <a:endParaRPr lang="en-US" sz="2200" dirty="0"/>
-          </a:p>
-        </p:txBody>
-      </p:sp>
-      <p:sp>
-        <p:nvSpPr>
-          <p:cNvPr id="4" name="Shape 2"/>
-          <p:cNvSpPr/>
-          <p:nvPr/>
-        </p:nvSpPr>
-        <p:spPr>
-          <a:xfrm>
-            <a:off x="548640" y="3977640"/>
-            <a:ext cx="11094415" cy="0"/>
-          </a:xfrm>
-          <a:prstGeom prst="line">
-            <a:avLst/>
-          </a:prstGeom>
-          <a:noFill/>
-          <a:ln w="12700">
-            <a:solidFill>
-              <a:srgbClr val="CCCCCC"/>
-            </a:solidFill>
-            <a:prstDash val="solid"/>
-          </a:ln>
-        </p:spPr>
-      </p:sp>
-      <p:sp>
-        <p:nvSpPr>
-          <p:cNvPr id="5" name="Text 3"/>
-          <p:cNvSpPr/>
-          <p:nvPr/>
-        </p:nvSpPr>
-        <p:spPr>
-          <a:xfrm>
-            <a:off x="548640" y="4160520"/>
-            <a:ext cx="11094415" cy="411480"/>
-          </a:xfrm>
-          <a:prstGeom prst="rect">
-            <a:avLst/>
-          </a:prstGeom>
-          <a:noFill/>
-          <a:ln/>
-        </p:spPr>
-        <p:txBody>
-          <a:bodyPr wrap="square" lIns="0" tIns="0" rIns="0" bIns="0" rtlCol="0" anchor="t"/>
-          <a:lstStyle/>
-          <a:p>
-            <a:pPr indent="0" marL="0">
-              <a:buNone/>
-            </a:pPr>
-            <a:r>
-              <a:rPr lang="en-US" sz="2000" b="1" dirty="0">
-                <a:solidFill>
-                  <a:srgbClr val="1F4E79"/>
-                </a:solidFill>
-                <a:latin typeface="Yu Gothic" pitchFamily="34" charset="0"/>
-                <a:ea typeface="Yu Gothic" pitchFamily="34" charset="-122"/>
-                <a:cs typeface="Yu Gothic" pitchFamily="34" charset="-120"/>
-              </a:rPr>
-              <a:t>相談したいこと</a:t>
-            </a:r>
-            <a:endParaRPr lang="en-US" sz="2000" dirty="0"/>
-          </a:p>
-        </p:txBody>
-      </p:sp>
-      <p:sp>
-        <p:nvSpPr>
-          <p:cNvPr id="6" name="Text 4"/>
-          <p:cNvSpPr/>
-          <p:nvPr/>
-        </p:nvSpPr>
-        <p:spPr>
-          <a:xfrm>
-            <a:off x="548640" y="4617720"/>
-            <a:ext cx="11094415" cy="1554480"/>
-          </a:xfrm>
-          <a:prstGeom prst="rect">
-            <a:avLst/>
-          </a:prstGeom>
-          <a:noFill/>
-          <a:ln/>
-        </p:spPr>
-        <p:txBody>
-          <a:bodyPr wrap="square" lIns="0" tIns="0" rIns="0" bIns="0" rtlCol="0" anchor="t"/>
-          <a:lstStyle/>
-          <a:p>
-            <a:pPr marL="228600" indent="-228600">
-              <a:spcAft>
-                <a:spcPts val="600"/>
-              </a:spcAft>
-              <a:buSzPct val="100000"/>
-              <a:buChar char="•"/>
-            </a:pPr>
-            <a:r>
-              <a:rPr lang="en-US" sz="2000" dirty="0">
-                <a:solidFill>
-                  <a:srgbClr val="2D2D2D"/>
-                </a:solidFill>
-                <a:latin typeface="Yu Gothic" pitchFamily="34" charset="0"/>
-                <a:ea typeface="Yu Gothic" pitchFamily="34" charset="-122"/>
-                <a:cs typeface="Yu Gothic" pitchFamily="34" charset="-120"/>
-              </a:rPr>
-              <a:t>別のマイクでの検証のため、日本語で自分でも録音すべきか</a:t>
-            </a:r>
-            <a:endParaRPr lang="en-US" sz="2000" dirty="0"/>
-          </a:p>
-          <a:p>
-            <a:pPr marL="228600" indent="-228600">
-              <a:spcAft>
-                <a:spcPts val="600"/>
-              </a:spcAft>
-              <a:buSzPct val="100000"/>
-              <a:buChar char="•"/>
-            </a:pPr>
-            <a:r>
-              <a:rPr lang="en-US" sz="2000" dirty="0">
-                <a:solidFill>
-                  <a:srgbClr val="2D2D2D"/>
-                </a:solidFill>
-                <a:latin typeface="Yu Gothic" pitchFamily="34" charset="0"/>
-                <a:ea typeface="Yu Gothic" pitchFamily="34" charset="-122"/>
-                <a:cs typeface="Yu Gothic" pitchFamily="34" charset="-120"/>
-              </a:rPr>
-              <a:t>手法の新しさをどこに置くのがよいか</a:t>
-            </a:r>
-            <a:endParaRPr lang="en-US" sz="2000" dirty="0"/>
-          </a:p>
-          <a:p>
-            <a:pPr marL="228600" indent="-228600">
-              <a:spcAft>
-                <a:spcPts val="600"/>
-              </a:spcAft>
-              <a:buSzPct val="100000"/>
-              <a:buChar char="•"/>
-            </a:pPr>
-            <a:r>
-              <a:rPr lang="en-US" sz="2000" dirty="0">
-                <a:solidFill>
-                  <a:srgbClr val="2D2D2D"/>
-                </a:solidFill>
-                <a:latin typeface="Yu Gothic" pitchFamily="34" charset="0"/>
-                <a:ea typeface="Yu Gothic" pitchFamily="34" charset="-122"/>
-                <a:cs typeface="Yu Gothic" pitchFamily="34" charset="-120"/>
-              </a:rPr>
-              <a:t>非商用ライセンスの公開モデルを土台にしてよいか</a:t>
-            </a:r>
-            <a:endParaRPr lang="en-US" sz="2000" dirty="0"/>
-          </a:p>
-        </p:txBody>
-      </p:sp>
-    </p:spTree>
-  </p:cSld>
-  <p:clrMapOvr>
-    <a:masterClrMapping/>
-  </p:clrMapOvr>
-</p:sld>
-</file>
-
-<file path=ppt/slides/slide9.xml><?xml version="1.0" encoding="utf-8"?>
-<p:sld xmlns:a="http://schemas.openxmlformats.org/drawingml/2006/main" xmlns:r="http://schemas.openxmlformats.org/officeDocument/2006/relationships" xmlns:p="http://schemas.openxmlformats.org/presentationml/2006/main">
-  <p:cSld name="Slide 9">
     <p:bg>
       <p:bgPr>
         <a:solidFill>

</xml_diff>

<commit_message>
Slides 2026-10: replace plan with final goal + working hypothesis and a map of candidate directions (PDCA)
Co-Authored-By: Claude Opus 5.5 (1M context) <noreply@anthropic.com>
</commit_message>
<xml_diff>
--- a/results/progress_slides_2026-10.pptx
+++ b/results/progress_slides_2026-10.pptx
@@ -16,9 +16,10 @@
     <p:sldId id="264" r:id="rId10"/>
     <p:sldId id="265" r:id="rId11"/>
     <p:sldId id="266" r:id="rId12"/>
+    <p:sldId id="267" r:id="rId13"/>
   </p:sldIdLst>
   <p:notesMasterIdLst>
-    <p:notesMasterId r:id="rId13"/>
+    <p:notesMasterId r:id="rId14"/>
   </p:notesMasterIdLst>
   <p:sldSz cx="12192000" cy="6858000"/>
   <p:notesSz cx="6858000" cy="12192000"/>
@@ -1199,11 +1200,7 @@
           <a:p>
             <a:r>
               <a:rPr lang="en-US" dirty="0"/>
-              <a:t>【台本】（約40秒）
-ここまでに試した方法をまとめます。普通のマイク向けの音声強調をそのまま使うと誤りが増え、Whisperに合わせて学習するとWhisper系だけ、複数の認識器に合わせても、学習に使っていない認識器ではやはり悪化しました。
-認識器に頼らない方法として、4つの音声強調の出力を平均する方法と、先行研究の方法は、どの認識器でも改善しましたが、改善は小さめでした。
-その中で、生成モデルを調整した方法だけが、全部の認識器で大きく改善しました。次で詳しく見ます。
-【補足】4つの平均：TAPS SE-Conformer・Demucs・TSTNN・再構成のみで再学習したSEの振幅を平均（推論は約1秒/発話と重い）。複数の認識器に合わせる：Whisper の損失＋XLS-R の損失で学習し、Zipformer で +9〜15%。Sato ら型：WavLM の内部表現を普通のマイクの音に近づける損失。</a:t>
+              <a:t/>
             </a:r>
             <a:endParaRPr lang="en-US" dirty="0"/>
           </a:p>
@@ -1291,10 +1288,11 @@
           <a:p>
             <a:r>
               <a:rPr lang="en-US" dirty="0"/>
-              <a:t>【台本】（約60秒）
-関連研究です。一番近いのは、今回の音響学会で東大の山中さんたちが発表した研究で、同じTAPSのデータを使っています。声質変換などで喉マイクの音を普通のマイクの音に近づけていて、聞こえは良くなりますが、音声認識の誤りはどの方法でも増えていました。一方、向こうは別の喉マイクや日本語でも確かめていて、同時録音のデータも要りません。ここは私に足りない点です。
-喉マイクで、入力の違う複数の音声認識で誤りが減るかを確かめた例は、調べた範囲では見当たりません。
-【補足】山中ら：無処理0.233、Sidon 0.308、Kanade(ft) 0.550。和田ら（神戸大・三菱電機）：喉マイクの感情認識でも汎用の雑音除去で悪化。</a:t>
+              <a:t>【台本】（約40秒）
+ここまでに試した方法をまとめます。普通のマイク向けの音声強調をそのまま使うと誤りが増え、Whisperに合わせて学習するとWhisper系だけ、複数の認識器に合わせても、学習に使っていない認識器ではやはり悪化しました。
+認識器に頼らない方法として、4つの音声強調の出力を平均する方法と、先行研究の方法は、どの認識器でも改善しましたが、改善は小さめでした。
+その中で、生成モデルを調整した方法だけが、全部の認識器で大きく改善しました。次で詳しく見ます。
+【補足】4つの平均：TAPS SE-Conformer・Demucs・TSTNN・再構成のみで再学習したSEの振幅を平均（推論は約1秒/発話と重い）。複数の認識器に合わせる：Whisper の損失＋XLS-R の損失で学習し、Zipformer で +9〜15%。Sato ら型：WavLM の内部表現を普通のマイクの音に近づける損失。</a:t>
             </a:r>
             <a:endParaRPr lang="en-US" dirty="0"/>
           </a:p>
@@ -1318,6 +1316,97 @@
             <a:fld id="{F7021451-1387-4CA6-816F-3879F97B5CBC}" type="slidenum">
               <a:rPr lang="en-US"/>
               <a:t>11</a:t>
+            </a:fld>
+            <a:endParaRPr lang="en-US"/>
+          </a:p>
+        </p:txBody>
+      </p:sp>
+    </p:spTree>
+    <p:extLst>
+      <p:ext uri="{BB962C8B-B14F-4D97-AF65-F5344CB8AC3E}">
+        <p14:creationId xmlns:p14="http://schemas.microsoft.com/office/powerpoint/2010/main" val="1024086991"/>
+      </p:ext>
+    </p:extLst>
+  </p:cSld>
+  <p:clrMapOvr>
+    <a:masterClrMapping/>
+  </p:clrMapOvr>
+</p:notes>
+</file>
+
+<file path=ppt/notesSlides/notesSlide12.xml><?xml version="1.0" encoding="utf-8"?>
+<p:notes xmlns:a="http://schemas.openxmlformats.org/drawingml/2006/main" xmlns:r="http://schemas.openxmlformats.org/officeDocument/2006/relationships" xmlns:p="http://schemas.openxmlformats.org/presentationml/2006/main">
+  <p:cSld>
+    <p:spTree>
+      <p:nvGrpSpPr>
+        <p:cNvPr id="1" name=""/>
+        <p:cNvGrpSpPr/>
+        <p:nvPr/>
+      </p:nvGrpSpPr>
+      <p:grpSpPr>
+        <a:xfrm>
+          <a:off x="0" y="0"/>
+          <a:ext cx="0" cy="0"/>
+          <a:chOff x="0" y="0"/>
+          <a:chExt cx="0" cy="0"/>
+        </a:xfrm>
+      </p:grpSpPr>
+      <p:sp>
+        <p:nvSpPr>
+          <p:cNvPr id="2" name="Slide Image Placeholder 1"/>
+          <p:cNvSpPr>
+            <a:spLocks noGrp="1" noRot="1" noChangeAspect="1"/>
+          </p:cNvSpPr>
+          <p:nvPr>
+            <p:ph type="sldImg"/>
+          </p:nvPr>
+        </p:nvSpPr>
+        <p:spPr/>
+      </p:sp>
+      <p:sp>
+        <p:nvSpPr>
+          <p:cNvPr id="3" name="Notes Placeholder 2"/>
+          <p:cNvSpPr>
+            <a:spLocks noGrp="1"/>
+          </p:cNvSpPr>
+          <p:nvPr>
+            <p:ph type="body" idx="1"/>
+          </p:nvPr>
+        </p:nvSpPr>
+        <p:spPr/>
+        <p:txBody>
+          <a:bodyPr/>
+          <a:lstStyle/>
+          <a:p>
+            <a:r>
+              <a:rPr lang="en-US" dirty="0"/>
+              <a:t>【台本】（約60秒）
+関連研究です。一番近いのは、今回の音響学会で東大の山中さんたちが発表した研究で、同じTAPSのデータを使っています。声質変換などで喉マイクの音を普通のマイクの音に近づけていて、聞こえは良くなりますが、音声認識の誤りはどの方法でも増えていました。一方、向こうは別の喉マイクや日本語でも確かめていて、同時録音のデータも要りません。ここは私に足りない点です。
+喉マイクで、入力の違う複数の音声認識で誤りが減るかを確かめた例は、調べた範囲では見当たりません。
+【補足】山中ら：無処理0.233、Sidon 0.308、Kanade(ft) 0.550。和田ら（神戸大・三菱電機）：喉マイクの感情認識でも汎用の雑音除去で悪化。</a:t>
+            </a:r>
+            <a:endParaRPr lang="en-US" dirty="0"/>
+          </a:p>
+        </p:txBody>
+      </p:sp>
+      <p:sp>
+        <p:nvSpPr>
+          <p:cNvPr id="4" name="Slide Number Placeholder 3"/>
+          <p:cNvSpPr>
+            <a:spLocks noGrp="1"/>
+          </p:cNvSpPr>
+          <p:nvPr>
+            <p:ph type="sldNum" sz="quarter" idx="10"/>
+          </p:nvPr>
+        </p:nvSpPr>
+        <p:spPr/>
+        <p:txBody>
+          <a:bodyPr/>
+          <a:lstStyle/>
+          <a:p>
+            <a:fld id="{F7021451-1387-4CA6-816F-3879F97B5CBC}" type="slidenum">
+              <a:rPr lang="en-US"/>
+              <a:t>12</a:t>
             </a:fld>
             <a:endParaRPr lang="en-US"/>
           </a:p>
@@ -1660,7 +1749,7 @@
               <a:t>【台本】（約45秒）
 では、もっと大きく改善するにはどうすればいいか。喉マイクの問題は、音が汚れていることではなく、高い音や子音が欠けていることです。
 これまでの音声強調は入力を直接加工するので、欠けた部分は、ありえる答えの平均しか出せず、こもった音になります。一方、生成モデルは大量の音声で自然な声の形を学んでいるので、欠けた部分を自然な声として描き足せます。
-実際、フランス語の喉マイクで、生成モデルを調整した方法が音素の誤りを最も減らしたという報告がありました。ただ評価は認識器1つだけだったので、9つの認識器でどれでも効くかを確かめることにしました。
+フランス語の喉マイクで生成モデルが最良という報告もあり、9つの認識器で確かめることにしました。
 【補足】Hauret ら: EBEN 18.6%、Mimi 追加学習 15.1%、NeMo flow matching 追加学習 7.6%。この案は 9/29 の方針議論（SE 分野の観点）で出た。</a:t>
             </a:r>
             <a:endParaRPr lang="en-US" dirty="0"/>
@@ -1941,9 +2030,10 @@
             <a:r>
               <a:rPr lang="en-US" dirty="0"/>
               <a:t>【台本】（約45秒）
-最後に課題と今後です。課題は、効いたのが事前学習のおかげかモデルの大きさか、1回生成しただけで確かか、他のデータでも効くか、そして公開モデルを調整しただけで新しさがないことです。
-そこで、まず事前学習なしのモデルとの比較や再確認で結果を固めます。そのうえで中心にしたいのが、認識に向いた生成のさせ方で、何回か生成して平均したり、元の音声強調の出力から生成を始めたりして、内容を取り違えにくくします。最後に、その出力を正解にして軽い音声強調へ蒸留したいと考えています。以上です。
-【補足】2 は今の学習済みモデルのまま試せる（認識器は使わない）。一番似た候補を選ぶ＝最小ベイズリスク選択（類似度は認識器に依存しない音声特徴で）。蒸留の正解は、生成モデルが学習で見ていない喉マイク音声で作る。</a:t>
+ここから今後の話です。生成モデルを提案手法にするかは、まだ決めていません。先に最終ゴールをはっきりさせました。
+（左）ゴールは、重みを変えられない、どの音声認識器でも誤りが減る喉マイク用の前処理を作り、なぜ効くのかを示すことです。基準はこの4つです。
+（右）これまでの結果は、1つの作業仮説でまとめられます。どの認識器にも効くのは自然な声に近い音で、特定の認識器にだけ効くのはその癖に合わせた音、という仮説です。これまでの結果はどれもこの仮説と合います。
+【補足】人工的な成分＝Whisper損失SEの出力に現れた 250 Hz 間隔の櫛状ピーク。SSL-MSE（自然な声の内部表現に近づける損失）も4認識器で改善しており仮説と整合。</a:t>
             </a:r>
             <a:endParaRPr lang="en-US" dirty="0"/>
           </a:p>
@@ -2031,7 +2121,12 @@
           <a:p>
             <a:r>
               <a:rPr lang="en-US" dirty="0"/>
-              <a:t/>
+              <a:t>【台本】（約50秒）
+そのうえで、生成モデルは候補の一つと位置づけて、仮説ごとに小さく試して絞り込んでいきます。
+最初に回すのはAの分析です。すでにある全ての出力で、自然な声との距離と、9つの認識器の誤りの関係を見ます。新しい学習がいらないので数日で結論が出ます。関係がはっきりすれば、これが研究の柱、設計原理になります。
+BからEも、並行して小さく試します。
+1週間ごとに、仮説、小さな実験、9つの認識器での確認、続けるか捨てるか、を回していきます。以上です。
+【補足】自然な声との距離の候補: 自己教師あり音声モデル（WavLM など）の内部表現での、同じ発話の気導音との距離、または気導音全体の分布との距離（FAD 型）。「続ける条件」は目安で、ゴールの基準に照らして判断する。</a:t>
             </a:r>
             <a:endParaRPr lang="en-US" dirty="0"/>
           </a:p>
@@ -2609,6 +2704,246 @@
                 <a:ea typeface="Yu Gothic" pitchFamily="34" charset="-122"/>
                 <a:cs typeface="Yu Gothic" pitchFamily="34" charset="-120"/>
               </a:rPr>
+              <a:t>参考文献</a:t>
+            </a:r>
+            <a:endParaRPr lang="en-US" sz="2800" dirty="0"/>
+          </a:p>
+        </p:txBody>
+      </p:sp>
+      <p:sp>
+        <p:nvSpPr>
+          <p:cNvPr id="3" name="Text 1"/>
+          <p:cNvSpPr/>
+          <p:nvPr/>
+        </p:nvSpPr>
+        <p:spPr>
+          <a:xfrm>
+            <a:off x="548640" y="1463040"/>
+            <a:ext cx="11094415" cy="4572000"/>
+          </a:xfrm>
+          <a:prstGeom prst="rect">
+            <a:avLst/>
+          </a:prstGeom>
+          <a:noFill/>
+          <a:ln/>
+        </p:spPr>
+        <p:txBody>
+          <a:bodyPr wrap="square" lIns="0" tIns="0" rIns="0" bIns="0" rtlCol="0" anchor="t"/>
+          <a:lstStyle/>
+          <a:p>
+            <a:pPr marL="228600" indent="-228600">
+              <a:spcAft>
+                <a:spcPts val="1000"/>
+              </a:spcAft>
+              <a:buSzPct val="100000"/>
+              <a:buChar char="•"/>
+            </a:pPr>
+            <a:r>
+              <a:rPr lang="en-US" sz="1400" dirty="0">
+                <a:solidFill>
+                  <a:srgbClr val="2D2D2D"/>
+                </a:solidFill>
+                <a:latin typeface="Yu Gothic" pitchFamily="34" charset="0"/>
+                <a:ea typeface="Yu Gothic" pitchFamily="34" charset="-122"/>
+                <a:cs typeface="Yu Gothic" pitchFamily="34" charset="-120"/>
+              </a:rPr>
+              <a:t>TAPS: Y. Kim et al., “Throat and acoustic paired speech dataset for deep learning-based speech enhancement,” Scientific Data, 2026.</a:t>
+            </a:r>
+            <a:endParaRPr lang="en-US" sz="1400" dirty="0"/>
+          </a:p>
+          <a:p>
+            <a:pPr marL="228600" indent="-228600">
+              <a:spcAft>
+                <a:spcPts val="1000"/>
+              </a:spcAft>
+              <a:buSzPct val="100000"/>
+              <a:buChar char="•"/>
+            </a:pPr>
+            <a:r>
+              <a:rPr lang="en-US" sz="1400" dirty="0">
+                <a:solidFill>
+                  <a:srgbClr val="2D2D2D"/>
+                </a:solidFill>
+                <a:latin typeface="Yu Gothic" pitchFamily="34" charset="0"/>
+                <a:ea typeface="Yu Gothic" pitchFamily="34" charset="-122"/>
+                <a:cs typeface="Yu Gothic" pitchFamily="34" charset="-120"/>
+              </a:rPr>
+              <a:t>Ku et al., “Generative speech foundation model pretraining for high-quality speech extraction and restoration,” arXiv:2409.16117.</a:t>
+            </a:r>
+            <a:endParaRPr lang="en-US" sz="1400" dirty="0"/>
+          </a:p>
+          <a:p>
+            <a:pPr marL="228600" indent="-228600">
+              <a:spcAft>
+                <a:spcPts val="1000"/>
+              </a:spcAft>
+              <a:buSzPct val="100000"/>
+              <a:buChar char="•"/>
+            </a:pPr>
+            <a:r>
+              <a:rPr lang="en-US" sz="1400" dirty="0">
+                <a:solidFill>
+                  <a:srgbClr val="2D2D2D"/>
+                </a:solidFill>
+                <a:latin typeface="Yu Gothic" pitchFamily="34" charset="0"/>
+                <a:ea typeface="Yu Gothic" pitchFamily="34" charset="-122"/>
+                <a:cs typeface="Yu Gothic" pitchFamily="34" charset="-120"/>
+              </a:rPr>
+              <a:t>山中 涼雅 ほか, “Zero-shot音声変換を用いた咽喉マイク音声の気導音復元に関する初期検討,” 日本音響学会 2026年秋季, 1-Q-42.</a:t>
+            </a:r>
+            <a:endParaRPr lang="en-US" sz="1400" dirty="0"/>
+          </a:p>
+          <a:p>
+            <a:pPr marL="228600" indent="-228600">
+              <a:spcAft>
+                <a:spcPts val="1000"/>
+              </a:spcAft>
+              <a:buSzPct val="100000"/>
+              <a:buChar char="•"/>
+            </a:pPr>
+            <a:r>
+              <a:rPr lang="en-US" sz="1400" dirty="0">
+                <a:solidFill>
+                  <a:srgbClr val="2D2D2D"/>
+                </a:solidFill>
+                <a:latin typeface="Yu Gothic" pitchFamily="34" charset="0"/>
+                <a:ea typeface="Yu Gothic" pitchFamily="34" charset="-122"/>
+                <a:cs typeface="Yu Gothic" pitchFamily="34" charset="-120"/>
+              </a:rPr>
+              <a:t>和田 航次郎 ほか, “咽喉マイク自由発話音声における感情認識の検討,” 日本音響学会 2026年秋季, 1-Q-56.</a:t>
+            </a:r>
+            <a:endParaRPr lang="en-US" sz="1400" dirty="0"/>
+          </a:p>
+          <a:p>
+            <a:pPr marL="228600" indent="-228600">
+              <a:spcAft>
+                <a:spcPts val="1000"/>
+              </a:spcAft>
+              <a:buSzPct val="100000"/>
+              <a:buChar char="•"/>
+            </a:pPr>
+            <a:r>
+              <a:rPr lang="en-US" sz="1400" dirty="0">
+                <a:solidFill>
+                  <a:srgbClr val="2D2D2D"/>
+                </a:solidFill>
+                <a:latin typeface="Yu Gothic" pitchFamily="34" charset="0"/>
+                <a:ea typeface="Yu Gothic" pitchFamily="34" charset="-122"/>
+                <a:cs typeface="Yu Gothic" pitchFamily="34" charset="-120"/>
+              </a:rPr>
+              <a:t>Sato et al., “Generic speech enhancement with self-supervised representation space loss,” arXiv:2507.07631, 2025.</a:t>
+            </a:r>
+            <a:endParaRPr lang="en-US" sz="1400" dirty="0"/>
+          </a:p>
+          <a:p>
+            <a:pPr marL="228600" indent="-228600">
+              <a:spcAft>
+                <a:spcPts val="1000"/>
+              </a:spcAft>
+              <a:buSzPct val="100000"/>
+              <a:buChar char="•"/>
+            </a:pPr>
+            <a:r>
+              <a:rPr lang="en-US" sz="1400" dirty="0">
+                <a:solidFill>
+                  <a:srgbClr val="2D2D2D"/>
+                </a:solidFill>
+                <a:latin typeface="Yu Gothic" pitchFamily="34" charset="0"/>
+                <a:ea typeface="Yu Gothic" pitchFamily="34" charset="-122"/>
+                <a:cs typeface="Yu Gothic" pitchFamily="34" charset="-120"/>
+              </a:rPr>
+              <a:t>J. Hauret et al., arXiv:2508.02974, 2025.（喉マイクのリアルタイム変換、生成モデルとの比較を含む）</a:t>
+            </a:r>
+            <a:endParaRPr lang="en-US" sz="1400" dirty="0"/>
+          </a:p>
+          <a:p>
+            <a:pPr marL="228600" indent="-228600">
+              <a:spcAft>
+                <a:spcPts val="1000"/>
+              </a:spcAft>
+              <a:buSzPct val="100000"/>
+              <a:buChar char="•"/>
+            </a:pPr>
+            <a:r>
+              <a:rPr lang="en-US" sz="1400" dirty="0">
+                <a:solidFill>
+                  <a:srgbClr val="2D2D2D"/>
+                </a:solidFill>
+                <a:latin typeface="Yu Gothic" pitchFamily="34" charset="0"/>
+                <a:ea typeface="Yu Gothic" pitchFamily="34" charset="-122"/>
+                <a:cs typeface="Yu Gothic" pitchFamily="34" charset="-120"/>
+              </a:rPr>
+              <a:t>J. Hauret et al., “Vibravox: A dataset of French speech captured with body-conduction audio sensors,” Speech Communication, 2025.</a:t>
+            </a:r>
+            <a:endParaRPr lang="en-US" sz="1400" dirty="0"/>
+          </a:p>
+        </p:txBody>
+      </p:sp>
+    </p:spTree>
+  </p:cSld>
+  <p:clrMapOvr>
+    <a:masterClrMapping/>
+  </p:clrMapOvr>
+</p:sld>
+</file>
+
+<file path=ppt/slides/slide11.xml><?xml version="1.0" encoding="utf-8"?>
+<p:sld xmlns:a="http://schemas.openxmlformats.org/drawingml/2006/main" xmlns:r="http://schemas.openxmlformats.org/officeDocument/2006/relationships" xmlns:p="http://schemas.openxmlformats.org/presentationml/2006/main">
+  <p:cSld name="Slide 11">
+    <p:bg>
+      <p:bgPr>
+        <a:solidFill>
+          <a:srgbClr val="FFFFFF"/>
+        </a:solidFill>
+      </p:bgPr>
+    </p:bg>
+    <p:spTree>
+      <p:nvGrpSpPr>
+        <p:cNvPr id="1" name=""/>
+        <p:cNvGrpSpPr/>
+        <p:nvPr/>
+      </p:nvGrpSpPr>
+      <p:grpSpPr>
+        <a:xfrm>
+          <a:off x="0" y="0"/>
+          <a:ext cx="0" cy="0"/>
+          <a:chOff x="0" y="0"/>
+          <a:chExt cx="0" cy="0"/>
+        </a:xfrm>
+      </p:grpSpPr>
+      <p:sp>
+        <p:nvSpPr>
+          <p:cNvPr id="2" name="Text 0"/>
+          <p:cNvSpPr/>
+          <p:nvPr/>
+        </p:nvSpPr>
+        <p:spPr>
+          <a:xfrm>
+            <a:off x="548640" y="365760"/>
+            <a:ext cx="11094415" cy="914400"/>
+          </a:xfrm>
+          <a:prstGeom prst="rect">
+            <a:avLst/>
+          </a:prstGeom>
+          <a:noFill/>
+          <a:ln/>
+        </p:spPr>
+        <p:txBody>
+          <a:bodyPr wrap="square" lIns="0" tIns="0" rIns="0" bIns="0" rtlCol="0" anchor="ctr"/>
+          <a:lstStyle/>
+          <a:p>
+            <a:pPr indent="0" marL="0">
+              <a:buNone/>
+            </a:pPr>
+            <a:r>
+              <a:rPr lang="en-US" sz="2800" b="1" dirty="0">
+                <a:solidFill>
+                  <a:srgbClr val="1F4E79"/>
+                </a:solidFill>
+                <a:latin typeface="Yu Gothic" pitchFamily="34" charset="0"/>
+                <a:ea typeface="Yu Gothic" pitchFamily="34" charset="-122"/>
+                <a:cs typeface="Yu Gothic" pitchFamily="34" charset="-120"/>
+              </a:rPr>
               <a:t>付録：試した6つの方法と結果</a:t>
             </a:r>
             <a:endParaRPr lang="en-US" sz="2800" dirty="0"/>
@@ -2617,7 +2952,7 @@
       </p:sp>
       <p:graphicFrame>
         <p:nvGraphicFramePr>
-          <p:cNvPr id="11" name="Table 0"/>
+          <p:cNvPr id="12" name="Table 0"/>
           <p:cNvGraphicFramePr>
             <a:graphicFrameLocks noGrp="1"/>
           </p:cNvGraphicFramePr>
@@ -3694,9 +4029,9 @@
 </p:sld>
 </file>
 
-<file path=ppt/slides/slide11.xml><?xml version="1.0" encoding="utf-8"?>
+<file path=ppt/slides/slide12.xml><?xml version="1.0" encoding="utf-8"?>
 <p:sld xmlns:a="http://schemas.openxmlformats.org/drawingml/2006/main" xmlns:r="http://schemas.openxmlformats.org/officeDocument/2006/relationships" xmlns:p="http://schemas.openxmlformats.org/presentationml/2006/main">
-  <p:cSld name="Slide 11">
+  <p:cSld name="Slide 12">
     <p:bg>
       <p:bgPr>
         <a:solidFill>
@@ -3759,7 +4094,7 @@
       </p:sp>
       <p:graphicFrame>
         <p:nvGraphicFramePr>
-          <p:cNvPr id="12" name="Table 0"/>
+          <p:cNvPr id="13" name="Table 0"/>
           <p:cNvGraphicFramePr>
             <a:graphicFrameLocks noGrp="1"/>
           </p:cNvGraphicFramePr>
@@ -9058,7 +9393,7 @@
                 <a:ea typeface="Yu Gothic" pitchFamily="34" charset="-122"/>
                 <a:cs typeface="Yu Gothic" pitchFamily="34" charset="-120"/>
               </a:rPr>
-              <a:t>今後は、結果を固め、認識に向いた生成のさせ方を探す</a:t>
+              <a:t>最終ゴール：どの認識器でも効く前処理と、その設計原理</a:t>
             </a:r>
             <a:endParaRPr lang="en-US" sz="2800" dirty="0"/>
           </a:p>
@@ -9072,8 +9407,8 @@
         </p:nvSpPr>
         <p:spPr>
           <a:xfrm>
-            <a:off x="548640" y="1508760"/>
-            <a:ext cx="4754880" cy="411480"/>
+            <a:off x="548640" y="1463040"/>
+            <a:ext cx="5486400" cy="411480"/>
           </a:xfrm>
           <a:prstGeom prst="rect">
             <a:avLst/>
@@ -9097,7 +9432,7 @@
                 <a:ea typeface="Yu Gothic" pitchFamily="34" charset="-122"/>
                 <a:cs typeface="Yu Gothic" pitchFamily="34" charset="-120"/>
               </a:rPr>
-              <a:t>残っている課題</a:t>
+              <a:t>最終ゴール（修士）</a:t>
             </a:r>
             <a:endParaRPr lang="en-US" sz="2000" dirty="0"/>
           </a:p>
@@ -9111,8 +9446,8 @@
         </p:nvSpPr>
         <p:spPr>
           <a:xfrm>
-            <a:off x="548640" y="2011680"/>
-            <a:ext cx="4754880" cy="3291840"/>
+            <a:off x="548640" y="1920240"/>
+            <a:ext cx="5486400" cy="1097280"/>
           </a:xfrm>
           <a:prstGeom prst="rect">
             <a:avLst/>
@@ -9124,12 +9459,11 @@
           <a:bodyPr wrap="square" lIns="0" tIns="0" rIns="0" bIns="0" rtlCol="0" anchor="t"/>
           <a:lstStyle/>
           <a:p>
-            <a:pPr marL="228600" indent="-228600">
-              <a:spcAft>
-                <a:spcPts val="1400"/>
-              </a:spcAft>
-              <a:buSzPct val="100000"/>
-              <a:buChar char="•"/>
+            <a:pPr indent="0" marL="0">
+              <a:lnSpc>
+                <a:spcPct val="125000"/>
+              </a:lnSpc>
+              <a:buNone/>
             </a:pPr>
             <a:r>
               <a:rPr lang="en-US" sz="1800" dirty="0">
@@ -9140,17 +9474,16 @@
                 <a:ea typeface="Yu Gothic" pitchFamily="34" charset="-122"/>
                 <a:cs typeface="Yu Gothic" pitchFamily="34" charset="-120"/>
               </a:rPr>
-              <a:t>事前学習のおかげか、大きさのせいか</a:t>
+              <a:t>どの認識器でも誤りが減る喉マイク用の前処理を作り、</a:t>
             </a:r>
             <a:endParaRPr lang="en-US" sz="1800" dirty="0"/>
           </a:p>
           <a:p>
-            <a:pPr marL="228600" indent="-228600">
-              <a:spcAft>
-                <a:spcPts val="1400"/>
-              </a:spcAft>
-              <a:buSzPct val="100000"/>
-              <a:buChar char="•"/>
+            <a:pPr indent="0" marL="0">
+              <a:lnSpc>
+                <a:spcPct val="125000"/>
+              </a:lnSpc>
+              <a:buNone/>
             </a:pPr>
             <a:r>
               <a:rPr lang="en-US" sz="1800" dirty="0">
@@ -9161,41 +9494,81 @@
                 <a:ea typeface="Yu Gothic" pitchFamily="34" charset="-122"/>
                 <a:cs typeface="Yu Gothic" pitchFamily="34" charset="-120"/>
               </a:rPr>
-              <a:t>1回生成しただけ（生成は毎回少し変わる）</a:t>
+              <a:t>なぜ効くかを示す（認識器の重みは変えない）</a:t>
             </a:r>
             <a:endParaRPr lang="en-US" sz="1800" dirty="0"/>
           </a:p>
-          <a:p>
-            <a:pPr marL="228600" indent="-228600">
-              <a:spcAft>
-                <a:spcPts val="1400"/>
-              </a:spcAft>
-              <a:buSzPct val="100000"/>
-              <a:buChar char="•"/>
-            </a:pPr>
-            <a:r>
-              <a:rPr lang="en-US" sz="1800" dirty="0">
-                <a:solidFill>
-                  <a:srgbClr val="2D2D2D"/>
+        </p:txBody>
+      </p:sp>
+      <p:sp>
+        <p:nvSpPr>
+          <p:cNvPr id="5" name="Text 3"/>
+          <p:cNvSpPr/>
+          <p:nvPr/>
+        </p:nvSpPr>
+        <p:spPr>
+          <a:xfrm>
+            <a:off x="548640" y="3154680"/>
+            <a:ext cx="5486400" cy="365760"/>
+          </a:xfrm>
+          <a:prstGeom prst="rect">
+            <a:avLst/>
+          </a:prstGeom>
+          <a:noFill/>
+          <a:ln/>
+        </p:spPr>
+        <p:txBody>
+          <a:bodyPr wrap="square" lIns="0" tIns="0" rIns="0" bIns="0" rtlCol="0" anchor="t"/>
+          <a:lstStyle/>
+          <a:p>
+            <a:pPr indent="0" marL="0">
+              <a:buNone/>
+            </a:pPr>
+            <a:r>
+              <a:rPr lang="en-US" sz="1800" b="1" dirty="0">
+                <a:solidFill>
+                  <a:srgbClr val="1F4E79"/>
                 </a:solidFill>
                 <a:latin typeface="Yu Gothic" pitchFamily="34" charset="0"/>
                 <a:ea typeface="Yu Gothic" pitchFamily="34" charset="-122"/>
                 <a:cs typeface="Yu Gothic" pitchFamily="34" charset="-120"/>
               </a:rPr>
-              <a:t>1つのデータセットでしか確かめていない</a:t>
+              <a:t>達成の基準</a:t>
             </a:r>
             <a:endParaRPr lang="en-US" sz="1800" dirty="0"/>
           </a:p>
+        </p:txBody>
+      </p:sp>
+      <p:sp>
+        <p:nvSpPr>
+          <p:cNvPr id="6" name="Text 4"/>
+          <p:cNvSpPr/>
+          <p:nvPr/>
+        </p:nvSpPr>
+        <p:spPr>
+          <a:xfrm>
+            <a:off x="548640" y="3566160"/>
+            <a:ext cx="5486400" cy="2377440"/>
+          </a:xfrm>
+          <a:prstGeom prst="rect">
+            <a:avLst/>
+          </a:prstGeom>
+          <a:noFill/>
+          <a:ln/>
+        </p:spPr>
+        <p:txBody>
+          <a:bodyPr wrap="square" lIns="0" tIns="0" rIns="0" bIns="0" rtlCol="0" anchor="t"/>
+          <a:lstStyle/>
           <a:p>
             <a:pPr marL="228600" indent="-228600">
               <a:spcAft>
-                <a:spcPts val="1400"/>
+                <a:spcPts val="800"/>
               </a:spcAft>
               <a:buSzPct val="100000"/>
               <a:buChar char="•"/>
             </a:pPr>
             <a:r>
-              <a:rPr lang="en-US" sz="1800" dirty="0">
+              <a:rPr lang="en-US" sz="1700" dirty="0">
                 <a:solidFill>
                   <a:srgbClr val="2D2D2D"/>
                 </a:solidFill>
@@ -9203,22 +9576,85 @@
                 <a:ea typeface="Yu Gothic" pitchFamily="34" charset="-122"/>
                 <a:cs typeface="Yu Gothic" pitchFamily="34" charset="-120"/>
               </a:rPr>
-              <a:t>公開モデルの調整だけで、新しさがない</a:t>
-            </a:r>
-            <a:endParaRPr lang="en-US" sz="1800" dirty="0"/>
+              <a:t>入力の違う認識器を含め、どれも改善・悪化なし</a:t>
+            </a:r>
+            <a:endParaRPr lang="en-US" sz="1700" dirty="0"/>
+          </a:p>
+          <a:p>
+            <a:pPr marL="228600" indent="-228600">
+              <a:spcAft>
+                <a:spcPts val="800"/>
+              </a:spcAft>
+              <a:buSzPct val="100000"/>
+              <a:buChar char="•"/>
+            </a:pPr>
+            <a:r>
+              <a:rPr lang="en-US" sz="1700" dirty="0">
+                <a:solidFill>
+                  <a:srgbClr val="2D2D2D"/>
+                </a:solidFill>
+                <a:latin typeface="Yu Gothic" pitchFamily="34" charset="0"/>
+                <a:ea typeface="Yu Gothic" pitchFamily="34" charset="-122"/>
+                <a:cs typeface="Yu Gothic" pitchFamily="34" charset="-120"/>
+              </a:rPr>
+              <a:t>既存の喉マイク用音声強調（TAPS）より明確に良い</a:t>
+            </a:r>
+            <a:endParaRPr lang="en-US" sz="1700" dirty="0"/>
+          </a:p>
+          <a:p>
+            <a:pPr marL="228600" indent="-228600">
+              <a:spcAft>
+                <a:spcPts val="800"/>
+              </a:spcAft>
+              <a:buSzPct val="100000"/>
+              <a:buChar char="•"/>
+            </a:pPr>
+            <a:r>
+              <a:rPr lang="en-US" sz="1700" dirty="0">
+                <a:solidFill>
+                  <a:srgbClr val="2D2D2D"/>
+                </a:solidFill>
+                <a:latin typeface="Yu Gothic" pitchFamily="34" charset="0"/>
+                <a:ea typeface="Yu Gothic" pitchFamily="34" charset="-122"/>
+                <a:cs typeface="Yu Gothic" pitchFamily="34" charset="-120"/>
+              </a:rPr>
+              <a:t>実際に使える計算量</a:t>
+            </a:r>
+            <a:endParaRPr lang="en-US" sz="1700" dirty="0"/>
+          </a:p>
+          <a:p>
+            <a:pPr marL="228600" indent="-228600">
+              <a:spcAft>
+                <a:spcPts val="800"/>
+              </a:spcAft>
+              <a:buSzPct val="100000"/>
+              <a:buChar char="•"/>
+            </a:pPr>
+            <a:r>
+              <a:rPr lang="en-US" sz="1700" dirty="0">
+                <a:solidFill>
+                  <a:srgbClr val="2D2D2D"/>
+                </a:solidFill>
+                <a:latin typeface="Yu Gothic" pitchFamily="34" charset="0"/>
+                <a:ea typeface="Yu Gothic" pitchFamily="34" charset="-122"/>
+                <a:cs typeface="Yu Gothic" pitchFamily="34" charset="-120"/>
+              </a:rPr>
+              <a:t>別のデータでも同じ結論</a:t>
+            </a:r>
+            <a:endParaRPr lang="en-US" sz="1700" dirty="0"/>
           </a:p>
         </p:txBody>
       </p:sp>
       <p:sp>
         <p:nvSpPr>
-          <p:cNvPr id="5" name="Shape 3"/>
+          <p:cNvPr id="7" name="Shape 5"/>
           <p:cNvSpPr/>
           <p:nvPr/>
         </p:nvSpPr>
         <p:spPr>
           <a:xfrm>
-            <a:off x="5532120" y="1554480"/>
-            <a:ext cx="0" cy="4206240"/>
+            <a:off x="6355080" y="1554480"/>
+            <a:ext cx="0" cy="4389120"/>
           </a:xfrm>
           <a:prstGeom prst="line">
             <a:avLst/>
@@ -9234,14 +9670,14 @@
       </p:sp>
       <p:sp>
         <p:nvSpPr>
-          <p:cNvPr id="6" name="Text 4"/>
+          <p:cNvPr id="8" name="Text 6"/>
           <p:cNvSpPr/>
           <p:nvPr/>
         </p:nvSpPr>
         <p:spPr>
           <a:xfrm>
-            <a:off x="5852160" y="1508760"/>
-            <a:ext cx="5790895" cy="411480"/>
+            <a:off x="6675120" y="1463040"/>
+            <a:ext cx="4967935" cy="411480"/>
           </a:xfrm>
           <a:prstGeom prst="rect">
             <a:avLst/>
@@ -9265,7 +9701,7 @@
                 <a:ea typeface="Yu Gothic" pitchFamily="34" charset="-122"/>
                 <a:cs typeface="Yu Gothic" pitchFamily="34" charset="-120"/>
               </a:rPr>
-              <a:t>今後の方針</a:t>
+              <a:t>作業仮説（これまでの結果から）</a:t>
             </a:r>
             <a:endParaRPr lang="en-US" sz="2000" dirty="0"/>
           </a:p>
@@ -9273,14 +9709,39 @@
       </p:sp>
       <p:sp>
         <p:nvSpPr>
-          <p:cNvPr id="7" name="Text 5"/>
+          <p:cNvPr id="9" name="Shape 7"/>
           <p:cNvSpPr/>
           <p:nvPr/>
         </p:nvSpPr>
         <p:spPr>
           <a:xfrm>
-            <a:off x="5852160" y="2011680"/>
-            <a:ext cx="5790895" cy="3749040"/>
+            <a:off x="6675120" y="1965960"/>
+            <a:ext cx="4967935" cy="1143000"/>
+          </a:xfrm>
+          <a:prstGeom prst="rect">
+            <a:avLst/>
+          </a:prstGeom>
+          <a:solidFill>
+            <a:srgbClr val="FFF2CC"/>
+          </a:solidFill>
+          <a:ln w="12700">
+            <a:solidFill>
+              <a:srgbClr val="E6C800"/>
+            </a:solidFill>
+            <a:prstDash val="solid"/>
+          </a:ln>
+        </p:spPr>
+      </p:sp>
+      <p:sp>
+        <p:nvSpPr>
+          <p:cNvPr id="10" name="Text 8"/>
+          <p:cNvSpPr/>
+          <p:nvPr/>
+        </p:nvSpPr>
+        <p:spPr>
+          <a:xfrm>
+            <a:off x="6858000" y="1965960"/>
+            <a:ext cx="4602175" cy="1143000"/>
           </a:xfrm>
           <a:prstGeom prst="rect">
             <a:avLst/>
@@ -9289,106 +9750,127 @@
           <a:ln/>
         </p:spPr>
         <p:txBody>
-          <a:bodyPr wrap="square" lIns="0" tIns="0" rIns="0" bIns="0" rtlCol="0" anchor="t"/>
+          <a:bodyPr wrap="square" lIns="0" tIns="0" rIns="0" bIns="0" rtlCol="0" anchor="ctr"/>
           <a:lstStyle/>
           <a:p>
             <a:pPr indent="0" marL="0">
               <a:lnSpc>
-                <a:spcPct val="120000"/>
+                <a:spcPct val="130000"/>
               </a:lnSpc>
-              <a:spcAft>
-                <a:spcPts val="1600"/>
-              </a:spcAft>
               <a:buNone/>
             </a:pPr>
             <a:r>
               <a:rPr lang="en-US" sz="1800" b="1" dirty="0">
                 <a:solidFill>
-                  <a:srgbClr val="2D2D2D"/>
+                  <a:srgbClr val="5A4300"/>
                 </a:solidFill>
                 <a:latin typeface="Yu Gothic" pitchFamily="34" charset="0"/>
                 <a:ea typeface="Yu Gothic" pitchFamily="34" charset="-122"/>
                 <a:cs typeface="Yu Gothic" pitchFamily="34" charset="-120"/>
               </a:rPr>
-              <a:t>1. 結果を固める：</a:t>
-            </a:r>
+              <a:t>どの認識器にも効く ＝ 自然な声に近い音</a:t>
+            </a:r>
+            <a:endParaRPr lang="en-US" sz="1800" dirty="0"/>
+          </a:p>
+          <a:p>
             <a:pPr indent="0" marL="0">
               <a:lnSpc>
-                <a:spcPct val="120000"/>
+                <a:spcPct val="130000"/>
               </a:lnSpc>
-              <a:spcAft>
-                <a:spcPts val="1600"/>
-              </a:spcAft>
               <a:buNone/>
             </a:pPr>
             <a:r>
               <a:rPr lang="en-US" sz="1800" dirty="0">
                 <a:solidFill>
-                  <a:srgbClr val="2D2D2D"/>
+                  <a:srgbClr val="5A4300"/>
                 </a:solidFill>
                 <a:latin typeface="Yu Gothic" pitchFamily="34" charset="0"/>
                 <a:ea typeface="Yu Gothic" pitchFamily="34" charset="-122"/>
                 <a:cs typeface="Yu Gothic" pitchFamily="34" charset="-120"/>
               </a:rPr>
-              <a:t>事前学習なしと比較／再生成・別データで再確認</a:t>
+              <a:t>特定の認識器だけ ＝ その癖に合わせた音</a:t>
             </a:r>
             <a:endParaRPr lang="en-US" sz="1800" dirty="0"/>
           </a:p>
-          <a:p>
-            <a:pPr indent="0" marL="0">
+        </p:txBody>
+      </p:sp>
+      <p:sp>
+        <p:nvSpPr>
+          <p:cNvPr id="11" name="Text 9"/>
+          <p:cNvSpPr/>
+          <p:nvPr/>
+        </p:nvSpPr>
+        <p:spPr>
+          <a:xfrm>
+            <a:off x="6675120" y="3291840"/>
+            <a:ext cx="4967935" cy="2651760"/>
+          </a:xfrm>
+          <a:prstGeom prst="rect">
+            <a:avLst/>
+          </a:prstGeom>
+          <a:noFill/>
+          <a:ln/>
+        </p:spPr>
+        <p:txBody>
+          <a:bodyPr wrap="square" lIns="0" tIns="0" rIns="0" bIns="0" rtlCol="0" anchor="t"/>
+          <a:lstStyle/>
+          <a:p>
+            <a:pPr marL="228600" indent="-228600">
               <a:lnSpc>
-                <a:spcPct val="120000"/>
+                <a:spcPct val="115000"/>
               </a:lnSpc>
               <a:spcAft>
-                <a:spcPts val="1600"/>
+                <a:spcPts val="1000"/>
               </a:spcAft>
-              <a:buNone/>
-            </a:pPr>
-            <a:r>
-              <a:rPr lang="en-US" sz="1800" b="1" dirty="0">
-                <a:solidFill>
-                  <a:srgbClr val="1F4E79"/>
+              <a:buSzPct val="100000"/>
+              <a:buChar char="•"/>
+            </a:pPr>
+            <a:r>
+              <a:rPr lang="en-US" sz="1600" dirty="0">
+                <a:solidFill>
+                  <a:srgbClr val="2D2D2D"/>
                 </a:solidFill>
                 <a:latin typeface="Yu Gothic" pitchFamily="34" charset="0"/>
                 <a:ea typeface="Yu Gothic" pitchFamily="34" charset="-122"/>
                 <a:cs typeface="Yu Gothic" pitchFamily="34" charset="-120"/>
               </a:rPr>
-              <a:t>2. 生成のさせ方（中心）：</a:t>
+              <a:t>Whisper用の学習：人工的な成分 → </a:t>
             </a:r>
             <a:pPr indent="0" marL="0">
               <a:lnSpc>
-                <a:spcPct val="120000"/>
+                <a:spcPct val="115000"/>
               </a:lnSpc>
               <a:spcAft>
-                <a:spcPts val="1600"/>
+                <a:spcPts val="1000"/>
               </a:spcAft>
               <a:buNone/>
             </a:pPr>
             <a:r>
-              <a:rPr lang="en-US" sz="1800" dirty="0">
-                <a:solidFill>
-                  <a:srgbClr val="2D2D2D"/>
+              <a:rPr lang="en-US" sz="1600" b="1" dirty="0">
+                <a:solidFill>
+                  <a:srgbClr val="C55A11"/>
                 </a:solidFill>
                 <a:latin typeface="Yu Gothic" pitchFamily="34" charset="0"/>
                 <a:ea typeface="Yu Gothic" pitchFamily="34" charset="-122"/>
                 <a:cs typeface="Yu Gothic" pitchFamily="34" charset="-120"/>
               </a:rPr>
-              <a:t>何回か生成して平均／一番似た候補を選ぶ／元の音声強調の出力から生成を始める</a:t>
-            </a:r>
-            <a:endParaRPr lang="en-US" sz="1800" dirty="0"/>
-          </a:p>
-          <a:p>
-            <a:pPr indent="0" marL="0">
+              <a:t>他で悪化</a:t>
+            </a:r>
+            <a:endParaRPr lang="en-US" sz="1600" dirty="0"/>
+          </a:p>
+          <a:p>
+            <a:pPr marL="228600" indent="-228600">
               <a:lnSpc>
-                <a:spcPct val="120000"/>
+                <a:spcPct val="115000"/>
               </a:lnSpc>
               <a:spcAft>
-                <a:spcPts val="1600"/>
+                <a:spcPts val="1000"/>
               </a:spcAft>
-              <a:buNone/>
-            </a:pPr>
-            <a:r>
-              <a:rPr lang="en-US" sz="1800" b="1" dirty="0">
+              <a:buSzPct val="100000"/>
+              <a:buChar char="•"/>
+            </a:pPr>
+            <a:r>
+              <a:rPr lang="en-US" sz="1600" dirty="0">
                 <a:solidFill>
                   <a:srgbClr val="2D2D2D"/>
                 </a:solidFill>
@@ -9396,19 +9878,23 @@
                 <a:ea typeface="Yu Gothic" pitchFamily="34" charset="-122"/>
                 <a:cs typeface="Yu Gothic" pitchFamily="34" charset="-120"/>
               </a:rPr>
-              <a:t>3. 軽くする：</a:t>
-            </a:r>
-            <a:pPr indent="0" marL="0">
+              <a:t>4つの平均：癖が打ち消し合う → 全9つで改善</a:t>
+            </a:r>
+            <a:endParaRPr lang="en-US" sz="1600" dirty="0"/>
+          </a:p>
+          <a:p>
+            <a:pPr marL="228600" indent="-228600">
               <a:lnSpc>
-                <a:spcPct val="120000"/>
+                <a:spcPct val="115000"/>
               </a:lnSpc>
               <a:spcAft>
-                <a:spcPts val="1600"/>
+                <a:spcPts val="1000"/>
               </a:spcAft>
-              <a:buNone/>
-            </a:pPr>
-            <a:r>
-              <a:rPr lang="en-US" sz="1800" dirty="0">
+              <a:buSzPct val="100000"/>
+              <a:buChar char="•"/>
+            </a:pPr>
+            <a:r>
+              <a:rPr lang="en-US" sz="1600" dirty="0">
                 <a:solidFill>
                   <a:srgbClr val="2D2D2D"/>
                 </a:solidFill>
@@ -9416,9 +9902,9 @@
                 <a:ea typeface="Yu Gothic" pitchFamily="34" charset="-122"/>
                 <a:cs typeface="Yu Gothic" pitchFamily="34" charset="-120"/>
               </a:rPr>
-              <a:t>2 の出力を正解に、軽い音声強調へ蒸留</a:t>
-            </a:r>
-            <a:endParaRPr lang="en-US" sz="1800" dirty="0"/>
+              <a:t>生成モデル：自然な声に描き直す → 全9つ改善</a:t>
+            </a:r>
+            <a:endParaRPr lang="en-US" sz="1600" dirty="0"/>
           </a:p>
         </p:txBody>
       </p:sp>
@@ -9487,22 +9973,1194 @@
                 <a:ea typeface="Yu Gothic" pitchFamily="34" charset="-122"/>
                 <a:cs typeface="Yu Gothic" pitchFamily="34" charset="-120"/>
               </a:rPr>
-              <a:t>参考文献</a:t>
+              <a:t>生成モデルは候補の一つ。仮説ごとに小さく試して絞り込む</a:t>
             </a:r>
             <a:endParaRPr lang="en-US" sz="2800" dirty="0"/>
           </a:p>
         </p:txBody>
       </p:sp>
-      <p:sp>
-        <p:nvSpPr>
-          <p:cNvPr id="3" name="Text 1"/>
+      <p:graphicFrame>
+        <p:nvGraphicFramePr>
+          <p:cNvPr id="10" name="Table 0"/>
+          <p:cNvGraphicFramePr>
+            <a:graphicFrameLocks noGrp="1"/>
+          </p:cNvGraphicFramePr>
+          <p:nvPr>
+            <p:extLst>
+              <p:ext uri="{D42A27DB-BD31-4B8C-83A1-F6EECF244321}">
+                <p14:modId xmlns:p14="http://schemas.microsoft.com/office/powerpoint/2010/main" val="1579011935"/>
+              </p:ext>
+            </p:extLst>
+          </p:nvPr>
+        </p:nvGraphicFramePr>
+        <p:xfrm>
+          <a:off x="548640" y="1463040"/>
+          <a:ext cx="11094415" cy="914400"/>
+        </p:xfrm>
+        <a:graphic>
+          <a:graphicData uri="http://schemas.openxmlformats.org/drawingml/2006/table">
+            <a:tbl>
+              <a:tblPr/>
+              <a:tblGrid>
+                <a:gridCol w="2286000"/>
+                <a:gridCol w="3291840"/>
+                <a:gridCol w="3474720"/>
+                <a:gridCol w="2041855"/>
+              </a:tblGrid>
+              <a:tr h="457200">
+                <a:tc>
+                  <a:txBody>
+                    <a:bodyPr/>
+                    <a:lstStyle/>
+                    <a:p>
+                      <a:pPr indent="0" marL="0">
+                        <a:buNone/>
+                      </a:pPr>
+                      <a:r>
+                        <a:rPr lang="en-US" sz="1500" b="1" dirty="0">
+                          <a:solidFill>
+                            <a:srgbClr val="1F4E79"/>
+                          </a:solidFill>
+                          <a:latin typeface="Yu Gothic" pitchFamily="34" charset="0"/>
+                          <a:ea typeface="Yu Gothic" pitchFamily="34" charset="-122"/>
+                          <a:cs typeface="Yu Gothic" pitchFamily="34" charset="-120"/>
+                        </a:rPr>
+                        <a:t>方向</a:t>
+                      </a:r>
+                      <a:endParaRPr lang="en-US" sz="1500" dirty="0">
+                        <a:latin typeface="Yu Gothic" charset="0"/>
+                        <a:ea typeface="Yu Gothic" charset="0"/>
+                        <a:cs typeface="Yu Gothic" charset="0"/>
+                      </a:endParaRPr>
+                    </a:p>
+                  </a:txBody>
+                  <a:tcPr marL="88900" marR="88900" marT="38100" marB="38100" anchor="ctr">
+                    <a:lnL w="0" cap="flat" cmpd="sng" algn="ctr">
+                      <a:noFill/>
+                    </a:lnL>
+                    <a:lnR w="0" cap="flat" cmpd="sng" algn="ctr">
+                      <a:noFill/>
+                    </a:lnR>
+                    <a:lnT w="0" cap="flat" cmpd="sng" algn="ctr">
+                      <a:noFill/>
+                    </a:lnT>
+                    <a:lnB w="19050" cap="flat" cmpd="sng" algn="ctr">
+                      <a:solidFill>
+                        <a:srgbClr val="1F4E79"/>
+                      </a:solidFill>
+                      <a:prstDash val="solid"/>
+                      <a:round/>
+                      <a:headEnd type="none" w="med" len="med"/>
+                      <a:tailEnd type="none" w="med" len="med"/>
+                    </a:lnB>
+                  </a:tcPr>
+                </a:tc>
+                <a:tc>
+                  <a:txBody>
+                    <a:bodyPr/>
+                    <a:lstStyle/>
+                    <a:p>
+                      <a:pPr indent="0" marL="0">
+                        <a:buNone/>
+                      </a:pPr>
+                      <a:r>
+                        <a:rPr lang="en-US" sz="1500" b="1" dirty="0">
+                          <a:solidFill>
+                            <a:srgbClr val="1F4E79"/>
+                          </a:solidFill>
+                          <a:latin typeface="Yu Gothic" pitchFamily="34" charset="0"/>
+                          <a:ea typeface="Yu Gothic" pitchFamily="34" charset="-122"/>
+                          <a:cs typeface="Yu Gothic" pitchFamily="34" charset="-120"/>
+                        </a:rPr>
+                        <a:t>確かめる仮説</a:t>
+                      </a:r>
+                      <a:endParaRPr lang="en-US" sz="1500" dirty="0">
+                        <a:latin typeface="Yu Gothic" charset="0"/>
+                        <a:ea typeface="Yu Gothic" charset="0"/>
+                        <a:cs typeface="Yu Gothic" charset="0"/>
+                      </a:endParaRPr>
+                    </a:p>
+                  </a:txBody>
+                  <a:tcPr marL="88900" marR="88900" marT="38100" marB="38100" anchor="ctr">
+                    <a:lnL w="0" cap="flat" cmpd="sng" algn="ctr">
+                      <a:noFill/>
+                    </a:lnL>
+                    <a:lnR w="0" cap="flat" cmpd="sng" algn="ctr">
+                      <a:noFill/>
+                    </a:lnR>
+                    <a:lnT w="0" cap="flat" cmpd="sng" algn="ctr">
+                      <a:noFill/>
+                    </a:lnT>
+                    <a:lnB w="19050" cap="flat" cmpd="sng" algn="ctr">
+                      <a:solidFill>
+                        <a:srgbClr val="1F4E79"/>
+                      </a:solidFill>
+                      <a:prstDash val="solid"/>
+                      <a:round/>
+                      <a:headEnd type="none" w="med" len="med"/>
+                      <a:tailEnd type="none" w="med" len="med"/>
+                    </a:lnB>
+                  </a:tcPr>
+                </a:tc>
+                <a:tc>
+                  <a:txBody>
+                    <a:bodyPr/>
+                    <a:lstStyle/>
+                    <a:p>
+                      <a:pPr indent="0" marL="0">
+                        <a:buNone/>
+                      </a:pPr>
+                      <a:r>
+                        <a:rPr lang="en-US" sz="1500" b="1" dirty="0">
+                          <a:solidFill>
+                            <a:srgbClr val="1F4E79"/>
+                          </a:solidFill>
+                          <a:latin typeface="Yu Gothic" pitchFamily="34" charset="0"/>
+                          <a:ea typeface="Yu Gothic" pitchFamily="34" charset="-122"/>
+                          <a:cs typeface="Yu Gothic" pitchFamily="34" charset="-120"/>
+                        </a:rPr>
+                        <a:t>最初の小さな実験</a:t>
+                      </a:r>
+                      <a:endParaRPr lang="en-US" sz="1500" dirty="0">
+                        <a:latin typeface="Yu Gothic" charset="0"/>
+                        <a:ea typeface="Yu Gothic" charset="0"/>
+                        <a:cs typeface="Yu Gothic" charset="0"/>
+                      </a:endParaRPr>
+                    </a:p>
+                  </a:txBody>
+                  <a:tcPr marL="88900" marR="88900" marT="38100" marB="38100" anchor="ctr">
+                    <a:lnL w="0" cap="flat" cmpd="sng" algn="ctr">
+                      <a:noFill/>
+                    </a:lnL>
+                    <a:lnR w="0" cap="flat" cmpd="sng" algn="ctr">
+                      <a:noFill/>
+                    </a:lnR>
+                    <a:lnT w="0" cap="flat" cmpd="sng" algn="ctr">
+                      <a:noFill/>
+                    </a:lnT>
+                    <a:lnB w="19050" cap="flat" cmpd="sng" algn="ctr">
+                      <a:solidFill>
+                        <a:srgbClr val="1F4E79"/>
+                      </a:solidFill>
+                      <a:prstDash val="solid"/>
+                      <a:round/>
+                      <a:headEnd type="none" w="med" len="med"/>
+                      <a:tailEnd type="none" w="med" len="med"/>
+                    </a:lnB>
+                  </a:tcPr>
+                </a:tc>
+                <a:tc>
+                  <a:txBody>
+                    <a:bodyPr/>
+                    <a:lstStyle/>
+                    <a:p>
+                      <a:pPr indent="0" marL="0">
+                        <a:buNone/>
+                      </a:pPr>
+                      <a:r>
+                        <a:rPr lang="en-US" sz="1500" b="1" dirty="0">
+                          <a:solidFill>
+                            <a:srgbClr val="1F4E79"/>
+                          </a:solidFill>
+                          <a:latin typeface="Yu Gothic" pitchFamily="34" charset="0"/>
+                          <a:ea typeface="Yu Gothic" pitchFamily="34" charset="-122"/>
+                          <a:cs typeface="Yu Gothic" pitchFamily="34" charset="-120"/>
+                        </a:rPr>
+                        <a:t>続ける条件</a:t>
+                      </a:r>
+                      <a:endParaRPr lang="en-US" sz="1500" dirty="0">
+                        <a:latin typeface="Yu Gothic" charset="0"/>
+                        <a:ea typeface="Yu Gothic" charset="0"/>
+                        <a:cs typeface="Yu Gothic" charset="0"/>
+                      </a:endParaRPr>
+                    </a:p>
+                  </a:txBody>
+                  <a:tcPr marL="88900" marR="88900" marT="38100" marB="38100" anchor="ctr">
+                    <a:lnL w="0" cap="flat" cmpd="sng" algn="ctr">
+                      <a:noFill/>
+                    </a:lnL>
+                    <a:lnR w="0" cap="flat" cmpd="sng" algn="ctr">
+                      <a:noFill/>
+                    </a:lnR>
+                    <a:lnT w="0" cap="flat" cmpd="sng" algn="ctr">
+                      <a:noFill/>
+                    </a:lnT>
+                    <a:lnB w="19050" cap="flat" cmpd="sng" algn="ctr">
+                      <a:solidFill>
+                        <a:srgbClr val="1F4E79"/>
+                      </a:solidFill>
+                      <a:prstDash val="solid"/>
+                      <a:round/>
+                      <a:headEnd type="none" w="med" len="med"/>
+                      <a:tailEnd type="none" w="med" len="med"/>
+                    </a:lnB>
+                  </a:tcPr>
+                </a:tc>
+              </a:tr>
+              <a:tr h="713232">
+                <a:tc>
+                  <a:txBody>
+                    <a:bodyPr/>
+                    <a:lstStyle/>
+                    <a:p>
+                      <a:pPr indent="0" marL="0">
+                        <a:buNone/>
+                      </a:pPr>
+                      <a:r>
+                        <a:rPr lang="en-US" sz="1400" b="1" dirty="0">
+                          <a:solidFill>
+                            <a:srgbClr val="1F4E79"/>
+                          </a:solidFill>
+                          <a:latin typeface="Yu Gothic" pitchFamily="34" charset="0"/>
+                          <a:ea typeface="Yu Gothic" pitchFamily="34" charset="-122"/>
+                          <a:cs typeface="Yu Gothic" pitchFamily="34" charset="-120"/>
+                        </a:rPr>
+                        <a:t>A. 分析（最初に回す）</a:t>
+                      </a:r>
+                      <a:endParaRPr lang="en-US" sz="1400" dirty="0">
+                        <a:latin typeface="Yu Gothic" charset="0"/>
+                        <a:ea typeface="Yu Gothic" charset="0"/>
+                        <a:cs typeface="Yu Gothic" charset="0"/>
+                      </a:endParaRPr>
+                    </a:p>
+                  </a:txBody>
+                  <a:tcPr marL="88900" marR="88900" marT="38100" marB="38100" anchor="ctr">
+                    <a:lnL w="0" cap="flat" cmpd="sng" algn="ctr">
+                      <a:noFill/>
+                    </a:lnL>
+                    <a:lnR w="0" cap="flat" cmpd="sng" algn="ctr">
+                      <a:noFill/>
+                    </a:lnR>
+                    <a:lnT w="0" cap="flat" cmpd="sng" algn="ctr">
+                      <a:noFill/>
+                    </a:lnT>
+                    <a:lnB w="9525" cap="flat" cmpd="sng" algn="ctr">
+                      <a:solidFill>
+                        <a:srgbClr val="CCCCCC"/>
+                      </a:solidFill>
+                      <a:prstDash val="solid"/>
+                      <a:round/>
+                      <a:headEnd type="none" w="med" len="med"/>
+                      <a:tailEnd type="none" w="med" len="med"/>
+                    </a:lnB>
+                  </a:tcPr>
+                </a:tc>
+                <a:tc>
+                  <a:txBody>
+                    <a:bodyPr/>
+                    <a:lstStyle/>
+                    <a:p>
+                      <a:pPr indent="0" marL="0">
+                        <a:buNone/>
+                      </a:pPr>
+                      <a:r>
+                        <a:rPr lang="en-US" sz="1400" dirty="0">
+                          <a:solidFill>
+                            <a:srgbClr val="2D2D2D"/>
+                          </a:solidFill>
+                          <a:latin typeface="Yu Gothic" pitchFamily="34" charset="0"/>
+                          <a:ea typeface="Yu Gothic" pitchFamily="34" charset="-122"/>
+                          <a:cs typeface="Yu Gothic" pitchFamily="34" charset="-120"/>
+                        </a:rPr>
+                        <a:t>自然な声に近いほど、どの認識器でも誤りが減る</a:t>
+                      </a:r>
+                      <a:endParaRPr lang="en-US" sz="1400" dirty="0">
+                        <a:latin typeface="Yu Gothic" charset="0"/>
+                        <a:ea typeface="Yu Gothic" charset="0"/>
+                        <a:cs typeface="Yu Gothic" charset="0"/>
+                      </a:endParaRPr>
+                    </a:p>
+                  </a:txBody>
+                  <a:tcPr marL="88900" marR="88900" marT="38100" marB="38100" anchor="ctr">
+                    <a:lnL w="0" cap="flat" cmpd="sng" algn="ctr">
+                      <a:noFill/>
+                    </a:lnL>
+                    <a:lnR w="0" cap="flat" cmpd="sng" algn="ctr">
+                      <a:noFill/>
+                    </a:lnR>
+                    <a:lnT w="0" cap="flat" cmpd="sng" algn="ctr">
+                      <a:noFill/>
+                    </a:lnT>
+                    <a:lnB w="9525" cap="flat" cmpd="sng" algn="ctr">
+                      <a:solidFill>
+                        <a:srgbClr val="CCCCCC"/>
+                      </a:solidFill>
+                      <a:prstDash val="solid"/>
+                      <a:round/>
+                      <a:headEnd type="none" w="med" len="med"/>
+                      <a:tailEnd type="none" w="med" len="med"/>
+                    </a:lnB>
+                  </a:tcPr>
+                </a:tc>
+                <a:tc>
+                  <a:txBody>
+                    <a:bodyPr/>
+                    <a:lstStyle/>
+                    <a:p>
+                      <a:pPr indent="0" marL="0">
+                        <a:buNone/>
+                      </a:pPr>
+                      <a:r>
+                        <a:rPr lang="en-US" sz="1400" dirty="0">
+                          <a:solidFill>
+                            <a:srgbClr val="2D2D2D"/>
+                          </a:solidFill>
+                          <a:latin typeface="Yu Gothic" pitchFamily="34" charset="0"/>
+                          <a:ea typeface="Yu Gothic" pitchFamily="34" charset="-122"/>
+                          <a:cs typeface="Yu Gothic" pitchFamily="34" charset="-120"/>
+                        </a:rPr>
+                        <a:t>既存の全出力で、自然な声との距離と9認識器の誤りの関係を見る</a:t>
+                      </a:r>
+                      <a:endParaRPr lang="en-US" sz="1400" dirty="0">
+                        <a:latin typeface="Yu Gothic" charset="0"/>
+                        <a:ea typeface="Yu Gothic" charset="0"/>
+                        <a:cs typeface="Yu Gothic" charset="0"/>
+                      </a:endParaRPr>
+                    </a:p>
+                  </a:txBody>
+                  <a:tcPr marL="88900" marR="88900" marT="38100" marB="38100" anchor="ctr">
+                    <a:lnL w="0" cap="flat" cmpd="sng" algn="ctr">
+                      <a:noFill/>
+                    </a:lnL>
+                    <a:lnR w="0" cap="flat" cmpd="sng" algn="ctr">
+                      <a:noFill/>
+                    </a:lnR>
+                    <a:lnT w="0" cap="flat" cmpd="sng" algn="ctr">
+                      <a:noFill/>
+                    </a:lnT>
+                    <a:lnB w="9525" cap="flat" cmpd="sng" algn="ctr">
+                      <a:solidFill>
+                        <a:srgbClr val="CCCCCC"/>
+                      </a:solidFill>
+                      <a:prstDash val="solid"/>
+                      <a:round/>
+                      <a:headEnd type="none" w="med" len="med"/>
+                      <a:tailEnd type="none" w="med" len="med"/>
+                    </a:lnB>
+                  </a:tcPr>
+                </a:tc>
+                <a:tc>
+                  <a:txBody>
+                    <a:bodyPr/>
+                    <a:lstStyle/>
+                    <a:p>
+                      <a:pPr indent="0" marL="0">
+                        <a:buNone/>
+                      </a:pPr>
+                      <a:r>
+                        <a:rPr lang="en-US" sz="1400" dirty="0">
+                          <a:solidFill>
+                            <a:srgbClr val="2D2D2D"/>
+                          </a:solidFill>
+                          <a:latin typeface="Yu Gothic" pitchFamily="34" charset="0"/>
+                          <a:ea typeface="Yu Gothic" pitchFamily="34" charset="-122"/>
+                          <a:cs typeface="Yu Gothic" pitchFamily="34" charset="-120"/>
+                        </a:rPr>
+                        <a:t>関係が明確なら柱に</a:t>
+                      </a:r>
+                      <a:endParaRPr lang="en-US" sz="1400" dirty="0">
+                        <a:latin typeface="Yu Gothic" charset="0"/>
+                        <a:ea typeface="Yu Gothic" charset="0"/>
+                        <a:cs typeface="Yu Gothic" charset="0"/>
+                      </a:endParaRPr>
+                    </a:p>
+                  </a:txBody>
+                  <a:tcPr marL="88900" marR="88900" marT="38100" marB="38100" anchor="ctr">
+                    <a:lnL w="0" cap="flat" cmpd="sng" algn="ctr">
+                      <a:noFill/>
+                    </a:lnL>
+                    <a:lnR w="0" cap="flat" cmpd="sng" algn="ctr">
+                      <a:noFill/>
+                    </a:lnR>
+                    <a:lnT w="0" cap="flat" cmpd="sng" algn="ctr">
+                      <a:noFill/>
+                    </a:lnT>
+                    <a:lnB w="9525" cap="flat" cmpd="sng" algn="ctr">
+                      <a:solidFill>
+                        <a:srgbClr val="CCCCCC"/>
+                      </a:solidFill>
+                      <a:prstDash val="solid"/>
+                      <a:round/>
+                      <a:headEnd type="none" w="med" len="med"/>
+                      <a:tailEnd type="none" w="med" len="med"/>
+                    </a:lnB>
+                  </a:tcPr>
+                </a:tc>
+              </a:tr>
+              <a:tr h="603504">
+                <a:tc>
+                  <a:txBody>
+                    <a:bodyPr/>
+                    <a:lstStyle/>
+                    <a:p>
+                      <a:pPr indent="0" marL="0">
+                        <a:buNone/>
+                      </a:pPr>
+                      <a:r>
+                        <a:rPr lang="en-US" sz="1400" b="1" dirty="0">
+                          <a:solidFill>
+                            <a:srgbClr val="2D2D2D"/>
+                          </a:solidFill>
+                          <a:latin typeface="Yu Gothic" pitchFamily="34" charset="0"/>
+                          <a:ea typeface="Yu Gothic" pitchFamily="34" charset="-122"/>
+                          <a:cs typeface="Yu Gothic" pitchFamily="34" charset="-120"/>
+                        </a:rPr>
+                        <a:t>B. 事前学習</a:t>
+                      </a:r>
+                      <a:endParaRPr lang="en-US" sz="1400" dirty="0">
+                        <a:latin typeface="Yu Gothic" charset="0"/>
+                        <a:ea typeface="Yu Gothic" charset="0"/>
+                        <a:cs typeface="Yu Gothic" charset="0"/>
+                      </a:endParaRPr>
+                    </a:p>
+                  </a:txBody>
+                  <a:tcPr marL="88900" marR="88900" marT="38100" marB="38100" anchor="ctr">
+                    <a:lnL w="0" cap="flat" cmpd="sng" algn="ctr">
+                      <a:noFill/>
+                    </a:lnL>
+                    <a:lnR w="0" cap="flat" cmpd="sng" algn="ctr">
+                      <a:noFill/>
+                    </a:lnR>
+                    <a:lnT w="0" cap="flat" cmpd="sng" algn="ctr">
+                      <a:noFill/>
+                    </a:lnT>
+                    <a:lnB w="9525" cap="flat" cmpd="sng" algn="ctr">
+                      <a:solidFill>
+                        <a:srgbClr val="CCCCCC"/>
+                      </a:solidFill>
+                      <a:prstDash val="solid"/>
+                      <a:round/>
+                      <a:headEnd type="none" w="med" len="med"/>
+                      <a:tailEnd type="none" w="med" len="med"/>
+                    </a:lnB>
+                  </a:tcPr>
+                </a:tc>
+                <a:tc>
+                  <a:txBody>
+                    <a:bodyPr/>
+                    <a:lstStyle/>
+                    <a:p>
+                      <a:pPr indent="0" marL="0">
+                        <a:buNone/>
+                      </a:pPr>
+                      <a:r>
+                        <a:rPr lang="en-US" sz="1400" dirty="0">
+                          <a:solidFill>
+                            <a:srgbClr val="2D2D2D"/>
+                          </a:solidFill>
+                          <a:latin typeface="Yu Gothic" pitchFamily="34" charset="0"/>
+                          <a:ea typeface="Yu Gothic" pitchFamily="34" charset="-122"/>
+                          <a:cs typeface="Yu Gothic" pitchFamily="34" charset="-120"/>
+                        </a:rPr>
+                        <a:t>効いているのは生成でなく、事前学習の知識</a:t>
+                      </a:r>
+                      <a:endParaRPr lang="en-US" sz="1400" dirty="0">
+                        <a:latin typeface="Yu Gothic" charset="0"/>
+                        <a:ea typeface="Yu Gothic" charset="0"/>
+                        <a:cs typeface="Yu Gothic" charset="0"/>
+                      </a:endParaRPr>
+                    </a:p>
+                  </a:txBody>
+                  <a:tcPr marL="88900" marR="88900" marT="38100" marB="38100" anchor="ctr">
+                    <a:lnL w="0" cap="flat" cmpd="sng" algn="ctr">
+                      <a:noFill/>
+                    </a:lnL>
+                    <a:lnR w="0" cap="flat" cmpd="sng" algn="ctr">
+                      <a:noFill/>
+                    </a:lnR>
+                    <a:lnT w="0" cap="flat" cmpd="sng" algn="ctr">
+                      <a:noFill/>
+                    </a:lnT>
+                    <a:lnB w="9525" cap="flat" cmpd="sng" algn="ctr">
+                      <a:solidFill>
+                        <a:srgbClr val="CCCCCC"/>
+                      </a:solidFill>
+                      <a:prstDash val="solid"/>
+                      <a:round/>
+                      <a:headEnd type="none" w="med" len="med"/>
+                      <a:tailEnd type="none" w="med" len="med"/>
+                    </a:lnB>
+                  </a:tcPr>
+                </a:tc>
+                <a:tc>
+                  <a:txBody>
+                    <a:bodyPr/>
+                    <a:lstStyle/>
+                    <a:p>
+                      <a:pPr indent="0" marL="0">
+                        <a:buNone/>
+                      </a:pPr>
+                      <a:r>
+                        <a:rPr lang="en-US" sz="1400" dirty="0">
+                          <a:solidFill>
+                            <a:srgbClr val="2D2D2D"/>
+                          </a:solidFill>
+                          <a:latin typeface="Yu Gothic" pitchFamily="34" charset="0"/>
+                          <a:ea typeface="Yu Gothic" pitchFamily="34" charset="-122"/>
+                          <a:cs typeface="Yu Gothic" pitchFamily="34" charset="-120"/>
+                        </a:rPr>
+                        <a:t>事前学習なしの対照／1段で出力する版</a:t>
+                      </a:r>
+                      <a:endParaRPr lang="en-US" sz="1400" dirty="0">
+                        <a:latin typeface="Yu Gothic" charset="0"/>
+                        <a:ea typeface="Yu Gothic" charset="0"/>
+                        <a:cs typeface="Yu Gothic" charset="0"/>
+                      </a:endParaRPr>
+                    </a:p>
+                  </a:txBody>
+                  <a:tcPr marL="88900" marR="88900" marT="38100" marB="38100" anchor="ctr">
+                    <a:lnL w="0" cap="flat" cmpd="sng" algn="ctr">
+                      <a:noFill/>
+                    </a:lnL>
+                    <a:lnR w="0" cap="flat" cmpd="sng" algn="ctr">
+                      <a:noFill/>
+                    </a:lnR>
+                    <a:lnT w="0" cap="flat" cmpd="sng" algn="ctr">
+                      <a:noFill/>
+                    </a:lnT>
+                    <a:lnB w="9525" cap="flat" cmpd="sng" algn="ctr">
+                      <a:solidFill>
+                        <a:srgbClr val="CCCCCC"/>
+                      </a:solidFill>
+                      <a:prstDash val="solid"/>
+                      <a:round/>
+                      <a:headEnd type="none" w="med" len="med"/>
+                      <a:tailEnd type="none" w="med" len="med"/>
+                    </a:lnB>
+                  </a:tcPr>
+                </a:tc>
+                <a:tc>
+                  <a:txBody>
+                    <a:bodyPr/>
+                    <a:lstStyle/>
+                    <a:p>
+                      <a:pPr indent="0" marL="0">
+                        <a:buNone/>
+                      </a:pPr>
+                      <a:r>
+                        <a:rPr lang="en-US" sz="1400" dirty="0">
+                          <a:solidFill>
+                            <a:srgbClr val="2D2D2D"/>
+                          </a:solidFill>
+                          <a:latin typeface="Yu Gothic" pitchFamily="34" charset="0"/>
+                          <a:ea typeface="Yu Gothic" pitchFamily="34" charset="-122"/>
+                          <a:cs typeface="Yu Gothic" pitchFamily="34" charset="-120"/>
+                        </a:rPr>
+                        <a:t>事前学習ありが大差</a:t>
+                      </a:r>
+                      <a:endParaRPr lang="en-US" sz="1400" dirty="0">
+                        <a:latin typeface="Yu Gothic" charset="0"/>
+                        <a:ea typeface="Yu Gothic" charset="0"/>
+                        <a:cs typeface="Yu Gothic" charset="0"/>
+                      </a:endParaRPr>
+                    </a:p>
+                  </a:txBody>
+                  <a:tcPr marL="88900" marR="88900" marT="38100" marB="38100" anchor="ctr">
+                    <a:lnL w="0" cap="flat" cmpd="sng" algn="ctr">
+                      <a:noFill/>
+                    </a:lnL>
+                    <a:lnR w="0" cap="flat" cmpd="sng" algn="ctr">
+                      <a:noFill/>
+                    </a:lnR>
+                    <a:lnT w="0" cap="flat" cmpd="sng" algn="ctr">
+                      <a:noFill/>
+                    </a:lnT>
+                    <a:lnB w="9525" cap="flat" cmpd="sng" algn="ctr">
+                      <a:solidFill>
+                        <a:srgbClr val="CCCCCC"/>
+                      </a:solidFill>
+                      <a:prstDash val="solid"/>
+                      <a:round/>
+                      <a:headEnd type="none" w="med" len="med"/>
+                      <a:tailEnd type="none" w="med" len="med"/>
+                    </a:lnB>
+                  </a:tcPr>
+                </a:tc>
+              </a:tr>
+              <a:tr h="603504">
+                <a:tc>
+                  <a:txBody>
+                    <a:bodyPr/>
+                    <a:lstStyle/>
+                    <a:p>
+                      <a:pPr indent="0" marL="0">
+                        <a:buNone/>
+                      </a:pPr>
+                      <a:r>
+                        <a:rPr lang="en-US" sz="1400" b="1" dirty="0">
+                          <a:solidFill>
+                            <a:srgbClr val="2D2D2D"/>
+                          </a:solidFill>
+                          <a:latin typeface="Yu Gothic" pitchFamily="34" charset="0"/>
+                          <a:ea typeface="Yu Gothic" pitchFamily="34" charset="-122"/>
+                          <a:cs typeface="Yu Gothic" pitchFamily="34" charset="-120"/>
+                        </a:rPr>
+                        <a:t>C. 生成のさせ方</a:t>
+                      </a:r>
+                      <a:endParaRPr lang="en-US" sz="1400" dirty="0">
+                        <a:latin typeface="Yu Gothic" charset="0"/>
+                        <a:ea typeface="Yu Gothic" charset="0"/>
+                        <a:cs typeface="Yu Gothic" charset="0"/>
+                      </a:endParaRPr>
+                    </a:p>
+                  </a:txBody>
+                  <a:tcPr marL="88900" marR="88900" marT="38100" marB="38100" anchor="ctr">
+                    <a:lnL w="0" cap="flat" cmpd="sng" algn="ctr">
+                      <a:noFill/>
+                    </a:lnL>
+                    <a:lnR w="0" cap="flat" cmpd="sng" algn="ctr">
+                      <a:noFill/>
+                    </a:lnR>
+                    <a:lnT w="0" cap="flat" cmpd="sng" algn="ctr">
+                      <a:noFill/>
+                    </a:lnT>
+                    <a:lnB w="9525" cap="flat" cmpd="sng" algn="ctr">
+                      <a:solidFill>
+                        <a:srgbClr val="CCCCCC"/>
+                      </a:solidFill>
+                      <a:prstDash val="solid"/>
+                      <a:round/>
+                      <a:headEnd type="none" w="med" len="med"/>
+                      <a:tailEnd type="none" w="med" len="med"/>
+                    </a:lnB>
+                  </a:tcPr>
+                </a:tc>
+                <a:tc>
+                  <a:txBody>
+                    <a:bodyPr/>
+                    <a:lstStyle/>
+                    <a:p>
+                      <a:pPr indent="0" marL="0">
+                        <a:buNone/>
+                      </a:pPr>
+                      <a:r>
+                        <a:rPr lang="en-US" sz="1400" dirty="0">
+                          <a:solidFill>
+                            <a:srgbClr val="2D2D2D"/>
+                          </a:solidFill>
+                          <a:latin typeface="Yu Gothic" pitchFamily="34" charset="0"/>
+                          <a:ea typeface="Yu Gothic" pitchFamily="34" charset="-122"/>
+                          <a:cs typeface="Yu Gothic" pitchFamily="34" charset="-120"/>
+                        </a:rPr>
+                        <a:t>生成のばらつきが誤りの原因</a:t>
+                      </a:r>
+                      <a:endParaRPr lang="en-US" sz="1400" dirty="0">
+                        <a:latin typeface="Yu Gothic" charset="0"/>
+                        <a:ea typeface="Yu Gothic" charset="0"/>
+                        <a:cs typeface="Yu Gothic" charset="0"/>
+                      </a:endParaRPr>
+                    </a:p>
+                  </a:txBody>
+                  <a:tcPr marL="88900" marR="88900" marT="38100" marB="38100" anchor="ctr">
+                    <a:lnL w="0" cap="flat" cmpd="sng" algn="ctr">
+                      <a:noFill/>
+                    </a:lnL>
+                    <a:lnR w="0" cap="flat" cmpd="sng" algn="ctr">
+                      <a:noFill/>
+                    </a:lnR>
+                    <a:lnT w="0" cap="flat" cmpd="sng" algn="ctr">
+                      <a:noFill/>
+                    </a:lnT>
+                    <a:lnB w="9525" cap="flat" cmpd="sng" algn="ctr">
+                      <a:solidFill>
+                        <a:srgbClr val="CCCCCC"/>
+                      </a:solidFill>
+                      <a:prstDash val="solid"/>
+                      <a:round/>
+                      <a:headEnd type="none" w="med" len="med"/>
+                      <a:tailEnd type="none" w="med" len="med"/>
+                    </a:lnB>
+                  </a:tcPr>
+                </a:tc>
+                <a:tc>
+                  <a:txBody>
+                    <a:bodyPr/>
+                    <a:lstStyle/>
+                    <a:p>
+                      <a:pPr indent="0" marL="0">
+                        <a:buNone/>
+                      </a:pPr>
+                      <a:r>
+                        <a:rPr lang="en-US" sz="1400" dirty="0">
+                          <a:solidFill>
+                            <a:srgbClr val="2D2D2D"/>
+                          </a:solidFill>
+                          <a:latin typeface="Yu Gothic" pitchFamily="34" charset="0"/>
+                          <a:ea typeface="Yu Gothic" pitchFamily="34" charset="-122"/>
+                          <a:cs typeface="Yu Gothic" pitchFamily="34" charset="-120"/>
+                        </a:rPr>
+                        <a:t>シード違いのばらつきと誤りの関係</a:t>
+                      </a:r>
+                      <a:endParaRPr lang="en-US" sz="1400" dirty="0">
+                        <a:latin typeface="Yu Gothic" charset="0"/>
+                        <a:ea typeface="Yu Gothic" charset="0"/>
+                        <a:cs typeface="Yu Gothic" charset="0"/>
+                      </a:endParaRPr>
+                    </a:p>
+                  </a:txBody>
+                  <a:tcPr marL="88900" marR="88900" marT="38100" marB="38100" anchor="ctr">
+                    <a:lnL w="0" cap="flat" cmpd="sng" algn="ctr">
+                      <a:noFill/>
+                    </a:lnL>
+                    <a:lnR w="0" cap="flat" cmpd="sng" algn="ctr">
+                      <a:noFill/>
+                    </a:lnR>
+                    <a:lnT w="0" cap="flat" cmpd="sng" algn="ctr">
+                      <a:noFill/>
+                    </a:lnT>
+                    <a:lnB w="9525" cap="flat" cmpd="sng" algn="ctr">
+                      <a:solidFill>
+                        <a:srgbClr val="CCCCCC"/>
+                      </a:solidFill>
+                      <a:prstDash val="solid"/>
+                      <a:round/>
+                      <a:headEnd type="none" w="med" len="med"/>
+                      <a:tailEnd type="none" w="med" len="med"/>
+                    </a:lnB>
+                  </a:tcPr>
+                </a:tc>
+                <a:tc>
+                  <a:txBody>
+                    <a:bodyPr/>
+                    <a:lstStyle/>
+                    <a:p>
+                      <a:pPr indent="0" marL="0">
+                        <a:buNone/>
+                      </a:pPr>
+                      <a:r>
+                        <a:rPr lang="en-US" sz="1400" dirty="0">
+                          <a:solidFill>
+                            <a:srgbClr val="2D2D2D"/>
+                          </a:solidFill>
+                          <a:latin typeface="Yu Gothic" pitchFamily="34" charset="0"/>
+                          <a:ea typeface="Yu Gothic" pitchFamily="34" charset="-122"/>
+                          <a:cs typeface="Yu Gothic" pitchFamily="34" charset="-120"/>
+                        </a:rPr>
+                        <a:t>両者が連動</a:t>
+                      </a:r>
+                      <a:endParaRPr lang="en-US" sz="1400" dirty="0">
+                        <a:latin typeface="Yu Gothic" charset="0"/>
+                        <a:ea typeface="Yu Gothic" charset="0"/>
+                        <a:cs typeface="Yu Gothic" charset="0"/>
+                      </a:endParaRPr>
+                    </a:p>
+                  </a:txBody>
+                  <a:tcPr marL="88900" marR="88900" marT="38100" marB="38100" anchor="ctr">
+                    <a:lnL w="0" cap="flat" cmpd="sng" algn="ctr">
+                      <a:noFill/>
+                    </a:lnL>
+                    <a:lnR w="0" cap="flat" cmpd="sng" algn="ctr">
+                      <a:noFill/>
+                    </a:lnR>
+                    <a:lnT w="0" cap="flat" cmpd="sng" algn="ctr">
+                      <a:noFill/>
+                    </a:lnT>
+                    <a:lnB w="9525" cap="flat" cmpd="sng" algn="ctr">
+                      <a:solidFill>
+                        <a:srgbClr val="CCCCCC"/>
+                      </a:solidFill>
+                      <a:prstDash val="solid"/>
+                      <a:round/>
+                      <a:headEnd type="none" w="med" len="med"/>
+                      <a:tailEnd type="none" w="med" len="med"/>
+                    </a:lnB>
+                  </a:tcPr>
+                </a:tc>
+              </a:tr>
+              <a:tr h="713232">
+                <a:tc>
+                  <a:txBody>
+                    <a:bodyPr/>
+                    <a:lstStyle/>
+                    <a:p>
+                      <a:pPr indent="0" marL="0">
+                        <a:buNone/>
+                      </a:pPr>
+                      <a:r>
+                        <a:rPr lang="en-US" sz="1400" b="1" dirty="0">
+                          <a:solidFill>
+                            <a:srgbClr val="2D2D2D"/>
+                          </a:solidFill>
+                          <a:latin typeface="Yu Gothic" pitchFamily="34" charset="0"/>
+                          <a:ea typeface="Yu Gothic" pitchFamily="34" charset="-122"/>
+                          <a:cs typeface="Yu Gothic" pitchFamily="34" charset="-120"/>
+                        </a:rPr>
+                        <a:t>D. 損失の設計</a:t>
+                      </a:r>
+                      <a:endParaRPr lang="en-US" sz="1400" dirty="0">
+                        <a:latin typeface="Yu Gothic" charset="0"/>
+                        <a:ea typeface="Yu Gothic" charset="0"/>
+                        <a:cs typeface="Yu Gothic" charset="0"/>
+                      </a:endParaRPr>
+                    </a:p>
+                  </a:txBody>
+                  <a:tcPr marL="88900" marR="88900" marT="38100" marB="38100" anchor="ctr">
+                    <a:lnL w="0" cap="flat" cmpd="sng" algn="ctr">
+                      <a:noFill/>
+                    </a:lnL>
+                    <a:lnR w="0" cap="flat" cmpd="sng" algn="ctr">
+                      <a:noFill/>
+                    </a:lnR>
+                    <a:lnT w="0" cap="flat" cmpd="sng" algn="ctr">
+                      <a:noFill/>
+                    </a:lnT>
+                    <a:lnB w="9525" cap="flat" cmpd="sng" algn="ctr">
+                      <a:solidFill>
+                        <a:srgbClr val="CCCCCC"/>
+                      </a:solidFill>
+                      <a:prstDash val="solid"/>
+                      <a:round/>
+                      <a:headEnd type="none" w="med" len="med"/>
+                      <a:tailEnd type="none" w="med" len="med"/>
+                    </a:lnB>
+                  </a:tcPr>
+                </a:tc>
+                <a:tc>
+                  <a:txBody>
+                    <a:bodyPr/>
+                    <a:lstStyle/>
+                    <a:p>
+                      <a:pPr indent="0" marL="0">
+                        <a:buNone/>
+                      </a:pPr>
+                      <a:r>
+                        <a:rPr lang="en-US" sz="1400" dirty="0">
+                          <a:solidFill>
+                            <a:srgbClr val="2D2D2D"/>
+                          </a:solidFill>
+                          <a:latin typeface="Yu Gothic" pitchFamily="34" charset="0"/>
+                          <a:ea typeface="Yu Gothic" pitchFamily="34" charset="-122"/>
+                          <a:cs typeface="Yu Gothic" pitchFamily="34" charset="-120"/>
+                        </a:rPr>
+                        <a:t>自然な声との距離を損失にすれば軽くても効く</a:t>
+                      </a:r>
+                      <a:endParaRPr lang="en-US" sz="1400" dirty="0">
+                        <a:latin typeface="Yu Gothic" charset="0"/>
+                        <a:ea typeface="Yu Gothic" charset="0"/>
+                        <a:cs typeface="Yu Gothic" charset="0"/>
+                      </a:endParaRPr>
+                    </a:p>
+                  </a:txBody>
+                  <a:tcPr marL="88900" marR="88900" marT="38100" marB="38100" anchor="ctr">
+                    <a:lnL w="0" cap="flat" cmpd="sng" algn="ctr">
+                      <a:noFill/>
+                    </a:lnL>
+                    <a:lnR w="0" cap="flat" cmpd="sng" algn="ctr">
+                      <a:noFill/>
+                    </a:lnR>
+                    <a:lnT w="0" cap="flat" cmpd="sng" algn="ctr">
+                      <a:noFill/>
+                    </a:lnT>
+                    <a:lnB w="9525" cap="flat" cmpd="sng" algn="ctr">
+                      <a:solidFill>
+                        <a:srgbClr val="CCCCCC"/>
+                      </a:solidFill>
+                      <a:prstDash val="solid"/>
+                      <a:round/>
+                      <a:headEnd type="none" w="med" len="med"/>
+                      <a:tailEnd type="none" w="med" len="med"/>
+                    </a:lnB>
+                  </a:tcPr>
+                </a:tc>
+                <a:tc>
+                  <a:txBody>
+                    <a:bodyPr/>
+                    <a:lstStyle/>
+                    <a:p>
+                      <a:pPr indent="0" marL="0">
+                        <a:buNone/>
+                      </a:pPr>
+                      <a:r>
+                        <a:rPr lang="en-US" sz="1400" dirty="0">
+                          <a:solidFill>
+                            <a:srgbClr val="2D2D2D"/>
+                          </a:solidFill>
+                          <a:latin typeface="Yu Gothic" pitchFamily="34" charset="0"/>
+                          <a:ea typeface="Yu Gothic" pitchFamily="34" charset="-122"/>
+                          <a:cs typeface="Yu Gothic" pitchFamily="34" charset="-120"/>
+                        </a:rPr>
+                        <a:t>SSL表現の損失などを9認識器で評価</a:t>
+                      </a:r>
+                      <a:endParaRPr lang="en-US" sz="1400" dirty="0">
+                        <a:latin typeface="Yu Gothic" charset="0"/>
+                        <a:ea typeface="Yu Gothic" charset="0"/>
+                        <a:cs typeface="Yu Gothic" charset="0"/>
+                      </a:endParaRPr>
+                    </a:p>
+                  </a:txBody>
+                  <a:tcPr marL="88900" marR="88900" marT="38100" marB="38100" anchor="ctr">
+                    <a:lnL w="0" cap="flat" cmpd="sng" algn="ctr">
+                      <a:noFill/>
+                    </a:lnL>
+                    <a:lnR w="0" cap="flat" cmpd="sng" algn="ctr">
+                      <a:noFill/>
+                    </a:lnR>
+                    <a:lnT w="0" cap="flat" cmpd="sng" algn="ctr">
+                      <a:noFill/>
+                    </a:lnT>
+                    <a:lnB w="9525" cap="flat" cmpd="sng" algn="ctr">
+                      <a:solidFill>
+                        <a:srgbClr val="CCCCCC"/>
+                      </a:solidFill>
+                      <a:prstDash val="solid"/>
+                      <a:round/>
+                      <a:headEnd type="none" w="med" len="med"/>
+                      <a:tailEnd type="none" w="med" len="med"/>
+                    </a:lnB>
+                  </a:tcPr>
+                </a:tc>
+                <a:tc>
+                  <a:txBody>
+                    <a:bodyPr/>
+                    <a:lstStyle/>
+                    <a:p>
+                      <a:pPr indent="0" marL="0">
+                        <a:buNone/>
+                      </a:pPr>
+                      <a:r>
+                        <a:rPr lang="en-US" sz="1400" dirty="0">
+                          <a:solidFill>
+                            <a:srgbClr val="2D2D2D"/>
+                          </a:solidFill>
+                          <a:latin typeface="Yu Gothic" pitchFamily="34" charset="0"/>
+                          <a:ea typeface="Yu Gothic" pitchFamily="34" charset="-122"/>
+                          <a:cs typeface="Yu Gothic" pitchFamily="34" charset="-120"/>
+                        </a:rPr>
+                        <a:t>生成モデルに近づく</a:t>
+                      </a:r>
+                      <a:endParaRPr lang="en-US" sz="1400" dirty="0">
+                        <a:latin typeface="Yu Gothic" charset="0"/>
+                        <a:ea typeface="Yu Gothic" charset="0"/>
+                        <a:cs typeface="Yu Gothic" charset="0"/>
+                      </a:endParaRPr>
+                    </a:p>
+                  </a:txBody>
+                  <a:tcPr marL="88900" marR="88900" marT="38100" marB="38100" anchor="ctr">
+                    <a:lnL w="0" cap="flat" cmpd="sng" algn="ctr">
+                      <a:noFill/>
+                    </a:lnL>
+                    <a:lnR w="0" cap="flat" cmpd="sng" algn="ctr">
+                      <a:noFill/>
+                    </a:lnR>
+                    <a:lnT w="0" cap="flat" cmpd="sng" algn="ctr">
+                      <a:noFill/>
+                    </a:lnT>
+                    <a:lnB w="9525" cap="flat" cmpd="sng" algn="ctr">
+                      <a:solidFill>
+                        <a:srgbClr val="CCCCCC"/>
+                      </a:solidFill>
+                      <a:prstDash val="solid"/>
+                      <a:round/>
+                      <a:headEnd type="none" w="med" len="med"/>
+                      <a:tailEnd type="none" w="med" len="med"/>
+                    </a:lnB>
+                  </a:tcPr>
+                </a:tc>
+              </a:tr>
+              <a:tr h="603504">
+                <a:tc>
+                  <a:txBody>
+                    <a:bodyPr/>
+                    <a:lstStyle/>
+                    <a:p>
+                      <a:pPr indent="0" marL="0">
+                        <a:buNone/>
+                      </a:pPr>
+                      <a:r>
+                        <a:rPr lang="en-US" sz="1400" b="1" dirty="0">
+                          <a:solidFill>
+                            <a:srgbClr val="2D2D2D"/>
+                          </a:solidFill>
+                          <a:latin typeface="Yu Gothic" pitchFamily="34" charset="0"/>
+                          <a:ea typeface="Yu Gothic" pitchFamily="34" charset="-122"/>
+                          <a:cs typeface="Yu Gothic" pitchFamily="34" charset="-120"/>
+                        </a:rPr>
+                        <a:t>E. 軽量化</a:t>
+                      </a:r>
+                      <a:endParaRPr lang="en-US" sz="1400" dirty="0">
+                        <a:latin typeface="Yu Gothic" charset="0"/>
+                        <a:ea typeface="Yu Gothic" charset="0"/>
+                        <a:cs typeface="Yu Gothic" charset="0"/>
+                      </a:endParaRPr>
+                    </a:p>
+                  </a:txBody>
+                  <a:tcPr marL="88900" marR="88900" marT="38100" marB="38100" anchor="ctr">
+                    <a:lnL w="0" cap="flat" cmpd="sng" algn="ctr">
+                      <a:noFill/>
+                    </a:lnL>
+                    <a:lnR w="0" cap="flat" cmpd="sng" algn="ctr">
+                      <a:noFill/>
+                    </a:lnR>
+                    <a:lnT w="0" cap="flat" cmpd="sng" algn="ctr">
+                      <a:noFill/>
+                    </a:lnT>
+                    <a:lnB w="9525" cap="flat" cmpd="sng" algn="ctr">
+                      <a:solidFill>
+                        <a:srgbClr val="CCCCCC"/>
+                      </a:solidFill>
+                      <a:prstDash val="solid"/>
+                      <a:round/>
+                      <a:headEnd type="none" w="med" len="med"/>
+                      <a:tailEnd type="none" w="med" len="med"/>
+                    </a:lnB>
+                  </a:tcPr>
+                </a:tc>
+                <a:tc>
+                  <a:txBody>
+                    <a:bodyPr/>
+                    <a:lstStyle/>
+                    <a:p>
+                      <a:pPr indent="0" marL="0">
+                        <a:buNone/>
+                      </a:pPr>
+                      <a:r>
+                        <a:rPr lang="en-US" sz="1400" dirty="0">
+                          <a:solidFill>
+                            <a:srgbClr val="2D2D2D"/>
+                          </a:solidFill>
+                          <a:latin typeface="Yu Gothic" pitchFamily="34" charset="0"/>
+                          <a:ea typeface="Yu Gothic" pitchFamily="34" charset="-122"/>
+                          <a:cs typeface="Yu Gothic" pitchFamily="34" charset="-120"/>
+                        </a:rPr>
+                        <a:t>良い出力を教師にして、軽いモデルへ移せる</a:t>
+                      </a:r>
+                      <a:endParaRPr lang="en-US" sz="1400" dirty="0">
+                        <a:latin typeface="Yu Gothic" charset="0"/>
+                        <a:ea typeface="Yu Gothic" charset="0"/>
+                        <a:cs typeface="Yu Gothic" charset="0"/>
+                      </a:endParaRPr>
+                    </a:p>
+                  </a:txBody>
+                  <a:tcPr marL="88900" marR="88900" marT="38100" marB="38100" anchor="ctr">
+                    <a:lnL w="0" cap="flat" cmpd="sng" algn="ctr">
+                      <a:noFill/>
+                    </a:lnL>
+                    <a:lnR w="0" cap="flat" cmpd="sng" algn="ctr">
+                      <a:noFill/>
+                    </a:lnR>
+                    <a:lnT w="0" cap="flat" cmpd="sng" algn="ctr">
+                      <a:noFill/>
+                    </a:lnT>
+                    <a:lnB w="9525" cap="flat" cmpd="sng" algn="ctr">
+                      <a:solidFill>
+                        <a:srgbClr val="CCCCCC"/>
+                      </a:solidFill>
+                      <a:prstDash val="solid"/>
+                      <a:round/>
+                      <a:headEnd type="none" w="med" len="med"/>
+                      <a:tailEnd type="none" w="med" len="med"/>
+                    </a:lnB>
+                  </a:tcPr>
+                </a:tc>
+                <a:tc>
+                  <a:txBody>
+                    <a:bodyPr/>
+                    <a:lstStyle/>
+                    <a:p>
+                      <a:pPr indent="0" marL="0">
+                        <a:buNone/>
+                      </a:pPr>
+                      <a:r>
+                        <a:rPr lang="en-US" sz="1400" dirty="0">
+                          <a:solidFill>
+                            <a:srgbClr val="2D2D2D"/>
+                          </a:solidFill>
+                          <a:latin typeface="Yu Gothic" pitchFamily="34" charset="0"/>
+                          <a:ea typeface="Yu Gothic" pitchFamily="34" charset="-122"/>
+                          <a:cs typeface="Yu Gothic" pitchFamily="34" charset="-120"/>
+                        </a:rPr>
+                        <a:t>未学習のデータで教師を作り、蒸留</a:t>
+                      </a:r>
+                      <a:endParaRPr lang="en-US" sz="1400" dirty="0">
+                        <a:latin typeface="Yu Gothic" charset="0"/>
+                        <a:ea typeface="Yu Gothic" charset="0"/>
+                        <a:cs typeface="Yu Gothic" charset="0"/>
+                      </a:endParaRPr>
+                    </a:p>
+                  </a:txBody>
+                  <a:tcPr marL="88900" marR="88900" marT="38100" marB="38100" anchor="ctr">
+                    <a:lnL w="0" cap="flat" cmpd="sng" algn="ctr">
+                      <a:noFill/>
+                    </a:lnL>
+                    <a:lnR w="0" cap="flat" cmpd="sng" algn="ctr">
+                      <a:noFill/>
+                    </a:lnR>
+                    <a:lnT w="0" cap="flat" cmpd="sng" algn="ctr">
+                      <a:noFill/>
+                    </a:lnT>
+                    <a:lnB w="9525" cap="flat" cmpd="sng" algn="ctr">
+                      <a:solidFill>
+                        <a:srgbClr val="CCCCCC"/>
+                      </a:solidFill>
+                      <a:prstDash val="solid"/>
+                      <a:round/>
+                      <a:headEnd type="none" w="med" len="med"/>
+                      <a:tailEnd type="none" w="med" len="med"/>
+                    </a:lnB>
+                  </a:tcPr>
+                </a:tc>
+                <a:tc>
+                  <a:txBody>
+                    <a:bodyPr/>
+                    <a:lstStyle/>
+                    <a:p>
+                      <a:pPr indent="0" marL="0">
+                        <a:buNone/>
+                      </a:pPr>
+                      <a:r>
+                        <a:rPr lang="en-US" sz="1400" dirty="0">
+                          <a:solidFill>
+                            <a:srgbClr val="2D2D2D"/>
+                          </a:solidFill>
+                          <a:latin typeface="Yu Gothic" pitchFamily="34" charset="0"/>
+                          <a:ea typeface="Yu Gothic" pitchFamily="34" charset="-122"/>
+                          <a:cs typeface="Yu Gothic" pitchFamily="34" charset="-120"/>
+                        </a:rPr>
+                        <a:t>効果の大半が残る</a:t>
+                      </a:r>
+                      <a:endParaRPr lang="en-US" sz="1400" dirty="0">
+                        <a:latin typeface="Yu Gothic" charset="0"/>
+                        <a:ea typeface="Yu Gothic" charset="0"/>
+                        <a:cs typeface="Yu Gothic" charset="0"/>
+                      </a:endParaRPr>
+                    </a:p>
+                  </a:txBody>
+                  <a:tcPr marL="88900" marR="88900" marT="38100" marB="38100" anchor="ctr">
+                    <a:lnL w="0" cap="flat" cmpd="sng" algn="ctr">
+                      <a:noFill/>
+                    </a:lnL>
+                    <a:lnR w="0" cap="flat" cmpd="sng" algn="ctr">
+                      <a:noFill/>
+                    </a:lnR>
+                    <a:lnT w="0" cap="flat" cmpd="sng" algn="ctr">
+                      <a:noFill/>
+                    </a:lnT>
+                    <a:lnB w="9525" cap="flat" cmpd="sng" algn="ctr">
+                      <a:solidFill>
+                        <a:srgbClr val="CCCCCC"/>
+                      </a:solidFill>
+                      <a:prstDash val="solid"/>
+                      <a:round/>
+                      <a:headEnd type="none" w="med" len="med"/>
+                      <a:tailEnd type="none" w="med" len="med"/>
+                    </a:lnB>
+                  </a:tcPr>
+                </a:tc>
+              </a:tr>
+            </a:tbl>
+          </a:graphicData>
+        </a:graphic>
+      </p:graphicFrame>
+      <p:sp>
+        <p:nvSpPr>
+          <p:cNvPr id="4" name="Text 1"/>
           <p:cNvSpPr/>
           <p:nvPr/>
         </p:nvSpPr>
         <p:spPr>
           <a:xfrm>
-            <a:off x="548640" y="1463040"/>
-            <a:ext cx="11094415" cy="4572000"/>
+            <a:off x="548640" y="5486400"/>
+            <a:ext cx="11094415" cy="411480"/>
           </a:xfrm>
           <a:prstGeom prst="rect">
             <a:avLst/>
@@ -9515,14 +11173,11 @@
           <a:lstStyle/>
           <a:p>
             <a:pPr marL="228600" indent="-228600">
-              <a:spcAft>
-                <a:spcPts val="1000"/>
-              </a:spcAft>
               <a:buSzPct val="100000"/>
               <a:buChar char="•"/>
             </a:pPr>
             <a:r>
-              <a:rPr lang="en-US" sz="1400" dirty="0">
+              <a:rPr lang="en-US" sz="1700" dirty="0">
                 <a:solidFill>
                   <a:srgbClr val="2D2D2D"/>
                 </a:solidFill>
@@ -9530,135 +11185,48 @@
                 <a:ea typeface="Yu Gothic" pitchFamily="34" charset="-122"/>
                 <a:cs typeface="Yu Gothic" pitchFamily="34" charset="-120"/>
               </a:rPr>
-              <a:t>TAPS: Y. Kim et al., “Throat and acoustic paired speech dataset for deep learning-based speech enhancement,” Scientific Data, 2026.</a:t>
-            </a:r>
-            <a:endParaRPr lang="en-US" sz="1400" dirty="0"/>
-          </a:p>
-          <a:p>
-            <a:pPr marL="228600" indent="-228600">
-              <a:spcAft>
-                <a:spcPts val="1000"/>
-              </a:spcAft>
-              <a:buSzPct val="100000"/>
-              <a:buChar char="•"/>
-            </a:pPr>
-            <a:r>
-              <a:rPr lang="en-US" sz="1400" dirty="0">
-                <a:solidFill>
-                  <a:srgbClr val="2D2D2D"/>
+              <a:t>1週間ごとに「仮説 → 小さな実験 → 9つの認識器で確認 → 続ける／捨てる」を回す</a:t>
+            </a:r>
+            <a:endParaRPr lang="en-US" sz="1700" dirty="0"/>
+          </a:p>
+        </p:txBody>
+      </p:sp>
+      <p:sp>
+        <p:nvSpPr>
+          <p:cNvPr id="5" name="Text 2"/>
+          <p:cNvSpPr/>
+          <p:nvPr/>
+        </p:nvSpPr>
+        <p:spPr>
+          <a:xfrm>
+            <a:off x="548640" y="6309360"/>
+            <a:ext cx="11094415" cy="320040"/>
+          </a:xfrm>
+          <a:prstGeom prst="rect">
+            <a:avLst/>
+          </a:prstGeom>
+          <a:noFill/>
+          <a:ln/>
+        </p:spPr>
+        <p:txBody>
+          <a:bodyPr wrap="square" lIns="0" tIns="0" rIns="0" bIns="0" rtlCol="0" anchor="t"/>
+          <a:lstStyle/>
+          <a:p>
+            <a:pPr indent="0" marL="0">
+              <a:buNone/>
+            </a:pPr>
+            <a:r>
+              <a:rPr lang="en-US" sz="1200" dirty="0">
+                <a:solidFill>
+                  <a:srgbClr val="777777"/>
                 </a:solidFill>
                 <a:latin typeface="Yu Gothic" pitchFamily="34" charset="0"/>
                 <a:ea typeface="Yu Gothic" pitchFamily="34" charset="-122"/>
                 <a:cs typeface="Yu Gothic" pitchFamily="34" charset="-120"/>
               </a:rPr>
-              <a:t>Ku et al., “Generative speech foundation model pretraining for high-quality speech extraction and restoration,” arXiv:2409.16117.</a:t>
-            </a:r>
-            <a:endParaRPr lang="en-US" sz="1400" dirty="0"/>
-          </a:p>
-          <a:p>
-            <a:pPr marL="228600" indent="-228600">
-              <a:spcAft>
-                <a:spcPts val="1000"/>
-              </a:spcAft>
-              <a:buSzPct val="100000"/>
-              <a:buChar char="•"/>
-            </a:pPr>
-            <a:r>
-              <a:rPr lang="en-US" sz="1400" dirty="0">
-                <a:solidFill>
-                  <a:srgbClr val="2D2D2D"/>
-                </a:solidFill>
-                <a:latin typeface="Yu Gothic" pitchFamily="34" charset="0"/>
-                <a:ea typeface="Yu Gothic" pitchFamily="34" charset="-122"/>
-                <a:cs typeface="Yu Gothic" pitchFamily="34" charset="-120"/>
-              </a:rPr>
-              <a:t>山中 涼雅 ほか, “Zero-shot音声変換を用いた咽喉マイク音声の気導音復元に関する初期検討,” 日本音響学会 2026年秋季, 1-Q-42.</a:t>
-            </a:r>
-            <a:endParaRPr lang="en-US" sz="1400" dirty="0"/>
-          </a:p>
-          <a:p>
-            <a:pPr marL="228600" indent="-228600">
-              <a:spcAft>
-                <a:spcPts val="1000"/>
-              </a:spcAft>
-              <a:buSzPct val="100000"/>
-              <a:buChar char="•"/>
-            </a:pPr>
-            <a:r>
-              <a:rPr lang="en-US" sz="1400" dirty="0">
-                <a:solidFill>
-                  <a:srgbClr val="2D2D2D"/>
-                </a:solidFill>
-                <a:latin typeface="Yu Gothic" pitchFamily="34" charset="0"/>
-                <a:ea typeface="Yu Gothic" pitchFamily="34" charset="-122"/>
-                <a:cs typeface="Yu Gothic" pitchFamily="34" charset="-120"/>
-              </a:rPr>
-              <a:t>和田 航次郎 ほか, “咽喉マイク自由発話音声における感情認識の検討,” 日本音響学会 2026年秋季, 1-Q-56.</a:t>
-            </a:r>
-            <a:endParaRPr lang="en-US" sz="1400" dirty="0"/>
-          </a:p>
-          <a:p>
-            <a:pPr marL="228600" indent="-228600">
-              <a:spcAft>
-                <a:spcPts val="1000"/>
-              </a:spcAft>
-              <a:buSzPct val="100000"/>
-              <a:buChar char="•"/>
-            </a:pPr>
-            <a:r>
-              <a:rPr lang="en-US" sz="1400" dirty="0">
-                <a:solidFill>
-                  <a:srgbClr val="2D2D2D"/>
-                </a:solidFill>
-                <a:latin typeface="Yu Gothic" pitchFamily="34" charset="0"/>
-                <a:ea typeface="Yu Gothic" pitchFamily="34" charset="-122"/>
-                <a:cs typeface="Yu Gothic" pitchFamily="34" charset="-120"/>
-              </a:rPr>
-              <a:t>Sato et al., “Generic speech enhancement with self-supervised representation space loss,” arXiv:2507.07631, 2025.</a:t>
-            </a:r>
-            <a:endParaRPr lang="en-US" sz="1400" dirty="0"/>
-          </a:p>
-          <a:p>
-            <a:pPr marL="228600" indent="-228600">
-              <a:spcAft>
-                <a:spcPts val="1000"/>
-              </a:spcAft>
-              <a:buSzPct val="100000"/>
-              <a:buChar char="•"/>
-            </a:pPr>
-            <a:r>
-              <a:rPr lang="en-US" sz="1400" dirty="0">
-                <a:solidFill>
-                  <a:srgbClr val="2D2D2D"/>
-                </a:solidFill>
-                <a:latin typeface="Yu Gothic" pitchFamily="34" charset="0"/>
-                <a:ea typeface="Yu Gothic" pitchFamily="34" charset="-122"/>
-                <a:cs typeface="Yu Gothic" pitchFamily="34" charset="-120"/>
-              </a:rPr>
-              <a:t>J. Hauret et al., arXiv:2508.02974, 2025.（喉マイクのリアルタイム変換、生成モデルとの比較を含む）</a:t>
-            </a:r>
-            <a:endParaRPr lang="en-US" sz="1400" dirty="0"/>
-          </a:p>
-          <a:p>
-            <a:pPr marL="228600" indent="-228600">
-              <a:spcAft>
-                <a:spcPts val="1000"/>
-              </a:spcAft>
-              <a:buSzPct val="100000"/>
-              <a:buChar char="•"/>
-            </a:pPr>
-            <a:r>
-              <a:rPr lang="en-US" sz="1400" dirty="0">
-                <a:solidFill>
-                  <a:srgbClr val="2D2D2D"/>
-                </a:solidFill>
-                <a:latin typeface="Yu Gothic" pitchFamily="34" charset="0"/>
-                <a:ea typeface="Yu Gothic" pitchFamily="34" charset="-122"/>
-                <a:cs typeface="Yu Gothic" pitchFamily="34" charset="-120"/>
-              </a:rPr>
-              <a:t>J. Hauret et al., “Vibravox: A dataset of French speech captured with body-conduction audio sensors,” Speech Communication, 2025.</a:t>
-            </a:r>
-            <a:endParaRPr lang="en-US" sz="1400" dirty="0"/>
+              <a:t>確認はいつも同じ条件: 入力の違う認識器を含む9つ、話者単位の検定、悪化する認識器がないか</a:t>
+            </a:r>
+            <a:endParaRPr lang="en-US" sz="1200" dirty="0"/>
           </a:p>
         </p:txBody>
       </p:sp>

</xml_diff>

<commit_message>
Slides 2026-10: fix goal text line breaks
Co-Authored-By: Claude Opus 5.5 (1M context) <noreply@anthropic.com>
</commit_message>
<xml_diff>
--- a/results/progress_slides_2026-10.pptx
+++ b/results/progress_slides_2026-10.pptx
@@ -9474,7 +9474,7 @@
                 <a:ea typeface="Yu Gothic" pitchFamily="34" charset="-122"/>
                 <a:cs typeface="Yu Gothic" pitchFamily="34" charset="-120"/>
               </a:rPr>
-              <a:t>どの認識器でも誤りが減る喉マイク用の前処理を作り、</a:t>
+              <a:t>どの認識器でも誤りが減る喉マイク用の前処理を作る</a:t>
             </a:r>
             <a:endParaRPr lang="en-US" sz="1800" dirty="0"/>
           </a:p>
@@ -9494,7 +9494,27 @@
                 <a:ea typeface="Yu Gothic" pitchFamily="34" charset="-122"/>
                 <a:cs typeface="Yu Gothic" pitchFamily="34" charset="-120"/>
               </a:rPr>
-              <a:t>なぜ効くかを示す（認識器の重みは変えない）</a:t>
+              <a:t>なぜ効くのかを示す</a:t>
+            </a:r>
+            <a:endParaRPr lang="en-US" sz="1800" dirty="0"/>
+          </a:p>
+          <a:p>
+            <a:pPr indent="0" marL="0">
+              <a:lnSpc>
+                <a:spcPct val="125000"/>
+              </a:lnSpc>
+              <a:buNone/>
+            </a:pPr>
+            <a:r>
+              <a:rPr lang="en-US" sz="1800" dirty="0">
+                <a:solidFill>
+                  <a:srgbClr val="2D2D2D"/>
+                </a:solidFill>
+                <a:latin typeface="Yu Gothic" pitchFamily="34" charset="0"/>
+                <a:ea typeface="Yu Gothic" pitchFamily="34" charset="-122"/>
+                <a:cs typeface="Yu Gothic" pitchFamily="34" charset="-120"/>
+              </a:rPr>
+              <a:t>（認識器の重みは変えない）</a:t>
             </a:r>
             <a:endParaRPr lang="en-US" sz="1800" dirty="0"/>
           </a:p>

</xml_diff>

<commit_message>
Slides 2026-10: redraw the direction map as row bands with arrows so each row reads as one line of reasoning
Co-Authored-By: Claude Opus 5.5 (1M context) <noreply@anthropic.com>
</commit_message>
<xml_diff>
--- a/results/progress_slides_2026-10.pptx
+++ b/results/progress_slides_2026-10.pptx
@@ -9999,1188 +9999,1529 @@
           </a:p>
         </p:txBody>
       </p:sp>
-      <p:graphicFrame>
-        <p:nvGraphicFramePr>
-          <p:cNvPr id="10" name="Table 0"/>
-          <p:cNvGraphicFramePr>
-            <a:graphicFrameLocks noGrp="1"/>
-          </p:cNvGraphicFramePr>
-          <p:nvPr>
-            <p:extLst>
-              <p:ext uri="{D42A27DB-BD31-4B8C-83A1-F6EECF244321}">
-                <p14:modId xmlns:p14="http://schemas.microsoft.com/office/powerpoint/2010/main" val="1579011935"/>
-              </p:ext>
-            </p:extLst>
-          </p:nvPr>
-        </p:nvGraphicFramePr>
-        <p:xfrm>
-          <a:off x="548640" y="1463040"/>
-          <a:ext cx="11094415" cy="914400"/>
-        </p:xfrm>
-        <a:graphic>
-          <a:graphicData uri="http://schemas.openxmlformats.org/drawingml/2006/table">
-            <a:tbl>
-              <a:tblPr/>
-              <a:tblGrid>
-                <a:gridCol w="2286000"/>
-                <a:gridCol w="3291840"/>
-                <a:gridCol w="3474720"/>
-                <a:gridCol w="2041855"/>
-              </a:tblGrid>
-              <a:tr h="457200">
-                <a:tc>
-                  <a:txBody>
-                    <a:bodyPr/>
-                    <a:lstStyle/>
-                    <a:p>
-                      <a:pPr indent="0" marL="0">
-                        <a:buNone/>
-                      </a:pPr>
-                      <a:r>
-                        <a:rPr lang="en-US" sz="1500" b="1" dirty="0">
-                          <a:solidFill>
-                            <a:srgbClr val="1F4E79"/>
-                          </a:solidFill>
-                          <a:latin typeface="Yu Gothic" pitchFamily="34" charset="0"/>
-                          <a:ea typeface="Yu Gothic" pitchFamily="34" charset="-122"/>
-                          <a:cs typeface="Yu Gothic" pitchFamily="34" charset="-120"/>
-                        </a:rPr>
-                        <a:t>方向</a:t>
-                      </a:r>
-                      <a:endParaRPr lang="en-US" sz="1500" dirty="0">
-                        <a:latin typeface="Yu Gothic" charset="0"/>
-                        <a:ea typeface="Yu Gothic" charset="0"/>
-                        <a:cs typeface="Yu Gothic" charset="0"/>
-                      </a:endParaRPr>
-                    </a:p>
-                  </a:txBody>
-                  <a:tcPr marL="88900" marR="88900" marT="38100" marB="38100" anchor="ctr">
-                    <a:lnL w="0" cap="flat" cmpd="sng" algn="ctr">
-                      <a:noFill/>
-                    </a:lnL>
-                    <a:lnR w="0" cap="flat" cmpd="sng" algn="ctr">
-                      <a:noFill/>
-                    </a:lnR>
-                    <a:lnT w="0" cap="flat" cmpd="sng" algn="ctr">
-                      <a:noFill/>
-                    </a:lnT>
-                    <a:lnB w="19050" cap="flat" cmpd="sng" algn="ctr">
-                      <a:solidFill>
-                        <a:srgbClr val="1F4E79"/>
-                      </a:solidFill>
-                      <a:prstDash val="solid"/>
-                      <a:round/>
-                      <a:headEnd type="none" w="med" len="med"/>
-                      <a:tailEnd type="none" w="med" len="med"/>
-                    </a:lnB>
-                  </a:tcPr>
-                </a:tc>
-                <a:tc>
-                  <a:txBody>
-                    <a:bodyPr/>
-                    <a:lstStyle/>
-                    <a:p>
-                      <a:pPr indent="0" marL="0">
-                        <a:buNone/>
-                      </a:pPr>
-                      <a:r>
-                        <a:rPr lang="en-US" sz="1500" b="1" dirty="0">
-                          <a:solidFill>
-                            <a:srgbClr val="1F4E79"/>
-                          </a:solidFill>
-                          <a:latin typeface="Yu Gothic" pitchFamily="34" charset="0"/>
-                          <a:ea typeface="Yu Gothic" pitchFamily="34" charset="-122"/>
-                          <a:cs typeface="Yu Gothic" pitchFamily="34" charset="-120"/>
-                        </a:rPr>
-                        <a:t>確かめる仮説</a:t>
-                      </a:r>
-                      <a:endParaRPr lang="en-US" sz="1500" dirty="0">
-                        <a:latin typeface="Yu Gothic" charset="0"/>
-                        <a:ea typeface="Yu Gothic" charset="0"/>
-                        <a:cs typeface="Yu Gothic" charset="0"/>
-                      </a:endParaRPr>
-                    </a:p>
-                  </a:txBody>
-                  <a:tcPr marL="88900" marR="88900" marT="38100" marB="38100" anchor="ctr">
-                    <a:lnL w="0" cap="flat" cmpd="sng" algn="ctr">
-                      <a:noFill/>
-                    </a:lnL>
-                    <a:lnR w="0" cap="flat" cmpd="sng" algn="ctr">
-                      <a:noFill/>
-                    </a:lnR>
-                    <a:lnT w="0" cap="flat" cmpd="sng" algn="ctr">
-                      <a:noFill/>
-                    </a:lnT>
-                    <a:lnB w="19050" cap="flat" cmpd="sng" algn="ctr">
-                      <a:solidFill>
-                        <a:srgbClr val="1F4E79"/>
-                      </a:solidFill>
-                      <a:prstDash val="solid"/>
-                      <a:round/>
-                      <a:headEnd type="none" w="med" len="med"/>
-                      <a:tailEnd type="none" w="med" len="med"/>
-                    </a:lnB>
-                  </a:tcPr>
-                </a:tc>
-                <a:tc>
-                  <a:txBody>
-                    <a:bodyPr/>
-                    <a:lstStyle/>
-                    <a:p>
-                      <a:pPr indent="0" marL="0">
-                        <a:buNone/>
-                      </a:pPr>
-                      <a:r>
-                        <a:rPr lang="en-US" sz="1500" b="1" dirty="0">
-                          <a:solidFill>
-                            <a:srgbClr val="1F4E79"/>
-                          </a:solidFill>
-                          <a:latin typeface="Yu Gothic" pitchFamily="34" charset="0"/>
-                          <a:ea typeface="Yu Gothic" pitchFamily="34" charset="-122"/>
-                          <a:cs typeface="Yu Gothic" pitchFamily="34" charset="-120"/>
-                        </a:rPr>
-                        <a:t>最初の小さな実験</a:t>
-                      </a:r>
-                      <a:endParaRPr lang="en-US" sz="1500" dirty="0">
-                        <a:latin typeface="Yu Gothic" charset="0"/>
-                        <a:ea typeface="Yu Gothic" charset="0"/>
-                        <a:cs typeface="Yu Gothic" charset="0"/>
-                      </a:endParaRPr>
-                    </a:p>
-                  </a:txBody>
-                  <a:tcPr marL="88900" marR="88900" marT="38100" marB="38100" anchor="ctr">
-                    <a:lnL w="0" cap="flat" cmpd="sng" algn="ctr">
-                      <a:noFill/>
-                    </a:lnL>
-                    <a:lnR w="0" cap="flat" cmpd="sng" algn="ctr">
-                      <a:noFill/>
-                    </a:lnR>
-                    <a:lnT w="0" cap="flat" cmpd="sng" algn="ctr">
-                      <a:noFill/>
-                    </a:lnT>
-                    <a:lnB w="19050" cap="flat" cmpd="sng" algn="ctr">
-                      <a:solidFill>
-                        <a:srgbClr val="1F4E79"/>
-                      </a:solidFill>
-                      <a:prstDash val="solid"/>
-                      <a:round/>
-                      <a:headEnd type="none" w="med" len="med"/>
-                      <a:tailEnd type="none" w="med" len="med"/>
-                    </a:lnB>
-                  </a:tcPr>
-                </a:tc>
-                <a:tc>
-                  <a:txBody>
-                    <a:bodyPr/>
-                    <a:lstStyle/>
-                    <a:p>
-                      <a:pPr indent="0" marL="0">
-                        <a:buNone/>
-                      </a:pPr>
-                      <a:r>
-                        <a:rPr lang="en-US" sz="1500" b="1" dirty="0">
-                          <a:solidFill>
-                            <a:srgbClr val="1F4E79"/>
-                          </a:solidFill>
-                          <a:latin typeface="Yu Gothic" pitchFamily="34" charset="0"/>
-                          <a:ea typeface="Yu Gothic" pitchFamily="34" charset="-122"/>
-                          <a:cs typeface="Yu Gothic" pitchFamily="34" charset="-120"/>
-                        </a:rPr>
-                        <a:t>続ける条件</a:t>
-                      </a:r>
-                      <a:endParaRPr lang="en-US" sz="1500" dirty="0">
-                        <a:latin typeface="Yu Gothic" charset="0"/>
-                        <a:ea typeface="Yu Gothic" charset="0"/>
-                        <a:cs typeface="Yu Gothic" charset="0"/>
-                      </a:endParaRPr>
-                    </a:p>
-                  </a:txBody>
-                  <a:tcPr marL="88900" marR="88900" marT="38100" marB="38100" anchor="ctr">
-                    <a:lnL w="0" cap="flat" cmpd="sng" algn="ctr">
-                      <a:noFill/>
-                    </a:lnL>
-                    <a:lnR w="0" cap="flat" cmpd="sng" algn="ctr">
-                      <a:noFill/>
-                    </a:lnR>
-                    <a:lnT w="0" cap="flat" cmpd="sng" algn="ctr">
-                      <a:noFill/>
-                    </a:lnT>
-                    <a:lnB w="19050" cap="flat" cmpd="sng" algn="ctr">
-                      <a:solidFill>
-                        <a:srgbClr val="1F4E79"/>
-                      </a:solidFill>
-                      <a:prstDash val="solid"/>
-                      <a:round/>
-                      <a:headEnd type="none" w="med" len="med"/>
-                      <a:tailEnd type="none" w="med" len="med"/>
-                    </a:lnB>
-                  </a:tcPr>
-                </a:tc>
-              </a:tr>
-              <a:tr h="713232">
-                <a:tc>
-                  <a:txBody>
-                    <a:bodyPr/>
-                    <a:lstStyle/>
-                    <a:p>
-                      <a:pPr indent="0" marL="0">
-                        <a:buNone/>
-                      </a:pPr>
-                      <a:r>
-                        <a:rPr lang="en-US" sz="1400" b="1" dirty="0">
-                          <a:solidFill>
-                            <a:srgbClr val="1F4E79"/>
-                          </a:solidFill>
-                          <a:latin typeface="Yu Gothic" pitchFamily="34" charset="0"/>
-                          <a:ea typeface="Yu Gothic" pitchFamily="34" charset="-122"/>
-                          <a:cs typeface="Yu Gothic" pitchFamily="34" charset="-120"/>
-                        </a:rPr>
-                        <a:t>A. 分析（最初に回す）</a:t>
-                      </a:r>
-                      <a:endParaRPr lang="en-US" sz="1400" dirty="0">
-                        <a:latin typeface="Yu Gothic" charset="0"/>
-                        <a:ea typeface="Yu Gothic" charset="0"/>
-                        <a:cs typeface="Yu Gothic" charset="0"/>
-                      </a:endParaRPr>
-                    </a:p>
-                  </a:txBody>
-                  <a:tcPr marL="88900" marR="88900" marT="38100" marB="38100" anchor="ctr">
-                    <a:lnL w="0" cap="flat" cmpd="sng" algn="ctr">
-                      <a:noFill/>
-                    </a:lnL>
-                    <a:lnR w="0" cap="flat" cmpd="sng" algn="ctr">
-                      <a:noFill/>
-                    </a:lnR>
-                    <a:lnT w="0" cap="flat" cmpd="sng" algn="ctr">
-                      <a:noFill/>
-                    </a:lnT>
-                    <a:lnB w="9525" cap="flat" cmpd="sng" algn="ctr">
-                      <a:solidFill>
-                        <a:srgbClr val="CCCCCC"/>
-                      </a:solidFill>
-                      <a:prstDash val="solid"/>
-                      <a:round/>
-                      <a:headEnd type="none" w="med" len="med"/>
-                      <a:tailEnd type="none" w="med" len="med"/>
-                    </a:lnB>
-                  </a:tcPr>
-                </a:tc>
-                <a:tc>
-                  <a:txBody>
-                    <a:bodyPr/>
-                    <a:lstStyle/>
-                    <a:p>
-                      <a:pPr indent="0" marL="0">
-                        <a:buNone/>
-                      </a:pPr>
-                      <a:r>
-                        <a:rPr lang="en-US" sz="1400" dirty="0">
-                          <a:solidFill>
-                            <a:srgbClr val="2D2D2D"/>
-                          </a:solidFill>
-                          <a:latin typeface="Yu Gothic" pitchFamily="34" charset="0"/>
-                          <a:ea typeface="Yu Gothic" pitchFamily="34" charset="-122"/>
-                          <a:cs typeface="Yu Gothic" pitchFamily="34" charset="-120"/>
-                        </a:rPr>
-                        <a:t>自然な声に近いほど、どの認識器でも誤りが減る</a:t>
-                      </a:r>
-                      <a:endParaRPr lang="en-US" sz="1400" dirty="0">
-                        <a:latin typeface="Yu Gothic" charset="0"/>
-                        <a:ea typeface="Yu Gothic" charset="0"/>
-                        <a:cs typeface="Yu Gothic" charset="0"/>
-                      </a:endParaRPr>
-                    </a:p>
-                  </a:txBody>
-                  <a:tcPr marL="88900" marR="88900" marT="38100" marB="38100" anchor="ctr">
-                    <a:lnL w="0" cap="flat" cmpd="sng" algn="ctr">
-                      <a:noFill/>
-                    </a:lnL>
-                    <a:lnR w="0" cap="flat" cmpd="sng" algn="ctr">
-                      <a:noFill/>
-                    </a:lnR>
-                    <a:lnT w="0" cap="flat" cmpd="sng" algn="ctr">
-                      <a:noFill/>
-                    </a:lnT>
-                    <a:lnB w="9525" cap="flat" cmpd="sng" algn="ctr">
-                      <a:solidFill>
-                        <a:srgbClr val="CCCCCC"/>
-                      </a:solidFill>
-                      <a:prstDash val="solid"/>
-                      <a:round/>
-                      <a:headEnd type="none" w="med" len="med"/>
-                      <a:tailEnd type="none" w="med" len="med"/>
-                    </a:lnB>
-                  </a:tcPr>
-                </a:tc>
-                <a:tc>
-                  <a:txBody>
-                    <a:bodyPr/>
-                    <a:lstStyle/>
-                    <a:p>
-                      <a:pPr indent="0" marL="0">
-                        <a:buNone/>
-                      </a:pPr>
-                      <a:r>
-                        <a:rPr lang="en-US" sz="1400" dirty="0">
-                          <a:solidFill>
-                            <a:srgbClr val="2D2D2D"/>
-                          </a:solidFill>
-                          <a:latin typeface="Yu Gothic" pitchFamily="34" charset="0"/>
-                          <a:ea typeface="Yu Gothic" pitchFamily="34" charset="-122"/>
-                          <a:cs typeface="Yu Gothic" pitchFamily="34" charset="-120"/>
-                        </a:rPr>
-                        <a:t>既存の全出力で、自然な声との距離と9認識器の誤りの関係を見る</a:t>
-                      </a:r>
-                      <a:endParaRPr lang="en-US" sz="1400" dirty="0">
-                        <a:latin typeface="Yu Gothic" charset="0"/>
-                        <a:ea typeface="Yu Gothic" charset="0"/>
-                        <a:cs typeface="Yu Gothic" charset="0"/>
-                      </a:endParaRPr>
-                    </a:p>
-                  </a:txBody>
-                  <a:tcPr marL="88900" marR="88900" marT="38100" marB="38100" anchor="ctr">
-                    <a:lnL w="0" cap="flat" cmpd="sng" algn="ctr">
-                      <a:noFill/>
-                    </a:lnL>
-                    <a:lnR w="0" cap="flat" cmpd="sng" algn="ctr">
-                      <a:noFill/>
-                    </a:lnR>
-                    <a:lnT w="0" cap="flat" cmpd="sng" algn="ctr">
-                      <a:noFill/>
-                    </a:lnT>
-                    <a:lnB w="9525" cap="flat" cmpd="sng" algn="ctr">
-                      <a:solidFill>
-                        <a:srgbClr val="CCCCCC"/>
-                      </a:solidFill>
-                      <a:prstDash val="solid"/>
-                      <a:round/>
-                      <a:headEnd type="none" w="med" len="med"/>
-                      <a:tailEnd type="none" w="med" len="med"/>
-                    </a:lnB>
-                  </a:tcPr>
-                </a:tc>
-                <a:tc>
-                  <a:txBody>
-                    <a:bodyPr/>
-                    <a:lstStyle/>
-                    <a:p>
-                      <a:pPr indent="0" marL="0">
-                        <a:buNone/>
-                      </a:pPr>
-                      <a:r>
-                        <a:rPr lang="en-US" sz="1400" dirty="0">
-                          <a:solidFill>
-                            <a:srgbClr val="2D2D2D"/>
-                          </a:solidFill>
-                          <a:latin typeface="Yu Gothic" pitchFamily="34" charset="0"/>
-                          <a:ea typeface="Yu Gothic" pitchFamily="34" charset="-122"/>
-                          <a:cs typeface="Yu Gothic" pitchFamily="34" charset="-120"/>
-                        </a:rPr>
-                        <a:t>関係が明確なら柱に</a:t>
-                      </a:r>
-                      <a:endParaRPr lang="en-US" sz="1400" dirty="0">
-                        <a:latin typeface="Yu Gothic" charset="0"/>
-                        <a:ea typeface="Yu Gothic" charset="0"/>
-                        <a:cs typeface="Yu Gothic" charset="0"/>
-                      </a:endParaRPr>
-                    </a:p>
-                  </a:txBody>
-                  <a:tcPr marL="88900" marR="88900" marT="38100" marB="38100" anchor="ctr">
-                    <a:lnL w="0" cap="flat" cmpd="sng" algn="ctr">
-                      <a:noFill/>
-                    </a:lnL>
-                    <a:lnR w="0" cap="flat" cmpd="sng" algn="ctr">
-                      <a:noFill/>
-                    </a:lnR>
-                    <a:lnT w="0" cap="flat" cmpd="sng" algn="ctr">
-                      <a:noFill/>
-                    </a:lnT>
-                    <a:lnB w="9525" cap="flat" cmpd="sng" algn="ctr">
-                      <a:solidFill>
-                        <a:srgbClr val="CCCCCC"/>
-                      </a:solidFill>
-                      <a:prstDash val="solid"/>
-                      <a:round/>
-                      <a:headEnd type="none" w="med" len="med"/>
-                      <a:tailEnd type="none" w="med" len="med"/>
-                    </a:lnB>
-                  </a:tcPr>
-                </a:tc>
-              </a:tr>
-              <a:tr h="603504">
-                <a:tc>
-                  <a:txBody>
-                    <a:bodyPr/>
-                    <a:lstStyle/>
-                    <a:p>
-                      <a:pPr indent="0" marL="0">
-                        <a:buNone/>
-                      </a:pPr>
-                      <a:r>
-                        <a:rPr lang="en-US" sz="1400" b="1" dirty="0">
-                          <a:solidFill>
-                            <a:srgbClr val="2D2D2D"/>
-                          </a:solidFill>
-                          <a:latin typeface="Yu Gothic" pitchFamily="34" charset="0"/>
-                          <a:ea typeface="Yu Gothic" pitchFamily="34" charset="-122"/>
-                          <a:cs typeface="Yu Gothic" pitchFamily="34" charset="-120"/>
-                        </a:rPr>
-                        <a:t>B. 事前学習</a:t>
-                      </a:r>
-                      <a:endParaRPr lang="en-US" sz="1400" dirty="0">
-                        <a:latin typeface="Yu Gothic" charset="0"/>
-                        <a:ea typeface="Yu Gothic" charset="0"/>
-                        <a:cs typeface="Yu Gothic" charset="0"/>
-                      </a:endParaRPr>
-                    </a:p>
-                  </a:txBody>
-                  <a:tcPr marL="88900" marR="88900" marT="38100" marB="38100" anchor="ctr">
-                    <a:lnL w="0" cap="flat" cmpd="sng" algn="ctr">
-                      <a:noFill/>
-                    </a:lnL>
-                    <a:lnR w="0" cap="flat" cmpd="sng" algn="ctr">
-                      <a:noFill/>
-                    </a:lnR>
-                    <a:lnT w="0" cap="flat" cmpd="sng" algn="ctr">
-                      <a:noFill/>
-                    </a:lnT>
-                    <a:lnB w="9525" cap="flat" cmpd="sng" algn="ctr">
-                      <a:solidFill>
-                        <a:srgbClr val="CCCCCC"/>
-                      </a:solidFill>
-                      <a:prstDash val="solid"/>
-                      <a:round/>
-                      <a:headEnd type="none" w="med" len="med"/>
-                      <a:tailEnd type="none" w="med" len="med"/>
-                    </a:lnB>
-                  </a:tcPr>
-                </a:tc>
-                <a:tc>
-                  <a:txBody>
-                    <a:bodyPr/>
-                    <a:lstStyle/>
-                    <a:p>
-                      <a:pPr indent="0" marL="0">
-                        <a:buNone/>
-                      </a:pPr>
-                      <a:r>
-                        <a:rPr lang="en-US" sz="1400" dirty="0">
-                          <a:solidFill>
-                            <a:srgbClr val="2D2D2D"/>
-                          </a:solidFill>
-                          <a:latin typeface="Yu Gothic" pitchFamily="34" charset="0"/>
-                          <a:ea typeface="Yu Gothic" pitchFamily="34" charset="-122"/>
-                          <a:cs typeface="Yu Gothic" pitchFamily="34" charset="-120"/>
-                        </a:rPr>
-                        <a:t>効いているのは生成でなく、事前学習の知識</a:t>
-                      </a:r>
-                      <a:endParaRPr lang="en-US" sz="1400" dirty="0">
-                        <a:latin typeface="Yu Gothic" charset="0"/>
-                        <a:ea typeface="Yu Gothic" charset="0"/>
-                        <a:cs typeface="Yu Gothic" charset="0"/>
-                      </a:endParaRPr>
-                    </a:p>
-                  </a:txBody>
-                  <a:tcPr marL="88900" marR="88900" marT="38100" marB="38100" anchor="ctr">
-                    <a:lnL w="0" cap="flat" cmpd="sng" algn="ctr">
-                      <a:noFill/>
-                    </a:lnL>
-                    <a:lnR w="0" cap="flat" cmpd="sng" algn="ctr">
-                      <a:noFill/>
-                    </a:lnR>
-                    <a:lnT w="0" cap="flat" cmpd="sng" algn="ctr">
-                      <a:noFill/>
-                    </a:lnT>
-                    <a:lnB w="9525" cap="flat" cmpd="sng" algn="ctr">
-                      <a:solidFill>
-                        <a:srgbClr val="CCCCCC"/>
-                      </a:solidFill>
-                      <a:prstDash val="solid"/>
-                      <a:round/>
-                      <a:headEnd type="none" w="med" len="med"/>
-                      <a:tailEnd type="none" w="med" len="med"/>
-                    </a:lnB>
-                  </a:tcPr>
-                </a:tc>
-                <a:tc>
-                  <a:txBody>
-                    <a:bodyPr/>
-                    <a:lstStyle/>
-                    <a:p>
-                      <a:pPr indent="0" marL="0">
-                        <a:buNone/>
-                      </a:pPr>
-                      <a:r>
-                        <a:rPr lang="en-US" sz="1400" dirty="0">
-                          <a:solidFill>
-                            <a:srgbClr val="2D2D2D"/>
-                          </a:solidFill>
-                          <a:latin typeface="Yu Gothic" pitchFamily="34" charset="0"/>
-                          <a:ea typeface="Yu Gothic" pitchFamily="34" charset="-122"/>
-                          <a:cs typeface="Yu Gothic" pitchFamily="34" charset="-120"/>
-                        </a:rPr>
-                        <a:t>事前学習なしの対照／1段で出力する版</a:t>
-                      </a:r>
-                      <a:endParaRPr lang="en-US" sz="1400" dirty="0">
-                        <a:latin typeface="Yu Gothic" charset="0"/>
-                        <a:ea typeface="Yu Gothic" charset="0"/>
-                        <a:cs typeface="Yu Gothic" charset="0"/>
-                      </a:endParaRPr>
-                    </a:p>
-                  </a:txBody>
-                  <a:tcPr marL="88900" marR="88900" marT="38100" marB="38100" anchor="ctr">
-                    <a:lnL w="0" cap="flat" cmpd="sng" algn="ctr">
-                      <a:noFill/>
-                    </a:lnL>
-                    <a:lnR w="0" cap="flat" cmpd="sng" algn="ctr">
-                      <a:noFill/>
-                    </a:lnR>
-                    <a:lnT w="0" cap="flat" cmpd="sng" algn="ctr">
-                      <a:noFill/>
-                    </a:lnT>
-                    <a:lnB w="9525" cap="flat" cmpd="sng" algn="ctr">
-                      <a:solidFill>
-                        <a:srgbClr val="CCCCCC"/>
-                      </a:solidFill>
-                      <a:prstDash val="solid"/>
-                      <a:round/>
-                      <a:headEnd type="none" w="med" len="med"/>
-                      <a:tailEnd type="none" w="med" len="med"/>
-                    </a:lnB>
-                  </a:tcPr>
-                </a:tc>
-                <a:tc>
-                  <a:txBody>
-                    <a:bodyPr/>
-                    <a:lstStyle/>
-                    <a:p>
-                      <a:pPr indent="0" marL="0">
-                        <a:buNone/>
-                      </a:pPr>
-                      <a:r>
-                        <a:rPr lang="en-US" sz="1400" dirty="0">
-                          <a:solidFill>
-                            <a:srgbClr val="2D2D2D"/>
-                          </a:solidFill>
-                          <a:latin typeface="Yu Gothic" pitchFamily="34" charset="0"/>
-                          <a:ea typeface="Yu Gothic" pitchFamily="34" charset="-122"/>
-                          <a:cs typeface="Yu Gothic" pitchFamily="34" charset="-120"/>
-                        </a:rPr>
-                        <a:t>事前学習ありが大差</a:t>
-                      </a:r>
-                      <a:endParaRPr lang="en-US" sz="1400" dirty="0">
-                        <a:latin typeface="Yu Gothic" charset="0"/>
-                        <a:ea typeface="Yu Gothic" charset="0"/>
-                        <a:cs typeface="Yu Gothic" charset="0"/>
-                      </a:endParaRPr>
-                    </a:p>
-                  </a:txBody>
-                  <a:tcPr marL="88900" marR="88900" marT="38100" marB="38100" anchor="ctr">
-                    <a:lnL w="0" cap="flat" cmpd="sng" algn="ctr">
-                      <a:noFill/>
-                    </a:lnL>
-                    <a:lnR w="0" cap="flat" cmpd="sng" algn="ctr">
-                      <a:noFill/>
-                    </a:lnR>
-                    <a:lnT w="0" cap="flat" cmpd="sng" algn="ctr">
-                      <a:noFill/>
-                    </a:lnT>
-                    <a:lnB w="9525" cap="flat" cmpd="sng" algn="ctr">
-                      <a:solidFill>
-                        <a:srgbClr val="CCCCCC"/>
-                      </a:solidFill>
-                      <a:prstDash val="solid"/>
-                      <a:round/>
-                      <a:headEnd type="none" w="med" len="med"/>
-                      <a:tailEnd type="none" w="med" len="med"/>
-                    </a:lnB>
-                  </a:tcPr>
-                </a:tc>
-              </a:tr>
-              <a:tr h="603504">
-                <a:tc>
-                  <a:txBody>
-                    <a:bodyPr/>
-                    <a:lstStyle/>
-                    <a:p>
-                      <a:pPr indent="0" marL="0">
-                        <a:buNone/>
-                      </a:pPr>
-                      <a:r>
-                        <a:rPr lang="en-US" sz="1400" b="1" dirty="0">
-                          <a:solidFill>
-                            <a:srgbClr val="2D2D2D"/>
-                          </a:solidFill>
-                          <a:latin typeface="Yu Gothic" pitchFamily="34" charset="0"/>
-                          <a:ea typeface="Yu Gothic" pitchFamily="34" charset="-122"/>
-                          <a:cs typeface="Yu Gothic" pitchFamily="34" charset="-120"/>
-                        </a:rPr>
-                        <a:t>C. 生成のさせ方</a:t>
-                      </a:r>
-                      <a:endParaRPr lang="en-US" sz="1400" dirty="0">
-                        <a:latin typeface="Yu Gothic" charset="0"/>
-                        <a:ea typeface="Yu Gothic" charset="0"/>
-                        <a:cs typeface="Yu Gothic" charset="0"/>
-                      </a:endParaRPr>
-                    </a:p>
-                  </a:txBody>
-                  <a:tcPr marL="88900" marR="88900" marT="38100" marB="38100" anchor="ctr">
-                    <a:lnL w="0" cap="flat" cmpd="sng" algn="ctr">
-                      <a:noFill/>
-                    </a:lnL>
-                    <a:lnR w="0" cap="flat" cmpd="sng" algn="ctr">
-                      <a:noFill/>
-                    </a:lnR>
-                    <a:lnT w="0" cap="flat" cmpd="sng" algn="ctr">
-                      <a:noFill/>
-                    </a:lnT>
-                    <a:lnB w="9525" cap="flat" cmpd="sng" algn="ctr">
-                      <a:solidFill>
-                        <a:srgbClr val="CCCCCC"/>
-                      </a:solidFill>
-                      <a:prstDash val="solid"/>
-                      <a:round/>
-                      <a:headEnd type="none" w="med" len="med"/>
-                      <a:tailEnd type="none" w="med" len="med"/>
-                    </a:lnB>
-                  </a:tcPr>
-                </a:tc>
-                <a:tc>
-                  <a:txBody>
-                    <a:bodyPr/>
-                    <a:lstStyle/>
-                    <a:p>
-                      <a:pPr indent="0" marL="0">
-                        <a:buNone/>
-                      </a:pPr>
-                      <a:r>
-                        <a:rPr lang="en-US" sz="1400" dirty="0">
-                          <a:solidFill>
-                            <a:srgbClr val="2D2D2D"/>
-                          </a:solidFill>
-                          <a:latin typeface="Yu Gothic" pitchFamily="34" charset="0"/>
-                          <a:ea typeface="Yu Gothic" pitchFamily="34" charset="-122"/>
-                          <a:cs typeface="Yu Gothic" pitchFamily="34" charset="-120"/>
-                        </a:rPr>
-                        <a:t>生成のばらつきが誤りの原因</a:t>
-                      </a:r>
-                      <a:endParaRPr lang="en-US" sz="1400" dirty="0">
-                        <a:latin typeface="Yu Gothic" charset="0"/>
-                        <a:ea typeface="Yu Gothic" charset="0"/>
-                        <a:cs typeface="Yu Gothic" charset="0"/>
-                      </a:endParaRPr>
-                    </a:p>
-                  </a:txBody>
-                  <a:tcPr marL="88900" marR="88900" marT="38100" marB="38100" anchor="ctr">
-                    <a:lnL w="0" cap="flat" cmpd="sng" algn="ctr">
-                      <a:noFill/>
-                    </a:lnL>
-                    <a:lnR w="0" cap="flat" cmpd="sng" algn="ctr">
-                      <a:noFill/>
-                    </a:lnR>
-                    <a:lnT w="0" cap="flat" cmpd="sng" algn="ctr">
-                      <a:noFill/>
-                    </a:lnT>
-                    <a:lnB w="9525" cap="flat" cmpd="sng" algn="ctr">
-                      <a:solidFill>
-                        <a:srgbClr val="CCCCCC"/>
-                      </a:solidFill>
-                      <a:prstDash val="solid"/>
-                      <a:round/>
-                      <a:headEnd type="none" w="med" len="med"/>
-                      <a:tailEnd type="none" w="med" len="med"/>
-                    </a:lnB>
-                  </a:tcPr>
-                </a:tc>
-                <a:tc>
-                  <a:txBody>
-                    <a:bodyPr/>
-                    <a:lstStyle/>
-                    <a:p>
-                      <a:pPr indent="0" marL="0">
-                        <a:buNone/>
-                      </a:pPr>
-                      <a:r>
-                        <a:rPr lang="en-US" sz="1400" dirty="0">
-                          <a:solidFill>
-                            <a:srgbClr val="2D2D2D"/>
-                          </a:solidFill>
-                          <a:latin typeface="Yu Gothic" pitchFamily="34" charset="0"/>
-                          <a:ea typeface="Yu Gothic" pitchFamily="34" charset="-122"/>
-                          <a:cs typeface="Yu Gothic" pitchFamily="34" charset="-120"/>
-                        </a:rPr>
-                        <a:t>シード違いのばらつきと誤りの関係</a:t>
-                      </a:r>
-                      <a:endParaRPr lang="en-US" sz="1400" dirty="0">
-                        <a:latin typeface="Yu Gothic" charset="0"/>
-                        <a:ea typeface="Yu Gothic" charset="0"/>
-                        <a:cs typeface="Yu Gothic" charset="0"/>
-                      </a:endParaRPr>
-                    </a:p>
-                  </a:txBody>
-                  <a:tcPr marL="88900" marR="88900" marT="38100" marB="38100" anchor="ctr">
-                    <a:lnL w="0" cap="flat" cmpd="sng" algn="ctr">
-                      <a:noFill/>
-                    </a:lnL>
-                    <a:lnR w="0" cap="flat" cmpd="sng" algn="ctr">
-                      <a:noFill/>
-                    </a:lnR>
-                    <a:lnT w="0" cap="flat" cmpd="sng" algn="ctr">
-                      <a:noFill/>
-                    </a:lnT>
-                    <a:lnB w="9525" cap="flat" cmpd="sng" algn="ctr">
-                      <a:solidFill>
-                        <a:srgbClr val="CCCCCC"/>
-                      </a:solidFill>
-                      <a:prstDash val="solid"/>
-                      <a:round/>
-                      <a:headEnd type="none" w="med" len="med"/>
-                      <a:tailEnd type="none" w="med" len="med"/>
-                    </a:lnB>
-                  </a:tcPr>
-                </a:tc>
-                <a:tc>
-                  <a:txBody>
-                    <a:bodyPr/>
-                    <a:lstStyle/>
-                    <a:p>
-                      <a:pPr indent="0" marL="0">
-                        <a:buNone/>
-                      </a:pPr>
-                      <a:r>
-                        <a:rPr lang="en-US" sz="1400" dirty="0">
-                          <a:solidFill>
-                            <a:srgbClr val="2D2D2D"/>
-                          </a:solidFill>
-                          <a:latin typeface="Yu Gothic" pitchFamily="34" charset="0"/>
-                          <a:ea typeface="Yu Gothic" pitchFamily="34" charset="-122"/>
-                          <a:cs typeface="Yu Gothic" pitchFamily="34" charset="-120"/>
-                        </a:rPr>
-                        <a:t>両者が連動</a:t>
-                      </a:r>
-                      <a:endParaRPr lang="en-US" sz="1400" dirty="0">
-                        <a:latin typeface="Yu Gothic" charset="0"/>
-                        <a:ea typeface="Yu Gothic" charset="0"/>
-                        <a:cs typeface="Yu Gothic" charset="0"/>
-                      </a:endParaRPr>
-                    </a:p>
-                  </a:txBody>
-                  <a:tcPr marL="88900" marR="88900" marT="38100" marB="38100" anchor="ctr">
-                    <a:lnL w="0" cap="flat" cmpd="sng" algn="ctr">
-                      <a:noFill/>
-                    </a:lnL>
-                    <a:lnR w="0" cap="flat" cmpd="sng" algn="ctr">
-                      <a:noFill/>
-                    </a:lnR>
-                    <a:lnT w="0" cap="flat" cmpd="sng" algn="ctr">
-                      <a:noFill/>
-                    </a:lnT>
-                    <a:lnB w="9525" cap="flat" cmpd="sng" algn="ctr">
-                      <a:solidFill>
-                        <a:srgbClr val="CCCCCC"/>
-                      </a:solidFill>
-                      <a:prstDash val="solid"/>
-                      <a:round/>
-                      <a:headEnd type="none" w="med" len="med"/>
-                      <a:tailEnd type="none" w="med" len="med"/>
-                    </a:lnB>
-                  </a:tcPr>
-                </a:tc>
-              </a:tr>
-              <a:tr h="713232">
-                <a:tc>
-                  <a:txBody>
-                    <a:bodyPr/>
-                    <a:lstStyle/>
-                    <a:p>
-                      <a:pPr indent="0" marL="0">
-                        <a:buNone/>
-                      </a:pPr>
-                      <a:r>
-                        <a:rPr lang="en-US" sz="1400" b="1" dirty="0">
-                          <a:solidFill>
-                            <a:srgbClr val="2D2D2D"/>
-                          </a:solidFill>
-                          <a:latin typeface="Yu Gothic" pitchFamily="34" charset="0"/>
-                          <a:ea typeface="Yu Gothic" pitchFamily="34" charset="-122"/>
-                          <a:cs typeface="Yu Gothic" pitchFamily="34" charset="-120"/>
-                        </a:rPr>
-                        <a:t>D. 損失の設計</a:t>
-                      </a:r>
-                      <a:endParaRPr lang="en-US" sz="1400" dirty="0">
-                        <a:latin typeface="Yu Gothic" charset="0"/>
-                        <a:ea typeface="Yu Gothic" charset="0"/>
-                        <a:cs typeface="Yu Gothic" charset="0"/>
-                      </a:endParaRPr>
-                    </a:p>
-                  </a:txBody>
-                  <a:tcPr marL="88900" marR="88900" marT="38100" marB="38100" anchor="ctr">
-                    <a:lnL w="0" cap="flat" cmpd="sng" algn="ctr">
-                      <a:noFill/>
-                    </a:lnL>
-                    <a:lnR w="0" cap="flat" cmpd="sng" algn="ctr">
-                      <a:noFill/>
-                    </a:lnR>
-                    <a:lnT w="0" cap="flat" cmpd="sng" algn="ctr">
-                      <a:noFill/>
-                    </a:lnT>
-                    <a:lnB w="9525" cap="flat" cmpd="sng" algn="ctr">
-                      <a:solidFill>
-                        <a:srgbClr val="CCCCCC"/>
-                      </a:solidFill>
-                      <a:prstDash val="solid"/>
-                      <a:round/>
-                      <a:headEnd type="none" w="med" len="med"/>
-                      <a:tailEnd type="none" w="med" len="med"/>
-                    </a:lnB>
-                  </a:tcPr>
-                </a:tc>
-                <a:tc>
-                  <a:txBody>
-                    <a:bodyPr/>
-                    <a:lstStyle/>
-                    <a:p>
-                      <a:pPr indent="0" marL="0">
-                        <a:buNone/>
-                      </a:pPr>
-                      <a:r>
-                        <a:rPr lang="en-US" sz="1400" dirty="0">
-                          <a:solidFill>
-                            <a:srgbClr val="2D2D2D"/>
-                          </a:solidFill>
-                          <a:latin typeface="Yu Gothic" pitchFamily="34" charset="0"/>
-                          <a:ea typeface="Yu Gothic" pitchFamily="34" charset="-122"/>
-                          <a:cs typeface="Yu Gothic" pitchFamily="34" charset="-120"/>
-                        </a:rPr>
-                        <a:t>自然な声との距離を損失にすれば軽くても効く</a:t>
-                      </a:r>
-                      <a:endParaRPr lang="en-US" sz="1400" dirty="0">
-                        <a:latin typeface="Yu Gothic" charset="0"/>
-                        <a:ea typeface="Yu Gothic" charset="0"/>
-                        <a:cs typeface="Yu Gothic" charset="0"/>
-                      </a:endParaRPr>
-                    </a:p>
-                  </a:txBody>
-                  <a:tcPr marL="88900" marR="88900" marT="38100" marB="38100" anchor="ctr">
-                    <a:lnL w="0" cap="flat" cmpd="sng" algn="ctr">
-                      <a:noFill/>
-                    </a:lnL>
-                    <a:lnR w="0" cap="flat" cmpd="sng" algn="ctr">
-                      <a:noFill/>
-                    </a:lnR>
-                    <a:lnT w="0" cap="flat" cmpd="sng" algn="ctr">
-                      <a:noFill/>
-                    </a:lnT>
-                    <a:lnB w="9525" cap="flat" cmpd="sng" algn="ctr">
-                      <a:solidFill>
-                        <a:srgbClr val="CCCCCC"/>
-                      </a:solidFill>
-                      <a:prstDash val="solid"/>
-                      <a:round/>
-                      <a:headEnd type="none" w="med" len="med"/>
-                      <a:tailEnd type="none" w="med" len="med"/>
-                    </a:lnB>
-                  </a:tcPr>
-                </a:tc>
-                <a:tc>
-                  <a:txBody>
-                    <a:bodyPr/>
-                    <a:lstStyle/>
-                    <a:p>
-                      <a:pPr indent="0" marL="0">
-                        <a:buNone/>
-                      </a:pPr>
-                      <a:r>
-                        <a:rPr lang="en-US" sz="1400" dirty="0">
-                          <a:solidFill>
-                            <a:srgbClr val="2D2D2D"/>
-                          </a:solidFill>
-                          <a:latin typeface="Yu Gothic" pitchFamily="34" charset="0"/>
-                          <a:ea typeface="Yu Gothic" pitchFamily="34" charset="-122"/>
-                          <a:cs typeface="Yu Gothic" pitchFamily="34" charset="-120"/>
-                        </a:rPr>
-                        <a:t>SSL表現の損失などを9認識器で評価</a:t>
-                      </a:r>
-                      <a:endParaRPr lang="en-US" sz="1400" dirty="0">
-                        <a:latin typeface="Yu Gothic" charset="0"/>
-                        <a:ea typeface="Yu Gothic" charset="0"/>
-                        <a:cs typeface="Yu Gothic" charset="0"/>
-                      </a:endParaRPr>
-                    </a:p>
-                  </a:txBody>
-                  <a:tcPr marL="88900" marR="88900" marT="38100" marB="38100" anchor="ctr">
-                    <a:lnL w="0" cap="flat" cmpd="sng" algn="ctr">
-                      <a:noFill/>
-                    </a:lnL>
-                    <a:lnR w="0" cap="flat" cmpd="sng" algn="ctr">
-                      <a:noFill/>
-                    </a:lnR>
-                    <a:lnT w="0" cap="flat" cmpd="sng" algn="ctr">
-                      <a:noFill/>
-                    </a:lnT>
-                    <a:lnB w="9525" cap="flat" cmpd="sng" algn="ctr">
-                      <a:solidFill>
-                        <a:srgbClr val="CCCCCC"/>
-                      </a:solidFill>
-                      <a:prstDash val="solid"/>
-                      <a:round/>
-                      <a:headEnd type="none" w="med" len="med"/>
-                      <a:tailEnd type="none" w="med" len="med"/>
-                    </a:lnB>
-                  </a:tcPr>
-                </a:tc>
-                <a:tc>
-                  <a:txBody>
-                    <a:bodyPr/>
-                    <a:lstStyle/>
-                    <a:p>
-                      <a:pPr indent="0" marL="0">
-                        <a:buNone/>
-                      </a:pPr>
-                      <a:r>
-                        <a:rPr lang="en-US" sz="1400" dirty="0">
-                          <a:solidFill>
-                            <a:srgbClr val="2D2D2D"/>
-                          </a:solidFill>
-                          <a:latin typeface="Yu Gothic" pitchFamily="34" charset="0"/>
-                          <a:ea typeface="Yu Gothic" pitchFamily="34" charset="-122"/>
-                          <a:cs typeface="Yu Gothic" pitchFamily="34" charset="-120"/>
-                        </a:rPr>
-                        <a:t>生成モデルに近づく</a:t>
-                      </a:r>
-                      <a:endParaRPr lang="en-US" sz="1400" dirty="0">
-                        <a:latin typeface="Yu Gothic" charset="0"/>
-                        <a:ea typeface="Yu Gothic" charset="0"/>
-                        <a:cs typeface="Yu Gothic" charset="0"/>
-                      </a:endParaRPr>
-                    </a:p>
-                  </a:txBody>
-                  <a:tcPr marL="88900" marR="88900" marT="38100" marB="38100" anchor="ctr">
-                    <a:lnL w="0" cap="flat" cmpd="sng" algn="ctr">
-                      <a:noFill/>
-                    </a:lnL>
-                    <a:lnR w="0" cap="flat" cmpd="sng" algn="ctr">
-                      <a:noFill/>
-                    </a:lnR>
-                    <a:lnT w="0" cap="flat" cmpd="sng" algn="ctr">
-                      <a:noFill/>
-                    </a:lnT>
-                    <a:lnB w="9525" cap="flat" cmpd="sng" algn="ctr">
-                      <a:solidFill>
-                        <a:srgbClr val="CCCCCC"/>
-                      </a:solidFill>
-                      <a:prstDash val="solid"/>
-                      <a:round/>
-                      <a:headEnd type="none" w="med" len="med"/>
-                      <a:tailEnd type="none" w="med" len="med"/>
-                    </a:lnB>
-                  </a:tcPr>
-                </a:tc>
-              </a:tr>
-              <a:tr h="603504">
-                <a:tc>
-                  <a:txBody>
-                    <a:bodyPr/>
-                    <a:lstStyle/>
-                    <a:p>
-                      <a:pPr indent="0" marL="0">
-                        <a:buNone/>
-                      </a:pPr>
-                      <a:r>
-                        <a:rPr lang="en-US" sz="1400" b="1" dirty="0">
-                          <a:solidFill>
-                            <a:srgbClr val="2D2D2D"/>
-                          </a:solidFill>
-                          <a:latin typeface="Yu Gothic" pitchFamily="34" charset="0"/>
-                          <a:ea typeface="Yu Gothic" pitchFamily="34" charset="-122"/>
-                          <a:cs typeface="Yu Gothic" pitchFamily="34" charset="-120"/>
-                        </a:rPr>
-                        <a:t>E. 軽量化</a:t>
-                      </a:r>
-                      <a:endParaRPr lang="en-US" sz="1400" dirty="0">
-                        <a:latin typeface="Yu Gothic" charset="0"/>
-                        <a:ea typeface="Yu Gothic" charset="0"/>
-                        <a:cs typeface="Yu Gothic" charset="0"/>
-                      </a:endParaRPr>
-                    </a:p>
-                  </a:txBody>
-                  <a:tcPr marL="88900" marR="88900" marT="38100" marB="38100" anchor="ctr">
-                    <a:lnL w="0" cap="flat" cmpd="sng" algn="ctr">
-                      <a:noFill/>
-                    </a:lnL>
-                    <a:lnR w="0" cap="flat" cmpd="sng" algn="ctr">
-                      <a:noFill/>
-                    </a:lnR>
-                    <a:lnT w="0" cap="flat" cmpd="sng" algn="ctr">
-                      <a:noFill/>
-                    </a:lnT>
-                    <a:lnB w="9525" cap="flat" cmpd="sng" algn="ctr">
-                      <a:solidFill>
-                        <a:srgbClr val="CCCCCC"/>
-                      </a:solidFill>
-                      <a:prstDash val="solid"/>
-                      <a:round/>
-                      <a:headEnd type="none" w="med" len="med"/>
-                      <a:tailEnd type="none" w="med" len="med"/>
-                    </a:lnB>
-                  </a:tcPr>
-                </a:tc>
-                <a:tc>
-                  <a:txBody>
-                    <a:bodyPr/>
-                    <a:lstStyle/>
-                    <a:p>
-                      <a:pPr indent="0" marL="0">
-                        <a:buNone/>
-                      </a:pPr>
-                      <a:r>
-                        <a:rPr lang="en-US" sz="1400" dirty="0">
-                          <a:solidFill>
-                            <a:srgbClr val="2D2D2D"/>
-                          </a:solidFill>
-                          <a:latin typeface="Yu Gothic" pitchFamily="34" charset="0"/>
-                          <a:ea typeface="Yu Gothic" pitchFamily="34" charset="-122"/>
-                          <a:cs typeface="Yu Gothic" pitchFamily="34" charset="-120"/>
-                        </a:rPr>
-                        <a:t>良い出力を教師にして、軽いモデルへ移せる</a:t>
-                      </a:r>
-                      <a:endParaRPr lang="en-US" sz="1400" dirty="0">
-                        <a:latin typeface="Yu Gothic" charset="0"/>
-                        <a:ea typeface="Yu Gothic" charset="0"/>
-                        <a:cs typeface="Yu Gothic" charset="0"/>
-                      </a:endParaRPr>
-                    </a:p>
-                  </a:txBody>
-                  <a:tcPr marL="88900" marR="88900" marT="38100" marB="38100" anchor="ctr">
-                    <a:lnL w="0" cap="flat" cmpd="sng" algn="ctr">
-                      <a:noFill/>
-                    </a:lnL>
-                    <a:lnR w="0" cap="flat" cmpd="sng" algn="ctr">
-                      <a:noFill/>
-                    </a:lnR>
-                    <a:lnT w="0" cap="flat" cmpd="sng" algn="ctr">
-                      <a:noFill/>
-                    </a:lnT>
-                    <a:lnB w="9525" cap="flat" cmpd="sng" algn="ctr">
-                      <a:solidFill>
-                        <a:srgbClr val="CCCCCC"/>
-                      </a:solidFill>
-                      <a:prstDash val="solid"/>
-                      <a:round/>
-                      <a:headEnd type="none" w="med" len="med"/>
-                      <a:tailEnd type="none" w="med" len="med"/>
-                    </a:lnB>
-                  </a:tcPr>
-                </a:tc>
-                <a:tc>
-                  <a:txBody>
-                    <a:bodyPr/>
-                    <a:lstStyle/>
-                    <a:p>
-                      <a:pPr indent="0" marL="0">
-                        <a:buNone/>
-                      </a:pPr>
-                      <a:r>
-                        <a:rPr lang="en-US" sz="1400" dirty="0">
-                          <a:solidFill>
-                            <a:srgbClr val="2D2D2D"/>
-                          </a:solidFill>
-                          <a:latin typeface="Yu Gothic" pitchFamily="34" charset="0"/>
-                          <a:ea typeface="Yu Gothic" pitchFamily="34" charset="-122"/>
-                          <a:cs typeface="Yu Gothic" pitchFamily="34" charset="-120"/>
-                        </a:rPr>
-                        <a:t>未学習のデータで教師を作り、蒸留</a:t>
-                      </a:r>
-                      <a:endParaRPr lang="en-US" sz="1400" dirty="0">
-                        <a:latin typeface="Yu Gothic" charset="0"/>
-                        <a:ea typeface="Yu Gothic" charset="0"/>
-                        <a:cs typeface="Yu Gothic" charset="0"/>
-                      </a:endParaRPr>
-                    </a:p>
-                  </a:txBody>
-                  <a:tcPr marL="88900" marR="88900" marT="38100" marB="38100" anchor="ctr">
-                    <a:lnL w="0" cap="flat" cmpd="sng" algn="ctr">
-                      <a:noFill/>
-                    </a:lnL>
-                    <a:lnR w="0" cap="flat" cmpd="sng" algn="ctr">
-                      <a:noFill/>
-                    </a:lnR>
-                    <a:lnT w="0" cap="flat" cmpd="sng" algn="ctr">
-                      <a:noFill/>
-                    </a:lnT>
-                    <a:lnB w="9525" cap="flat" cmpd="sng" algn="ctr">
-                      <a:solidFill>
-                        <a:srgbClr val="CCCCCC"/>
-                      </a:solidFill>
-                      <a:prstDash val="solid"/>
-                      <a:round/>
-                      <a:headEnd type="none" w="med" len="med"/>
-                      <a:tailEnd type="none" w="med" len="med"/>
-                    </a:lnB>
-                  </a:tcPr>
-                </a:tc>
-                <a:tc>
-                  <a:txBody>
-                    <a:bodyPr/>
-                    <a:lstStyle/>
-                    <a:p>
-                      <a:pPr indent="0" marL="0">
-                        <a:buNone/>
-                      </a:pPr>
-                      <a:r>
-                        <a:rPr lang="en-US" sz="1400" dirty="0">
-                          <a:solidFill>
-                            <a:srgbClr val="2D2D2D"/>
-                          </a:solidFill>
-                          <a:latin typeface="Yu Gothic" pitchFamily="34" charset="0"/>
-                          <a:ea typeface="Yu Gothic" pitchFamily="34" charset="-122"/>
-                          <a:cs typeface="Yu Gothic" pitchFamily="34" charset="-120"/>
-                        </a:rPr>
-                        <a:t>効果の大半が残る</a:t>
-                      </a:r>
-                      <a:endParaRPr lang="en-US" sz="1400" dirty="0">
-                        <a:latin typeface="Yu Gothic" charset="0"/>
-                        <a:ea typeface="Yu Gothic" charset="0"/>
-                        <a:cs typeface="Yu Gothic" charset="0"/>
-                      </a:endParaRPr>
-                    </a:p>
-                  </a:txBody>
-                  <a:tcPr marL="88900" marR="88900" marT="38100" marB="38100" anchor="ctr">
-                    <a:lnL w="0" cap="flat" cmpd="sng" algn="ctr">
-                      <a:noFill/>
-                    </a:lnL>
-                    <a:lnR w="0" cap="flat" cmpd="sng" algn="ctr">
-                      <a:noFill/>
-                    </a:lnR>
-                    <a:lnT w="0" cap="flat" cmpd="sng" algn="ctr">
-                      <a:noFill/>
-                    </a:lnT>
-                    <a:lnB w="9525" cap="flat" cmpd="sng" algn="ctr">
-                      <a:solidFill>
-                        <a:srgbClr val="CCCCCC"/>
-                      </a:solidFill>
-                      <a:prstDash val="solid"/>
-                      <a:round/>
-                      <a:headEnd type="none" w="med" len="med"/>
-                      <a:tailEnd type="none" w="med" len="med"/>
-                    </a:lnB>
-                  </a:tcPr>
-                </a:tc>
-              </a:tr>
-            </a:tbl>
-          </a:graphicData>
-        </a:graphic>
-      </p:graphicFrame>
-      <p:sp>
-        <p:nvSpPr>
-          <p:cNvPr id="4" name="Text 1"/>
-          <p:cNvSpPr/>
-          <p:nvPr/>
-        </p:nvSpPr>
-        <p:spPr>
-          <a:xfrm>
-            <a:off x="548640" y="5486400"/>
-            <a:ext cx="11094415" cy="411480"/>
+      <p:sp>
+        <p:nvSpPr>
+          <p:cNvPr id="3" name="Text 1"/>
+          <p:cNvSpPr/>
+          <p:nvPr/>
+        </p:nvSpPr>
+        <p:spPr>
+          <a:xfrm>
+            <a:off x="731520" y="1417320"/>
+            <a:ext cx="2011680" cy="274320"/>
+          </a:xfrm>
+          <a:prstGeom prst="rect">
+            <a:avLst/>
+          </a:prstGeom>
+          <a:noFill/>
+          <a:ln/>
+        </p:spPr>
+        <p:txBody>
+          <a:bodyPr wrap="square" lIns="0" tIns="0" rIns="0" bIns="0" rtlCol="0" anchor="t"/>
+          <a:lstStyle/>
+          <a:p>
+            <a:pPr indent="0" marL="0">
+              <a:buNone/>
+            </a:pPr>
+            <a:r>
+              <a:rPr lang="en-US" sz="1300" b="1" dirty="0">
+                <a:solidFill>
+                  <a:srgbClr val="777777"/>
+                </a:solidFill>
+                <a:latin typeface="Yu Gothic" pitchFamily="34" charset="0"/>
+                <a:ea typeface="Yu Gothic" pitchFamily="34" charset="-122"/>
+                <a:cs typeface="Yu Gothic" pitchFamily="34" charset="-120"/>
+              </a:rPr>
+              <a:t>方向</a:t>
+            </a:r>
+            <a:endParaRPr lang="en-US" sz="1300" dirty="0"/>
+          </a:p>
+        </p:txBody>
+      </p:sp>
+      <p:sp>
+        <p:nvSpPr>
+          <p:cNvPr id="4" name="Text 2"/>
+          <p:cNvSpPr/>
+          <p:nvPr/>
+        </p:nvSpPr>
+        <p:spPr>
+          <a:xfrm>
+            <a:off x="2880360" y="1417320"/>
+            <a:ext cx="3108960" cy="274320"/>
+          </a:xfrm>
+          <a:prstGeom prst="rect">
+            <a:avLst/>
+          </a:prstGeom>
+          <a:noFill/>
+          <a:ln/>
+        </p:spPr>
+        <p:txBody>
+          <a:bodyPr wrap="square" lIns="0" tIns="0" rIns="0" bIns="0" rtlCol="0" anchor="t"/>
+          <a:lstStyle/>
+          <a:p>
+            <a:pPr indent="0" marL="0">
+              <a:buNone/>
+            </a:pPr>
+            <a:r>
+              <a:rPr lang="en-US" sz="1300" b="1" dirty="0">
+                <a:solidFill>
+                  <a:srgbClr val="777777"/>
+                </a:solidFill>
+                <a:latin typeface="Yu Gothic" pitchFamily="34" charset="0"/>
+                <a:ea typeface="Yu Gothic" pitchFamily="34" charset="-122"/>
+                <a:cs typeface="Yu Gothic" pitchFamily="34" charset="-120"/>
+              </a:rPr>
+              <a:t>確かめる仮説</a:t>
+            </a:r>
+            <a:endParaRPr lang="en-US" sz="1300" dirty="0"/>
+          </a:p>
+        </p:txBody>
+      </p:sp>
+      <p:sp>
+        <p:nvSpPr>
+          <p:cNvPr id="5" name="Text 3"/>
+          <p:cNvSpPr/>
+          <p:nvPr/>
+        </p:nvSpPr>
+        <p:spPr>
+          <a:xfrm>
+            <a:off x="6355080" y="1417320"/>
+            <a:ext cx="3017520" cy="274320"/>
+          </a:xfrm>
+          <a:prstGeom prst="rect">
+            <a:avLst/>
+          </a:prstGeom>
+          <a:noFill/>
+          <a:ln/>
+        </p:spPr>
+        <p:txBody>
+          <a:bodyPr wrap="square" lIns="0" tIns="0" rIns="0" bIns="0" rtlCol="0" anchor="t"/>
+          <a:lstStyle/>
+          <a:p>
+            <a:pPr indent="0" marL="0">
+              <a:buNone/>
+            </a:pPr>
+            <a:r>
+              <a:rPr lang="en-US" sz="1300" b="1" dirty="0">
+                <a:solidFill>
+                  <a:srgbClr val="777777"/>
+                </a:solidFill>
+                <a:latin typeface="Yu Gothic" pitchFamily="34" charset="0"/>
+                <a:ea typeface="Yu Gothic" pitchFamily="34" charset="-122"/>
+                <a:cs typeface="Yu Gothic" pitchFamily="34" charset="-120"/>
+              </a:rPr>
+              <a:t>最初の小さな実験</a:t>
+            </a:r>
+            <a:endParaRPr lang="en-US" sz="1300" dirty="0"/>
+          </a:p>
+        </p:txBody>
+      </p:sp>
+      <p:sp>
+        <p:nvSpPr>
+          <p:cNvPr id="6" name="Text 4"/>
+          <p:cNvSpPr/>
+          <p:nvPr/>
+        </p:nvSpPr>
+        <p:spPr>
+          <a:xfrm>
+            <a:off x="9738360" y="1417320"/>
+            <a:ext cx="1767535" cy="274320"/>
+          </a:xfrm>
+          <a:prstGeom prst="rect">
+            <a:avLst/>
+          </a:prstGeom>
+          <a:noFill/>
+          <a:ln/>
+        </p:spPr>
+        <p:txBody>
+          <a:bodyPr wrap="square" lIns="0" tIns="0" rIns="0" bIns="0" rtlCol="0" anchor="t"/>
+          <a:lstStyle/>
+          <a:p>
+            <a:pPr indent="0" marL="0">
+              <a:buNone/>
+            </a:pPr>
+            <a:r>
+              <a:rPr lang="en-US" sz="1300" b="1" dirty="0">
+                <a:solidFill>
+                  <a:srgbClr val="777777"/>
+                </a:solidFill>
+                <a:latin typeface="Yu Gothic" pitchFamily="34" charset="0"/>
+                <a:ea typeface="Yu Gothic" pitchFamily="34" charset="-122"/>
+                <a:cs typeface="Yu Gothic" pitchFamily="34" charset="-120"/>
+              </a:rPr>
+              <a:t>続ける条件</a:t>
+            </a:r>
+            <a:endParaRPr lang="en-US" sz="1300" dirty="0"/>
+          </a:p>
+        </p:txBody>
+      </p:sp>
+      <p:sp>
+        <p:nvSpPr>
+          <p:cNvPr id="7" name="Shape 5"/>
+          <p:cNvSpPr/>
+          <p:nvPr/>
+        </p:nvSpPr>
+        <p:spPr>
+          <a:xfrm>
+            <a:off x="548640" y="1737360"/>
+            <a:ext cx="11094415" cy="676656"/>
+          </a:xfrm>
+          <a:prstGeom prst="rect">
+            <a:avLst/>
+          </a:prstGeom>
+          <a:solidFill>
+            <a:srgbClr val="FFF2CC"/>
+          </a:solidFill>
+          <a:ln w="12700">
+            <a:solidFill>
+              <a:srgbClr val="E6C800"/>
+            </a:solidFill>
+            <a:prstDash val="solid"/>
+          </a:ln>
+        </p:spPr>
+      </p:sp>
+      <p:sp>
+        <p:nvSpPr>
+          <p:cNvPr id="8" name="Text 6"/>
+          <p:cNvSpPr/>
+          <p:nvPr/>
+        </p:nvSpPr>
+        <p:spPr>
+          <a:xfrm>
+            <a:off x="731520" y="1737360"/>
+            <a:ext cx="2011680" cy="676656"/>
+          </a:xfrm>
+          <a:prstGeom prst="rect">
+            <a:avLst/>
+          </a:prstGeom>
+          <a:noFill/>
+          <a:ln/>
+        </p:spPr>
+        <p:txBody>
+          <a:bodyPr wrap="square" lIns="0" tIns="0" rIns="0" bIns="0" rtlCol="0" anchor="ctr"/>
+          <a:lstStyle/>
+          <a:p>
+            <a:pPr indent="0" marL="0">
+              <a:buNone/>
+            </a:pPr>
+            <a:r>
+              <a:rPr lang="en-US" sz="1600" b="1" dirty="0">
+                <a:solidFill>
+                  <a:srgbClr val="1F4E79"/>
+                </a:solidFill>
+                <a:latin typeface="Yu Gothic" pitchFamily="34" charset="0"/>
+                <a:ea typeface="Yu Gothic" pitchFamily="34" charset="-122"/>
+                <a:cs typeface="Yu Gothic" pitchFamily="34" charset="-120"/>
+              </a:rPr>
+              <a:t>A. 分析</a:t>
+            </a:r>
+            <a:endParaRPr lang="en-US" sz="1600" dirty="0"/>
+          </a:p>
+          <a:p>
+            <a:pPr indent="0" marL="0">
+              <a:buNone/>
+            </a:pPr>
+            <a:r>
+              <a:rPr lang="en-US" sz="1200" b="1" dirty="0">
+                <a:solidFill>
+                  <a:srgbClr val="7A5200"/>
+                </a:solidFill>
+                <a:latin typeface="Yu Gothic" pitchFamily="34" charset="0"/>
+                <a:ea typeface="Yu Gothic" pitchFamily="34" charset="-122"/>
+                <a:cs typeface="Yu Gothic" pitchFamily="34" charset="-120"/>
+              </a:rPr>
+              <a:t>最初に回す</a:t>
+            </a:r>
+            <a:endParaRPr lang="en-US" sz="1600" dirty="0"/>
+          </a:p>
+        </p:txBody>
+      </p:sp>
+      <p:sp>
+        <p:nvSpPr>
+          <p:cNvPr id="9" name="Text 7"/>
+          <p:cNvSpPr/>
+          <p:nvPr/>
+        </p:nvSpPr>
+        <p:spPr>
+          <a:xfrm>
+            <a:off x="2880360" y="1737360"/>
+            <a:ext cx="3108960" cy="676656"/>
+          </a:xfrm>
+          <a:prstGeom prst="rect">
+            <a:avLst/>
+          </a:prstGeom>
+          <a:noFill/>
+          <a:ln/>
+        </p:spPr>
+        <p:txBody>
+          <a:bodyPr wrap="square" lIns="0" tIns="0" rIns="0" bIns="0" rtlCol="0" anchor="ctr"/>
+          <a:lstStyle/>
+          <a:p>
+            <a:pPr indent="0" marL="0">
+              <a:lnSpc>
+                <a:spcPct val="110000"/>
+              </a:lnSpc>
+              <a:buNone/>
+            </a:pPr>
+            <a:r>
+              <a:rPr lang="en-US" sz="1400" dirty="0">
+                <a:solidFill>
+                  <a:srgbClr val="2D2D2D"/>
+                </a:solidFill>
+                <a:latin typeface="Yu Gothic" pitchFamily="34" charset="0"/>
+                <a:ea typeface="Yu Gothic" pitchFamily="34" charset="-122"/>
+                <a:cs typeface="Yu Gothic" pitchFamily="34" charset="-120"/>
+              </a:rPr>
+              <a:t>自然な声に近いほど、どの認識器でも誤りが減る</a:t>
+            </a:r>
+            <a:endParaRPr lang="en-US" sz="1400" dirty="0"/>
+          </a:p>
+        </p:txBody>
+      </p:sp>
+      <p:sp>
+        <p:nvSpPr>
+          <p:cNvPr id="10" name="Text 8"/>
+          <p:cNvSpPr/>
+          <p:nvPr/>
+        </p:nvSpPr>
+        <p:spPr>
+          <a:xfrm>
+            <a:off x="6355080" y="1737360"/>
+            <a:ext cx="3017520" cy="676656"/>
+          </a:xfrm>
+          <a:prstGeom prst="rect">
+            <a:avLst/>
+          </a:prstGeom>
+          <a:noFill/>
+          <a:ln/>
+        </p:spPr>
+        <p:txBody>
+          <a:bodyPr wrap="square" lIns="0" tIns="0" rIns="0" bIns="0" rtlCol="0" anchor="ctr"/>
+          <a:lstStyle/>
+          <a:p>
+            <a:pPr indent="0" marL="0">
+              <a:lnSpc>
+                <a:spcPct val="110000"/>
+              </a:lnSpc>
+              <a:buNone/>
+            </a:pPr>
+            <a:r>
+              <a:rPr lang="en-US" sz="1400" dirty="0">
+                <a:solidFill>
+                  <a:srgbClr val="2D2D2D"/>
+                </a:solidFill>
+                <a:latin typeface="Yu Gothic" pitchFamily="34" charset="0"/>
+                <a:ea typeface="Yu Gothic" pitchFamily="34" charset="-122"/>
+                <a:cs typeface="Yu Gothic" pitchFamily="34" charset="-120"/>
+              </a:rPr>
+              <a:t>既存の全出力で、自然な声との距離と9認識器の誤りの関係を見る</a:t>
+            </a:r>
+            <a:endParaRPr lang="en-US" sz="1400" dirty="0"/>
+          </a:p>
+        </p:txBody>
+      </p:sp>
+      <p:sp>
+        <p:nvSpPr>
+          <p:cNvPr id="11" name="Text 9"/>
+          <p:cNvSpPr/>
+          <p:nvPr/>
+        </p:nvSpPr>
+        <p:spPr>
+          <a:xfrm>
+            <a:off x="9738360" y="1737360"/>
+            <a:ext cx="1767535" cy="676656"/>
+          </a:xfrm>
+          <a:prstGeom prst="rect">
+            <a:avLst/>
+          </a:prstGeom>
+          <a:noFill/>
+          <a:ln/>
+        </p:spPr>
+        <p:txBody>
+          <a:bodyPr wrap="square" lIns="0" tIns="0" rIns="0" bIns="0" rtlCol="0" anchor="ctr"/>
+          <a:lstStyle/>
+          <a:p>
+            <a:pPr indent="0" marL="0">
+              <a:lnSpc>
+                <a:spcPct val="110000"/>
+              </a:lnSpc>
+              <a:buNone/>
+            </a:pPr>
+            <a:r>
+              <a:rPr lang="en-US" sz="1400" dirty="0">
+                <a:solidFill>
+                  <a:srgbClr val="2D2D2D"/>
+                </a:solidFill>
+                <a:latin typeface="Yu Gothic" pitchFamily="34" charset="0"/>
+                <a:ea typeface="Yu Gothic" pitchFamily="34" charset="-122"/>
+                <a:cs typeface="Yu Gothic" pitchFamily="34" charset="-120"/>
+              </a:rPr>
+              <a:t>関係が明確なら柱に</a:t>
+            </a:r>
+            <a:endParaRPr lang="en-US" sz="1400" dirty="0"/>
+          </a:p>
+        </p:txBody>
+      </p:sp>
+      <p:sp>
+        <p:nvSpPr>
+          <p:cNvPr id="12" name="Text 10"/>
+          <p:cNvSpPr/>
+          <p:nvPr/>
+        </p:nvSpPr>
+        <p:spPr>
+          <a:xfrm>
+            <a:off x="6016752" y="1737360"/>
+            <a:ext cx="320040" cy="676656"/>
+          </a:xfrm>
+          <a:prstGeom prst="rect">
+            <a:avLst/>
+          </a:prstGeom>
+          <a:noFill/>
+          <a:ln/>
+        </p:spPr>
+        <p:txBody>
+          <a:bodyPr wrap="square" lIns="0" tIns="0" rIns="0" bIns="0" rtlCol="0" anchor="ctr"/>
+          <a:lstStyle/>
+          <a:p>
+            <a:pPr algn="ctr" indent="0" marL="0">
+              <a:buNone/>
+            </a:pPr>
+            <a:r>
+              <a:rPr lang="en-US" sz="2000" b="1" dirty="0">
+                <a:solidFill>
+                  <a:srgbClr val="8C8C8C"/>
+                </a:solidFill>
+                <a:latin typeface="Yu Gothic" pitchFamily="34" charset="0"/>
+                <a:ea typeface="Yu Gothic" pitchFamily="34" charset="-122"/>
+                <a:cs typeface="Yu Gothic" pitchFamily="34" charset="-120"/>
+              </a:rPr>
+              <a:t>→</a:t>
+            </a:r>
+            <a:endParaRPr lang="en-US" sz="2000" dirty="0"/>
+          </a:p>
+        </p:txBody>
+      </p:sp>
+      <p:sp>
+        <p:nvSpPr>
+          <p:cNvPr id="13" name="Text 11"/>
+          <p:cNvSpPr/>
+          <p:nvPr/>
+        </p:nvSpPr>
+        <p:spPr>
+          <a:xfrm>
+            <a:off x="9400032" y="1737360"/>
+            <a:ext cx="320040" cy="676656"/>
+          </a:xfrm>
+          <a:prstGeom prst="rect">
+            <a:avLst/>
+          </a:prstGeom>
+          <a:noFill/>
+          <a:ln/>
+        </p:spPr>
+        <p:txBody>
+          <a:bodyPr wrap="square" lIns="0" tIns="0" rIns="0" bIns="0" rtlCol="0" anchor="ctr"/>
+          <a:lstStyle/>
+          <a:p>
+            <a:pPr algn="ctr" indent="0" marL="0">
+              <a:buNone/>
+            </a:pPr>
+            <a:r>
+              <a:rPr lang="en-US" sz="2000" b="1" dirty="0">
+                <a:solidFill>
+                  <a:srgbClr val="8C8C8C"/>
+                </a:solidFill>
+                <a:latin typeface="Yu Gothic" pitchFamily="34" charset="0"/>
+                <a:ea typeface="Yu Gothic" pitchFamily="34" charset="-122"/>
+                <a:cs typeface="Yu Gothic" pitchFamily="34" charset="-120"/>
+              </a:rPr>
+              <a:t>→</a:t>
+            </a:r>
+            <a:endParaRPr lang="en-US" sz="2000" dirty="0"/>
+          </a:p>
+        </p:txBody>
+      </p:sp>
+      <p:sp>
+        <p:nvSpPr>
+          <p:cNvPr id="14" name="Shape 12"/>
+          <p:cNvSpPr/>
+          <p:nvPr/>
+        </p:nvSpPr>
+        <p:spPr>
+          <a:xfrm>
+            <a:off x="548640" y="2523744"/>
+            <a:ext cx="11094415" cy="676656"/>
+          </a:xfrm>
+          <a:prstGeom prst="rect">
+            <a:avLst/>
+          </a:prstGeom>
+          <a:solidFill>
+            <a:srgbClr val="F2F4F7"/>
+          </a:solidFill>
+          <a:ln w="12700">
+            <a:solidFill>
+              <a:srgbClr val="F2F4F7"/>
+            </a:solidFill>
+            <a:prstDash val="solid"/>
+          </a:ln>
+        </p:spPr>
+      </p:sp>
+      <p:sp>
+        <p:nvSpPr>
+          <p:cNvPr id="15" name="Text 13"/>
+          <p:cNvSpPr/>
+          <p:nvPr/>
+        </p:nvSpPr>
+        <p:spPr>
+          <a:xfrm>
+            <a:off x="731520" y="2523744"/>
+            <a:ext cx="2011680" cy="676656"/>
+          </a:xfrm>
+          <a:prstGeom prst="rect">
+            <a:avLst/>
+          </a:prstGeom>
+          <a:noFill/>
+          <a:ln/>
+        </p:spPr>
+        <p:txBody>
+          <a:bodyPr wrap="square" lIns="0" tIns="0" rIns="0" bIns="0" rtlCol="0" anchor="ctr"/>
+          <a:lstStyle/>
+          <a:p>
+            <a:pPr indent="0" marL="0">
+              <a:buNone/>
+            </a:pPr>
+            <a:r>
+              <a:rPr lang="en-US" sz="1600" b="1" dirty="0">
+                <a:solidFill>
+                  <a:srgbClr val="1F4E79"/>
+                </a:solidFill>
+                <a:latin typeface="Yu Gothic" pitchFamily="34" charset="0"/>
+                <a:ea typeface="Yu Gothic" pitchFamily="34" charset="-122"/>
+                <a:cs typeface="Yu Gothic" pitchFamily="34" charset="-120"/>
+              </a:rPr>
+              <a:t>B. 事前学習</a:t>
+            </a:r>
+            <a:endParaRPr lang="en-US" sz="1600" dirty="0"/>
+          </a:p>
+        </p:txBody>
+      </p:sp>
+      <p:sp>
+        <p:nvSpPr>
+          <p:cNvPr id="16" name="Text 14"/>
+          <p:cNvSpPr/>
+          <p:nvPr/>
+        </p:nvSpPr>
+        <p:spPr>
+          <a:xfrm>
+            <a:off x="2880360" y="2523744"/>
+            <a:ext cx="3108960" cy="676656"/>
+          </a:xfrm>
+          <a:prstGeom prst="rect">
+            <a:avLst/>
+          </a:prstGeom>
+          <a:noFill/>
+          <a:ln/>
+        </p:spPr>
+        <p:txBody>
+          <a:bodyPr wrap="square" lIns="0" tIns="0" rIns="0" bIns="0" rtlCol="0" anchor="ctr"/>
+          <a:lstStyle/>
+          <a:p>
+            <a:pPr indent="0" marL="0">
+              <a:lnSpc>
+                <a:spcPct val="110000"/>
+              </a:lnSpc>
+              <a:buNone/>
+            </a:pPr>
+            <a:r>
+              <a:rPr lang="en-US" sz="1400" dirty="0">
+                <a:solidFill>
+                  <a:srgbClr val="2D2D2D"/>
+                </a:solidFill>
+                <a:latin typeface="Yu Gothic" pitchFamily="34" charset="0"/>
+                <a:ea typeface="Yu Gothic" pitchFamily="34" charset="-122"/>
+                <a:cs typeface="Yu Gothic" pitchFamily="34" charset="-120"/>
+              </a:rPr>
+              <a:t>効いているのは生成でなく、事前学習の知識</a:t>
+            </a:r>
+            <a:endParaRPr lang="en-US" sz="1400" dirty="0"/>
+          </a:p>
+        </p:txBody>
+      </p:sp>
+      <p:sp>
+        <p:nvSpPr>
+          <p:cNvPr id="17" name="Text 15"/>
+          <p:cNvSpPr/>
+          <p:nvPr/>
+        </p:nvSpPr>
+        <p:spPr>
+          <a:xfrm>
+            <a:off x="6355080" y="2523744"/>
+            <a:ext cx="3017520" cy="676656"/>
+          </a:xfrm>
+          <a:prstGeom prst="rect">
+            <a:avLst/>
+          </a:prstGeom>
+          <a:noFill/>
+          <a:ln/>
+        </p:spPr>
+        <p:txBody>
+          <a:bodyPr wrap="square" lIns="0" tIns="0" rIns="0" bIns="0" rtlCol="0" anchor="ctr"/>
+          <a:lstStyle/>
+          <a:p>
+            <a:pPr indent="0" marL="0">
+              <a:lnSpc>
+                <a:spcPct val="110000"/>
+              </a:lnSpc>
+              <a:buNone/>
+            </a:pPr>
+            <a:r>
+              <a:rPr lang="en-US" sz="1400" dirty="0">
+                <a:solidFill>
+                  <a:srgbClr val="2D2D2D"/>
+                </a:solidFill>
+                <a:latin typeface="Yu Gothic" pitchFamily="34" charset="0"/>
+                <a:ea typeface="Yu Gothic" pitchFamily="34" charset="-122"/>
+                <a:cs typeface="Yu Gothic" pitchFamily="34" charset="-120"/>
+              </a:rPr>
+              <a:t>事前学習なしの対照・1段で出す版</a:t>
+            </a:r>
+            <a:endParaRPr lang="en-US" sz="1400" dirty="0"/>
+          </a:p>
+        </p:txBody>
+      </p:sp>
+      <p:sp>
+        <p:nvSpPr>
+          <p:cNvPr id="18" name="Text 16"/>
+          <p:cNvSpPr/>
+          <p:nvPr/>
+        </p:nvSpPr>
+        <p:spPr>
+          <a:xfrm>
+            <a:off x="9738360" y="2523744"/>
+            <a:ext cx="1767535" cy="676656"/>
+          </a:xfrm>
+          <a:prstGeom prst="rect">
+            <a:avLst/>
+          </a:prstGeom>
+          <a:noFill/>
+          <a:ln/>
+        </p:spPr>
+        <p:txBody>
+          <a:bodyPr wrap="square" lIns="0" tIns="0" rIns="0" bIns="0" rtlCol="0" anchor="ctr"/>
+          <a:lstStyle/>
+          <a:p>
+            <a:pPr indent="0" marL="0">
+              <a:lnSpc>
+                <a:spcPct val="110000"/>
+              </a:lnSpc>
+              <a:buNone/>
+            </a:pPr>
+            <a:r>
+              <a:rPr lang="en-US" sz="1400" dirty="0">
+                <a:solidFill>
+                  <a:srgbClr val="2D2D2D"/>
+                </a:solidFill>
+                <a:latin typeface="Yu Gothic" pitchFamily="34" charset="0"/>
+                <a:ea typeface="Yu Gothic" pitchFamily="34" charset="-122"/>
+                <a:cs typeface="Yu Gothic" pitchFamily="34" charset="-120"/>
+              </a:rPr>
+              <a:t>事前学習ありが大差</a:t>
+            </a:r>
+            <a:endParaRPr lang="en-US" sz="1400" dirty="0"/>
+          </a:p>
+        </p:txBody>
+      </p:sp>
+      <p:sp>
+        <p:nvSpPr>
+          <p:cNvPr id="19" name="Text 17"/>
+          <p:cNvSpPr/>
+          <p:nvPr/>
+        </p:nvSpPr>
+        <p:spPr>
+          <a:xfrm>
+            <a:off x="6016752" y="2523744"/>
+            <a:ext cx="320040" cy="676656"/>
+          </a:xfrm>
+          <a:prstGeom prst="rect">
+            <a:avLst/>
+          </a:prstGeom>
+          <a:noFill/>
+          <a:ln/>
+        </p:spPr>
+        <p:txBody>
+          <a:bodyPr wrap="square" lIns="0" tIns="0" rIns="0" bIns="0" rtlCol="0" anchor="ctr"/>
+          <a:lstStyle/>
+          <a:p>
+            <a:pPr algn="ctr" indent="0" marL="0">
+              <a:buNone/>
+            </a:pPr>
+            <a:r>
+              <a:rPr lang="en-US" sz="2000" b="1" dirty="0">
+                <a:solidFill>
+                  <a:srgbClr val="8C8C8C"/>
+                </a:solidFill>
+                <a:latin typeface="Yu Gothic" pitchFamily="34" charset="0"/>
+                <a:ea typeface="Yu Gothic" pitchFamily="34" charset="-122"/>
+                <a:cs typeface="Yu Gothic" pitchFamily="34" charset="-120"/>
+              </a:rPr>
+              <a:t>→</a:t>
+            </a:r>
+            <a:endParaRPr lang="en-US" sz="2000" dirty="0"/>
+          </a:p>
+        </p:txBody>
+      </p:sp>
+      <p:sp>
+        <p:nvSpPr>
+          <p:cNvPr id="20" name="Text 18"/>
+          <p:cNvSpPr/>
+          <p:nvPr/>
+        </p:nvSpPr>
+        <p:spPr>
+          <a:xfrm>
+            <a:off x="9400032" y="2523744"/>
+            <a:ext cx="320040" cy="676656"/>
+          </a:xfrm>
+          <a:prstGeom prst="rect">
+            <a:avLst/>
+          </a:prstGeom>
+          <a:noFill/>
+          <a:ln/>
+        </p:spPr>
+        <p:txBody>
+          <a:bodyPr wrap="square" lIns="0" tIns="0" rIns="0" bIns="0" rtlCol="0" anchor="ctr"/>
+          <a:lstStyle/>
+          <a:p>
+            <a:pPr algn="ctr" indent="0" marL="0">
+              <a:buNone/>
+            </a:pPr>
+            <a:r>
+              <a:rPr lang="en-US" sz="2000" b="1" dirty="0">
+                <a:solidFill>
+                  <a:srgbClr val="8C8C8C"/>
+                </a:solidFill>
+                <a:latin typeface="Yu Gothic" pitchFamily="34" charset="0"/>
+                <a:ea typeface="Yu Gothic" pitchFamily="34" charset="-122"/>
+                <a:cs typeface="Yu Gothic" pitchFamily="34" charset="-120"/>
+              </a:rPr>
+              <a:t>→</a:t>
+            </a:r>
+            <a:endParaRPr lang="en-US" sz="2000" dirty="0"/>
+          </a:p>
+        </p:txBody>
+      </p:sp>
+      <p:sp>
+        <p:nvSpPr>
+          <p:cNvPr id="21" name="Shape 19"/>
+          <p:cNvSpPr/>
+          <p:nvPr/>
+        </p:nvSpPr>
+        <p:spPr>
+          <a:xfrm>
+            <a:off x="548640" y="3310128"/>
+            <a:ext cx="11094415" cy="676656"/>
+          </a:xfrm>
+          <a:prstGeom prst="rect">
+            <a:avLst/>
+          </a:prstGeom>
+          <a:solidFill>
+            <a:srgbClr val="F2F4F7"/>
+          </a:solidFill>
+          <a:ln w="12700">
+            <a:solidFill>
+              <a:srgbClr val="F2F4F7"/>
+            </a:solidFill>
+            <a:prstDash val="solid"/>
+          </a:ln>
+        </p:spPr>
+      </p:sp>
+      <p:sp>
+        <p:nvSpPr>
+          <p:cNvPr id="22" name="Text 20"/>
+          <p:cNvSpPr/>
+          <p:nvPr/>
+        </p:nvSpPr>
+        <p:spPr>
+          <a:xfrm>
+            <a:off x="731520" y="3310128"/>
+            <a:ext cx="2011680" cy="676656"/>
+          </a:xfrm>
+          <a:prstGeom prst="rect">
+            <a:avLst/>
+          </a:prstGeom>
+          <a:noFill/>
+          <a:ln/>
+        </p:spPr>
+        <p:txBody>
+          <a:bodyPr wrap="square" lIns="0" tIns="0" rIns="0" bIns="0" rtlCol="0" anchor="ctr"/>
+          <a:lstStyle/>
+          <a:p>
+            <a:pPr indent="0" marL="0">
+              <a:buNone/>
+            </a:pPr>
+            <a:r>
+              <a:rPr lang="en-US" sz="1600" b="1" dirty="0">
+                <a:solidFill>
+                  <a:srgbClr val="1F4E79"/>
+                </a:solidFill>
+                <a:latin typeface="Yu Gothic" pitchFamily="34" charset="0"/>
+                <a:ea typeface="Yu Gothic" pitchFamily="34" charset="-122"/>
+                <a:cs typeface="Yu Gothic" pitchFamily="34" charset="-120"/>
+              </a:rPr>
+              <a:t>C. 生成のさせ方</a:t>
+            </a:r>
+            <a:endParaRPr lang="en-US" sz="1600" dirty="0"/>
+          </a:p>
+        </p:txBody>
+      </p:sp>
+      <p:sp>
+        <p:nvSpPr>
+          <p:cNvPr id="23" name="Text 21"/>
+          <p:cNvSpPr/>
+          <p:nvPr/>
+        </p:nvSpPr>
+        <p:spPr>
+          <a:xfrm>
+            <a:off x="2880360" y="3310128"/>
+            <a:ext cx="3108960" cy="676656"/>
+          </a:xfrm>
+          <a:prstGeom prst="rect">
+            <a:avLst/>
+          </a:prstGeom>
+          <a:noFill/>
+          <a:ln/>
+        </p:spPr>
+        <p:txBody>
+          <a:bodyPr wrap="square" lIns="0" tIns="0" rIns="0" bIns="0" rtlCol="0" anchor="ctr"/>
+          <a:lstStyle/>
+          <a:p>
+            <a:pPr indent="0" marL="0">
+              <a:lnSpc>
+                <a:spcPct val="110000"/>
+              </a:lnSpc>
+              <a:buNone/>
+            </a:pPr>
+            <a:r>
+              <a:rPr lang="en-US" sz="1400" dirty="0">
+                <a:solidFill>
+                  <a:srgbClr val="2D2D2D"/>
+                </a:solidFill>
+                <a:latin typeface="Yu Gothic" pitchFamily="34" charset="0"/>
+                <a:ea typeface="Yu Gothic" pitchFamily="34" charset="-122"/>
+                <a:cs typeface="Yu Gothic" pitchFamily="34" charset="-120"/>
+              </a:rPr>
+              <a:t>生成のばらつきが誤りの原因</a:t>
+            </a:r>
+            <a:endParaRPr lang="en-US" sz="1400" dirty="0"/>
+          </a:p>
+        </p:txBody>
+      </p:sp>
+      <p:sp>
+        <p:nvSpPr>
+          <p:cNvPr id="24" name="Text 22"/>
+          <p:cNvSpPr/>
+          <p:nvPr/>
+        </p:nvSpPr>
+        <p:spPr>
+          <a:xfrm>
+            <a:off x="6355080" y="3310128"/>
+            <a:ext cx="3017520" cy="676656"/>
+          </a:xfrm>
+          <a:prstGeom prst="rect">
+            <a:avLst/>
+          </a:prstGeom>
+          <a:noFill/>
+          <a:ln/>
+        </p:spPr>
+        <p:txBody>
+          <a:bodyPr wrap="square" lIns="0" tIns="0" rIns="0" bIns="0" rtlCol="0" anchor="ctr"/>
+          <a:lstStyle/>
+          <a:p>
+            <a:pPr indent="0" marL="0">
+              <a:lnSpc>
+                <a:spcPct val="110000"/>
+              </a:lnSpc>
+              <a:buNone/>
+            </a:pPr>
+            <a:r>
+              <a:rPr lang="en-US" sz="1400" dirty="0">
+                <a:solidFill>
+                  <a:srgbClr val="2D2D2D"/>
+                </a:solidFill>
+                <a:latin typeface="Yu Gothic" pitchFamily="34" charset="0"/>
+                <a:ea typeface="Yu Gothic" pitchFamily="34" charset="-122"/>
+                <a:cs typeface="Yu Gothic" pitchFamily="34" charset="-120"/>
+              </a:rPr>
+              <a:t>シード違いのばらつきと誤りの関係</a:t>
+            </a:r>
+            <a:endParaRPr lang="en-US" sz="1400" dirty="0"/>
+          </a:p>
+        </p:txBody>
+      </p:sp>
+      <p:sp>
+        <p:nvSpPr>
+          <p:cNvPr id="25" name="Text 23"/>
+          <p:cNvSpPr/>
+          <p:nvPr/>
+        </p:nvSpPr>
+        <p:spPr>
+          <a:xfrm>
+            <a:off x="9738360" y="3310128"/>
+            <a:ext cx="1767535" cy="676656"/>
+          </a:xfrm>
+          <a:prstGeom prst="rect">
+            <a:avLst/>
+          </a:prstGeom>
+          <a:noFill/>
+          <a:ln/>
+        </p:spPr>
+        <p:txBody>
+          <a:bodyPr wrap="square" lIns="0" tIns="0" rIns="0" bIns="0" rtlCol="0" anchor="ctr"/>
+          <a:lstStyle/>
+          <a:p>
+            <a:pPr indent="0" marL="0">
+              <a:lnSpc>
+                <a:spcPct val="110000"/>
+              </a:lnSpc>
+              <a:buNone/>
+            </a:pPr>
+            <a:r>
+              <a:rPr lang="en-US" sz="1400" dirty="0">
+                <a:solidFill>
+                  <a:srgbClr val="2D2D2D"/>
+                </a:solidFill>
+                <a:latin typeface="Yu Gothic" pitchFamily="34" charset="0"/>
+                <a:ea typeface="Yu Gothic" pitchFamily="34" charset="-122"/>
+                <a:cs typeface="Yu Gothic" pitchFamily="34" charset="-120"/>
+              </a:rPr>
+              <a:t>両者が連動</a:t>
+            </a:r>
+            <a:endParaRPr lang="en-US" sz="1400" dirty="0"/>
+          </a:p>
+        </p:txBody>
+      </p:sp>
+      <p:sp>
+        <p:nvSpPr>
+          <p:cNvPr id="26" name="Text 24"/>
+          <p:cNvSpPr/>
+          <p:nvPr/>
+        </p:nvSpPr>
+        <p:spPr>
+          <a:xfrm>
+            <a:off x="6016752" y="3310128"/>
+            <a:ext cx="320040" cy="676656"/>
+          </a:xfrm>
+          <a:prstGeom prst="rect">
+            <a:avLst/>
+          </a:prstGeom>
+          <a:noFill/>
+          <a:ln/>
+        </p:spPr>
+        <p:txBody>
+          <a:bodyPr wrap="square" lIns="0" tIns="0" rIns="0" bIns="0" rtlCol="0" anchor="ctr"/>
+          <a:lstStyle/>
+          <a:p>
+            <a:pPr algn="ctr" indent="0" marL="0">
+              <a:buNone/>
+            </a:pPr>
+            <a:r>
+              <a:rPr lang="en-US" sz="2000" b="1" dirty="0">
+                <a:solidFill>
+                  <a:srgbClr val="8C8C8C"/>
+                </a:solidFill>
+                <a:latin typeface="Yu Gothic" pitchFamily="34" charset="0"/>
+                <a:ea typeface="Yu Gothic" pitchFamily="34" charset="-122"/>
+                <a:cs typeface="Yu Gothic" pitchFamily="34" charset="-120"/>
+              </a:rPr>
+              <a:t>→</a:t>
+            </a:r>
+            <a:endParaRPr lang="en-US" sz="2000" dirty="0"/>
+          </a:p>
+        </p:txBody>
+      </p:sp>
+      <p:sp>
+        <p:nvSpPr>
+          <p:cNvPr id="27" name="Text 25"/>
+          <p:cNvSpPr/>
+          <p:nvPr/>
+        </p:nvSpPr>
+        <p:spPr>
+          <a:xfrm>
+            <a:off x="9400032" y="3310128"/>
+            <a:ext cx="320040" cy="676656"/>
+          </a:xfrm>
+          <a:prstGeom prst="rect">
+            <a:avLst/>
+          </a:prstGeom>
+          <a:noFill/>
+          <a:ln/>
+        </p:spPr>
+        <p:txBody>
+          <a:bodyPr wrap="square" lIns="0" tIns="0" rIns="0" bIns="0" rtlCol="0" anchor="ctr"/>
+          <a:lstStyle/>
+          <a:p>
+            <a:pPr algn="ctr" indent="0" marL="0">
+              <a:buNone/>
+            </a:pPr>
+            <a:r>
+              <a:rPr lang="en-US" sz="2000" b="1" dirty="0">
+                <a:solidFill>
+                  <a:srgbClr val="8C8C8C"/>
+                </a:solidFill>
+                <a:latin typeface="Yu Gothic" pitchFamily="34" charset="0"/>
+                <a:ea typeface="Yu Gothic" pitchFamily="34" charset="-122"/>
+                <a:cs typeface="Yu Gothic" pitchFamily="34" charset="-120"/>
+              </a:rPr>
+              <a:t>→</a:t>
+            </a:r>
+            <a:endParaRPr lang="en-US" sz="2000" dirty="0"/>
+          </a:p>
+        </p:txBody>
+      </p:sp>
+      <p:sp>
+        <p:nvSpPr>
+          <p:cNvPr id="28" name="Shape 26"/>
+          <p:cNvSpPr/>
+          <p:nvPr/>
+        </p:nvSpPr>
+        <p:spPr>
+          <a:xfrm>
+            <a:off x="548640" y="4096512"/>
+            <a:ext cx="11094415" cy="676656"/>
+          </a:xfrm>
+          <a:prstGeom prst="rect">
+            <a:avLst/>
+          </a:prstGeom>
+          <a:solidFill>
+            <a:srgbClr val="F2F4F7"/>
+          </a:solidFill>
+          <a:ln w="12700">
+            <a:solidFill>
+              <a:srgbClr val="F2F4F7"/>
+            </a:solidFill>
+            <a:prstDash val="solid"/>
+          </a:ln>
+        </p:spPr>
+      </p:sp>
+      <p:sp>
+        <p:nvSpPr>
+          <p:cNvPr id="29" name="Text 27"/>
+          <p:cNvSpPr/>
+          <p:nvPr/>
+        </p:nvSpPr>
+        <p:spPr>
+          <a:xfrm>
+            <a:off x="731520" y="4096512"/>
+            <a:ext cx="2011680" cy="676656"/>
+          </a:xfrm>
+          <a:prstGeom prst="rect">
+            <a:avLst/>
+          </a:prstGeom>
+          <a:noFill/>
+          <a:ln/>
+        </p:spPr>
+        <p:txBody>
+          <a:bodyPr wrap="square" lIns="0" tIns="0" rIns="0" bIns="0" rtlCol="0" anchor="ctr"/>
+          <a:lstStyle/>
+          <a:p>
+            <a:pPr indent="0" marL="0">
+              <a:buNone/>
+            </a:pPr>
+            <a:r>
+              <a:rPr lang="en-US" sz="1600" b="1" dirty="0">
+                <a:solidFill>
+                  <a:srgbClr val="1F4E79"/>
+                </a:solidFill>
+                <a:latin typeface="Yu Gothic" pitchFamily="34" charset="0"/>
+                <a:ea typeface="Yu Gothic" pitchFamily="34" charset="-122"/>
+                <a:cs typeface="Yu Gothic" pitchFamily="34" charset="-120"/>
+              </a:rPr>
+              <a:t>D. 損失の設計</a:t>
+            </a:r>
+            <a:endParaRPr lang="en-US" sz="1600" dirty="0"/>
+          </a:p>
+        </p:txBody>
+      </p:sp>
+      <p:sp>
+        <p:nvSpPr>
+          <p:cNvPr id="30" name="Text 28"/>
+          <p:cNvSpPr/>
+          <p:nvPr/>
+        </p:nvSpPr>
+        <p:spPr>
+          <a:xfrm>
+            <a:off x="2880360" y="4096512"/>
+            <a:ext cx="3108960" cy="676656"/>
+          </a:xfrm>
+          <a:prstGeom prst="rect">
+            <a:avLst/>
+          </a:prstGeom>
+          <a:noFill/>
+          <a:ln/>
+        </p:spPr>
+        <p:txBody>
+          <a:bodyPr wrap="square" lIns="0" tIns="0" rIns="0" bIns="0" rtlCol="0" anchor="ctr"/>
+          <a:lstStyle/>
+          <a:p>
+            <a:pPr indent="0" marL="0">
+              <a:lnSpc>
+                <a:spcPct val="110000"/>
+              </a:lnSpc>
+              <a:buNone/>
+            </a:pPr>
+            <a:r>
+              <a:rPr lang="en-US" sz="1400" dirty="0">
+                <a:solidFill>
+                  <a:srgbClr val="2D2D2D"/>
+                </a:solidFill>
+                <a:latin typeface="Yu Gothic" pitchFamily="34" charset="0"/>
+                <a:ea typeface="Yu Gothic" pitchFamily="34" charset="-122"/>
+                <a:cs typeface="Yu Gothic" pitchFamily="34" charset="-120"/>
+              </a:rPr>
+              <a:t>自然な声との距離を損失にすれば軽くても効く</a:t>
+            </a:r>
+            <a:endParaRPr lang="en-US" sz="1400" dirty="0"/>
+          </a:p>
+        </p:txBody>
+      </p:sp>
+      <p:sp>
+        <p:nvSpPr>
+          <p:cNvPr id="31" name="Text 29"/>
+          <p:cNvSpPr/>
+          <p:nvPr/>
+        </p:nvSpPr>
+        <p:spPr>
+          <a:xfrm>
+            <a:off x="6355080" y="4096512"/>
+            <a:ext cx="3017520" cy="676656"/>
+          </a:xfrm>
+          <a:prstGeom prst="rect">
+            <a:avLst/>
+          </a:prstGeom>
+          <a:noFill/>
+          <a:ln/>
+        </p:spPr>
+        <p:txBody>
+          <a:bodyPr wrap="square" lIns="0" tIns="0" rIns="0" bIns="0" rtlCol="0" anchor="ctr"/>
+          <a:lstStyle/>
+          <a:p>
+            <a:pPr indent="0" marL="0">
+              <a:lnSpc>
+                <a:spcPct val="110000"/>
+              </a:lnSpc>
+              <a:buNone/>
+            </a:pPr>
+            <a:r>
+              <a:rPr lang="en-US" sz="1400" dirty="0">
+                <a:solidFill>
+                  <a:srgbClr val="2D2D2D"/>
+                </a:solidFill>
+                <a:latin typeface="Yu Gothic" pitchFamily="34" charset="0"/>
+                <a:ea typeface="Yu Gothic" pitchFamily="34" charset="-122"/>
+                <a:cs typeface="Yu Gothic" pitchFamily="34" charset="-120"/>
+              </a:rPr>
+              <a:t>SSL表現の損失などを9認識器で評価</a:t>
+            </a:r>
+            <a:endParaRPr lang="en-US" sz="1400" dirty="0"/>
+          </a:p>
+        </p:txBody>
+      </p:sp>
+      <p:sp>
+        <p:nvSpPr>
+          <p:cNvPr id="32" name="Text 30"/>
+          <p:cNvSpPr/>
+          <p:nvPr/>
+        </p:nvSpPr>
+        <p:spPr>
+          <a:xfrm>
+            <a:off x="9738360" y="4096512"/>
+            <a:ext cx="1767535" cy="676656"/>
+          </a:xfrm>
+          <a:prstGeom prst="rect">
+            <a:avLst/>
+          </a:prstGeom>
+          <a:noFill/>
+          <a:ln/>
+        </p:spPr>
+        <p:txBody>
+          <a:bodyPr wrap="square" lIns="0" tIns="0" rIns="0" bIns="0" rtlCol="0" anchor="ctr"/>
+          <a:lstStyle/>
+          <a:p>
+            <a:pPr indent="0" marL="0">
+              <a:lnSpc>
+                <a:spcPct val="110000"/>
+              </a:lnSpc>
+              <a:buNone/>
+            </a:pPr>
+            <a:r>
+              <a:rPr lang="en-US" sz="1400" dirty="0">
+                <a:solidFill>
+                  <a:srgbClr val="2D2D2D"/>
+                </a:solidFill>
+                <a:latin typeface="Yu Gothic" pitchFamily="34" charset="0"/>
+                <a:ea typeface="Yu Gothic" pitchFamily="34" charset="-122"/>
+                <a:cs typeface="Yu Gothic" pitchFamily="34" charset="-120"/>
+              </a:rPr>
+              <a:t>生成モデルに近づく</a:t>
+            </a:r>
+            <a:endParaRPr lang="en-US" sz="1400" dirty="0"/>
+          </a:p>
+        </p:txBody>
+      </p:sp>
+      <p:sp>
+        <p:nvSpPr>
+          <p:cNvPr id="33" name="Text 31"/>
+          <p:cNvSpPr/>
+          <p:nvPr/>
+        </p:nvSpPr>
+        <p:spPr>
+          <a:xfrm>
+            <a:off x="6016752" y="4096512"/>
+            <a:ext cx="320040" cy="676656"/>
+          </a:xfrm>
+          <a:prstGeom prst="rect">
+            <a:avLst/>
+          </a:prstGeom>
+          <a:noFill/>
+          <a:ln/>
+        </p:spPr>
+        <p:txBody>
+          <a:bodyPr wrap="square" lIns="0" tIns="0" rIns="0" bIns="0" rtlCol="0" anchor="ctr"/>
+          <a:lstStyle/>
+          <a:p>
+            <a:pPr algn="ctr" indent="0" marL="0">
+              <a:buNone/>
+            </a:pPr>
+            <a:r>
+              <a:rPr lang="en-US" sz="2000" b="1" dirty="0">
+                <a:solidFill>
+                  <a:srgbClr val="8C8C8C"/>
+                </a:solidFill>
+                <a:latin typeface="Yu Gothic" pitchFamily="34" charset="0"/>
+                <a:ea typeface="Yu Gothic" pitchFamily="34" charset="-122"/>
+                <a:cs typeface="Yu Gothic" pitchFamily="34" charset="-120"/>
+              </a:rPr>
+              <a:t>→</a:t>
+            </a:r>
+            <a:endParaRPr lang="en-US" sz="2000" dirty="0"/>
+          </a:p>
+        </p:txBody>
+      </p:sp>
+      <p:sp>
+        <p:nvSpPr>
+          <p:cNvPr id="34" name="Text 32"/>
+          <p:cNvSpPr/>
+          <p:nvPr/>
+        </p:nvSpPr>
+        <p:spPr>
+          <a:xfrm>
+            <a:off x="9400032" y="4096512"/>
+            <a:ext cx="320040" cy="676656"/>
+          </a:xfrm>
+          <a:prstGeom prst="rect">
+            <a:avLst/>
+          </a:prstGeom>
+          <a:noFill/>
+          <a:ln/>
+        </p:spPr>
+        <p:txBody>
+          <a:bodyPr wrap="square" lIns="0" tIns="0" rIns="0" bIns="0" rtlCol="0" anchor="ctr"/>
+          <a:lstStyle/>
+          <a:p>
+            <a:pPr algn="ctr" indent="0" marL="0">
+              <a:buNone/>
+            </a:pPr>
+            <a:r>
+              <a:rPr lang="en-US" sz="2000" b="1" dirty="0">
+                <a:solidFill>
+                  <a:srgbClr val="8C8C8C"/>
+                </a:solidFill>
+                <a:latin typeface="Yu Gothic" pitchFamily="34" charset="0"/>
+                <a:ea typeface="Yu Gothic" pitchFamily="34" charset="-122"/>
+                <a:cs typeface="Yu Gothic" pitchFamily="34" charset="-120"/>
+              </a:rPr>
+              <a:t>→</a:t>
+            </a:r>
+            <a:endParaRPr lang="en-US" sz="2000" dirty="0"/>
+          </a:p>
+        </p:txBody>
+      </p:sp>
+      <p:sp>
+        <p:nvSpPr>
+          <p:cNvPr id="35" name="Shape 33"/>
+          <p:cNvSpPr/>
+          <p:nvPr/>
+        </p:nvSpPr>
+        <p:spPr>
+          <a:xfrm>
+            <a:off x="548640" y="4882896"/>
+            <a:ext cx="11094415" cy="676656"/>
+          </a:xfrm>
+          <a:prstGeom prst="rect">
+            <a:avLst/>
+          </a:prstGeom>
+          <a:solidFill>
+            <a:srgbClr val="F2F4F7"/>
+          </a:solidFill>
+          <a:ln w="12700">
+            <a:solidFill>
+              <a:srgbClr val="F2F4F7"/>
+            </a:solidFill>
+            <a:prstDash val="solid"/>
+          </a:ln>
+        </p:spPr>
+      </p:sp>
+      <p:sp>
+        <p:nvSpPr>
+          <p:cNvPr id="36" name="Text 34"/>
+          <p:cNvSpPr/>
+          <p:nvPr/>
+        </p:nvSpPr>
+        <p:spPr>
+          <a:xfrm>
+            <a:off x="731520" y="4882896"/>
+            <a:ext cx="2011680" cy="676656"/>
+          </a:xfrm>
+          <a:prstGeom prst="rect">
+            <a:avLst/>
+          </a:prstGeom>
+          <a:noFill/>
+          <a:ln/>
+        </p:spPr>
+        <p:txBody>
+          <a:bodyPr wrap="square" lIns="0" tIns="0" rIns="0" bIns="0" rtlCol="0" anchor="ctr"/>
+          <a:lstStyle/>
+          <a:p>
+            <a:pPr indent="0" marL="0">
+              <a:buNone/>
+            </a:pPr>
+            <a:r>
+              <a:rPr lang="en-US" sz="1600" b="1" dirty="0">
+                <a:solidFill>
+                  <a:srgbClr val="1F4E79"/>
+                </a:solidFill>
+                <a:latin typeface="Yu Gothic" pitchFamily="34" charset="0"/>
+                <a:ea typeface="Yu Gothic" pitchFamily="34" charset="-122"/>
+                <a:cs typeface="Yu Gothic" pitchFamily="34" charset="-120"/>
+              </a:rPr>
+              <a:t>E. 軽量化</a:t>
+            </a:r>
+            <a:endParaRPr lang="en-US" sz="1600" dirty="0"/>
+          </a:p>
+        </p:txBody>
+      </p:sp>
+      <p:sp>
+        <p:nvSpPr>
+          <p:cNvPr id="37" name="Text 35"/>
+          <p:cNvSpPr/>
+          <p:nvPr/>
+        </p:nvSpPr>
+        <p:spPr>
+          <a:xfrm>
+            <a:off x="2880360" y="4882896"/>
+            <a:ext cx="3108960" cy="676656"/>
+          </a:xfrm>
+          <a:prstGeom prst="rect">
+            <a:avLst/>
+          </a:prstGeom>
+          <a:noFill/>
+          <a:ln/>
+        </p:spPr>
+        <p:txBody>
+          <a:bodyPr wrap="square" lIns="0" tIns="0" rIns="0" bIns="0" rtlCol="0" anchor="ctr"/>
+          <a:lstStyle/>
+          <a:p>
+            <a:pPr indent="0" marL="0">
+              <a:lnSpc>
+                <a:spcPct val="110000"/>
+              </a:lnSpc>
+              <a:buNone/>
+            </a:pPr>
+            <a:r>
+              <a:rPr lang="en-US" sz="1400" dirty="0">
+                <a:solidFill>
+                  <a:srgbClr val="2D2D2D"/>
+                </a:solidFill>
+                <a:latin typeface="Yu Gothic" pitchFamily="34" charset="0"/>
+                <a:ea typeface="Yu Gothic" pitchFamily="34" charset="-122"/>
+                <a:cs typeface="Yu Gothic" pitchFamily="34" charset="-120"/>
+              </a:rPr>
+              <a:t>良い出力を教師にして、軽いモデルへ移せる</a:t>
+            </a:r>
+            <a:endParaRPr lang="en-US" sz="1400" dirty="0"/>
+          </a:p>
+        </p:txBody>
+      </p:sp>
+      <p:sp>
+        <p:nvSpPr>
+          <p:cNvPr id="38" name="Text 36"/>
+          <p:cNvSpPr/>
+          <p:nvPr/>
+        </p:nvSpPr>
+        <p:spPr>
+          <a:xfrm>
+            <a:off x="6355080" y="4882896"/>
+            <a:ext cx="3017520" cy="676656"/>
+          </a:xfrm>
+          <a:prstGeom prst="rect">
+            <a:avLst/>
+          </a:prstGeom>
+          <a:noFill/>
+          <a:ln/>
+        </p:spPr>
+        <p:txBody>
+          <a:bodyPr wrap="square" lIns="0" tIns="0" rIns="0" bIns="0" rtlCol="0" anchor="ctr"/>
+          <a:lstStyle/>
+          <a:p>
+            <a:pPr indent="0" marL="0">
+              <a:lnSpc>
+                <a:spcPct val="110000"/>
+              </a:lnSpc>
+              <a:buNone/>
+            </a:pPr>
+            <a:r>
+              <a:rPr lang="en-US" sz="1400" dirty="0">
+                <a:solidFill>
+                  <a:srgbClr val="2D2D2D"/>
+                </a:solidFill>
+                <a:latin typeface="Yu Gothic" pitchFamily="34" charset="0"/>
+                <a:ea typeface="Yu Gothic" pitchFamily="34" charset="-122"/>
+                <a:cs typeface="Yu Gothic" pitchFamily="34" charset="-120"/>
+              </a:rPr>
+              <a:t>未学習のデータで教師を作り、蒸留</a:t>
+            </a:r>
+            <a:endParaRPr lang="en-US" sz="1400" dirty="0"/>
+          </a:p>
+        </p:txBody>
+      </p:sp>
+      <p:sp>
+        <p:nvSpPr>
+          <p:cNvPr id="39" name="Text 37"/>
+          <p:cNvSpPr/>
+          <p:nvPr/>
+        </p:nvSpPr>
+        <p:spPr>
+          <a:xfrm>
+            <a:off x="9738360" y="4882896"/>
+            <a:ext cx="1767535" cy="676656"/>
+          </a:xfrm>
+          <a:prstGeom prst="rect">
+            <a:avLst/>
+          </a:prstGeom>
+          <a:noFill/>
+          <a:ln/>
+        </p:spPr>
+        <p:txBody>
+          <a:bodyPr wrap="square" lIns="0" tIns="0" rIns="0" bIns="0" rtlCol="0" anchor="ctr"/>
+          <a:lstStyle/>
+          <a:p>
+            <a:pPr indent="0" marL="0">
+              <a:lnSpc>
+                <a:spcPct val="110000"/>
+              </a:lnSpc>
+              <a:buNone/>
+            </a:pPr>
+            <a:r>
+              <a:rPr lang="en-US" sz="1400" dirty="0">
+                <a:solidFill>
+                  <a:srgbClr val="2D2D2D"/>
+                </a:solidFill>
+                <a:latin typeface="Yu Gothic" pitchFamily="34" charset="0"/>
+                <a:ea typeface="Yu Gothic" pitchFamily="34" charset="-122"/>
+                <a:cs typeface="Yu Gothic" pitchFamily="34" charset="-120"/>
+              </a:rPr>
+              <a:t>効果の大半が残る</a:t>
+            </a:r>
+            <a:endParaRPr lang="en-US" sz="1400" dirty="0"/>
+          </a:p>
+        </p:txBody>
+      </p:sp>
+      <p:sp>
+        <p:nvSpPr>
+          <p:cNvPr id="40" name="Text 38"/>
+          <p:cNvSpPr/>
+          <p:nvPr/>
+        </p:nvSpPr>
+        <p:spPr>
+          <a:xfrm>
+            <a:off x="6016752" y="4882896"/>
+            <a:ext cx="320040" cy="676656"/>
+          </a:xfrm>
+          <a:prstGeom prst="rect">
+            <a:avLst/>
+          </a:prstGeom>
+          <a:noFill/>
+          <a:ln/>
+        </p:spPr>
+        <p:txBody>
+          <a:bodyPr wrap="square" lIns="0" tIns="0" rIns="0" bIns="0" rtlCol="0" anchor="ctr"/>
+          <a:lstStyle/>
+          <a:p>
+            <a:pPr algn="ctr" indent="0" marL="0">
+              <a:buNone/>
+            </a:pPr>
+            <a:r>
+              <a:rPr lang="en-US" sz="2000" b="1" dirty="0">
+                <a:solidFill>
+                  <a:srgbClr val="8C8C8C"/>
+                </a:solidFill>
+                <a:latin typeface="Yu Gothic" pitchFamily="34" charset="0"/>
+                <a:ea typeface="Yu Gothic" pitchFamily="34" charset="-122"/>
+                <a:cs typeface="Yu Gothic" pitchFamily="34" charset="-120"/>
+              </a:rPr>
+              <a:t>→</a:t>
+            </a:r>
+            <a:endParaRPr lang="en-US" sz="2000" dirty="0"/>
+          </a:p>
+        </p:txBody>
+      </p:sp>
+      <p:sp>
+        <p:nvSpPr>
+          <p:cNvPr id="41" name="Text 39"/>
+          <p:cNvSpPr/>
+          <p:nvPr/>
+        </p:nvSpPr>
+        <p:spPr>
+          <a:xfrm>
+            <a:off x="9400032" y="4882896"/>
+            <a:ext cx="320040" cy="676656"/>
+          </a:xfrm>
+          <a:prstGeom prst="rect">
+            <a:avLst/>
+          </a:prstGeom>
+          <a:noFill/>
+          <a:ln/>
+        </p:spPr>
+        <p:txBody>
+          <a:bodyPr wrap="square" lIns="0" tIns="0" rIns="0" bIns="0" rtlCol="0" anchor="ctr"/>
+          <a:lstStyle/>
+          <a:p>
+            <a:pPr algn="ctr" indent="0" marL="0">
+              <a:buNone/>
+            </a:pPr>
+            <a:r>
+              <a:rPr lang="en-US" sz="2000" b="1" dirty="0">
+                <a:solidFill>
+                  <a:srgbClr val="8C8C8C"/>
+                </a:solidFill>
+                <a:latin typeface="Yu Gothic" pitchFamily="34" charset="0"/>
+                <a:ea typeface="Yu Gothic" pitchFamily="34" charset="-122"/>
+                <a:cs typeface="Yu Gothic" pitchFamily="34" charset="-120"/>
+              </a:rPr>
+              <a:t>→</a:t>
+            </a:r>
+            <a:endParaRPr lang="en-US" sz="2000" dirty="0"/>
+          </a:p>
+        </p:txBody>
+      </p:sp>
+      <p:sp>
+        <p:nvSpPr>
+          <p:cNvPr id="42" name="Text 40"/>
+          <p:cNvSpPr/>
+          <p:nvPr/>
+        </p:nvSpPr>
+        <p:spPr>
+          <a:xfrm>
+            <a:off x="548640" y="5788152"/>
+            <a:ext cx="11094415" cy="320040"/>
           </a:xfrm>
           <a:prstGeom prst="rect">
             <a:avLst/>
@@ -11213,7 +11554,7 @@
       </p:sp>
       <p:sp>
         <p:nvSpPr>
-          <p:cNvPr id="5" name="Text 2"/>
+          <p:cNvPr id="43" name="Text 41"/>
           <p:cNvSpPr/>
           <p:nvPr/>
         </p:nvSpPr>
@@ -11244,7 +11585,7 @@
                 <a:ea typeface="Yu Gothic" pitchFamily="34" charset="-122"/>
                 <a:cs typeface="Yu Gothic" pitchFamily="34" charset="-120"/>
               </a:rPr>
-              <a:t>確認はいつも同じ条件: 入力の違う認識器を含む9つ、話者単位の検定、悪化する認識器がないか</a:t>
+              <a:t>確認はいつも同じ条件: 入力の違う認識器を含む9つ・話者単位の検定・悪化する認識器がないか</a:t>
             </a:r>
             <a:endParaRPr lang="en-US" sz="1200" dirty="0"/>
           </a:p>

</xml_diff>